<commit_message>
Continuing work on Wärmeübertragung & Wärmestrahlung
</commit_message>
<xml_diff>
--- a/B.Sc. LRT/Wärmeübertragung & -Strahlung/images/WÜS-Images.pptx
+++ b/B.Sc. LRT/Wärmeübertragung & -Strahlung/images/WÜS-Images.pptx
@@ -5,10 +5,13 @@
     <p:sldMasterId id="2147483660" r:id="rId1"/>
   </p:sldMasterIdLst>
   <p:notesMasterIdLst>
-    <p:notesMasterId r:id="rId3"/>
+    <p:notesMasterId r:id="rId6"/>
   </p:notesMasterIdLst>
   <p:sldIdLst>
     <p:sldId id="256" r:id="rId2"/>
+    <p:sldId id="257" r:id="rId3"/>
+    <p:sldId id="258" r:id="rId4"/>
+    <p:sldId id="259" r:id="rId5"/>
   </p:sldIdLst>
   <p:sldSz cx="3600450" cy="3600450"/>
   <p:notesSz cx="6858000" cy="9144000"/>
@@ -197,7 +200,7 @@
           <a:p>
             <a:fld id="{0C596C2D-C72C-406E-B79E-9BAC142DD20E}" type="datetimeFigureOut">
               <a:rPr lang="de-DE" smtClean="0"/>
-              <a:t>08.03.2026</a:t>
+              <a:t>16.03.2026</a:t>
             </a:fld>
             <a:endParaRPr lang="de-DE"/>
           </a:p>
@@ -595,7 +598,7 @@
           <a:p>
             <a:fld id="{6EAE28AA-0912-4DA0-8B30-7F3CA3FE6671}" type="datetimeFigureOut">
               <a:rPr lang="de-DE" smtClean="0"/>
-              <a:t>08.03.2026</a:t>
+              <a:t>16.03.2026</a:t>
             </a:fld>
             <a:endParaRPr lang="de-DE"/>
           </a:p>
@@ -765,7 +768,7 @@
           <a:p>
             <a:fld id="{6EAE28AA-0912-4DA0-8B30-7F3CA3FE6671}" type="datetimeFigureOut">
               <a:rPr lang="de-DE" smtClean="0"/>
-              <a:t>08.03.2026</a:t>
+              <a:t>16.03.2026</a:t>
             </a:fld>
             <a:endParaRPr lang="de-DE"/>
           </a:p>
@@ -945,7 +948,7 @@
           <a:p>
             <a:fld id="{6EAE28AA-0912-4DA0-8B30-7F3CA3FE6671}" type="datetimeFigureOut">
               <a:rPr lang="de-DE" smtClean="0"/>
-              <a:t>08.03.2026</a:t>
+              <a:t>16.03.2026</a:t>
             </a:fld>
             <a:endParaRPr lang="de-DE"/>
           </a:p>
@@ -1115,7 +1118,7 @@
           <a:p>
             <a:fld id="{6EAE28AA-0912-4DA0-8B30-7F3CA3FE6671}" type="datetimeFigureOut">
               <a:rPr lang="de-DE" smtClean="0"/>
-              <a:t>08.03.2026</a:t>
+              <a:t>16.03.2026</a:t>
             </a:fld>
             <a:endParaRPr lang="de-DE"/>
           </a:p>
@@ -1361,7 +1364,7 @@
           <a:p>
             <a:fld id="{6EAE28AA-0912-4DA0-8B30-7F3CA3FE6671}" type="datetimeFigureOut">
               <a:rPr lang="de-DE" smtClean="0"/>
-              <a:t>08.03.2026</a:t>
+              <a:t>16.03.2026</a:t>
             </a:fld>
             <a:endParaRPr lang="de-DE"/>
           </a:p>
@@ -1593,7 +1596,7 @@
           <a:p>
             <a:fld id="{6EAE28AA-0912-4DA0-8B30-7F3CA3FE6671}" type="datetimeFigureOut">
               <a:rPr lang="de-DE" smtClean="0"/>
-              <a:t>08.03.2026</a:t>
+              <a:t>16.03.2026</a:t>
             </a:fld>
             <a:endParaRPr lang="de-DE"/>
           </a:p>
@@ -1960,7 +1963,7 @@
           <a:p>
             <a:fld id="{6EAE28AA-0912-4DA0-8B30-7F3CA3FE6671}" type="datetimeFigureOut">
               <a:rPr lang="de-DE" smtClean="0"/>
-              <a:t>08.03.2026</a:t>
+              <a:t>16.03.2026</a:t>
             </a:fld>
             <a:endParaRPr lang="de-DE"/>
           </a:p>
@@ -2078,7 +2081,7 @@
           <a:p>
             <a:fld id="{6EAE28AA-0912-4DA0-8B30-7F3CA3FE6671}" type="datetimeFigureOut">
               <a:rPr lang="de-DE" smtClean="0"/>
-              <a:t>08.03.2026</a:t>
+              <a:t>16.03.2026</a:t>
             </a:fld>
             <a:endParaRPr lang="de-DE"/>
           </a:p>
@@ -2173,7 +2176,7 @@
           <a:p>
             <a:fld id="{6EAE28AA-0912-4DA0-8B30-7F3CA3FE6671}" type="datetimeFigureOut">
               <a:rPr lang="de-DE" smtClean="0"/>
-              <a:t>08.03.2026</a:t>
+              <a:t>16.03.2026</a:t>
             </a:fld>
             <a:endParaRPr lang="de-DE"/>
           </a:p>
@@ -2450,7 +2453,7 @@
           <a:p>
             <a:fld id="{6EAE28AA-0912-4DA0-8B30-7F3CA3FE6671}" type="datetimeFigureOut">
               <a:rPr lang="de-DE" smtClean="0"/>
-              <a:t>08.03.2026</a:t>
+              <a:t>16.03.2026</a:t>
             </a:fld>
             <a:endParaRPr lang="de-DE"/>
           </a:p>
@@ -2707,7 +2710,7 @@
           <a:p>
             <a:fld id="{6EAE28AA-0912-4DA0-8B30-7F3CA3FE6671}" type="datetimeFigureOut">
               <a:rPr lang="de-DE" smtClean="0"/>
-              <a:t>08.03.2026</a:t>
+              <a:t>16.03.2026</a:t>
             </a:fld>
             <a:endParaRPr lang="de-DE"/>
           </a:p>
@@ -2920,7 +2923,7 @@
           <a:p>
             <a:fld id="{6EAE28AA-0912-4DA0-8B30-7F3CA3FE6671}" type="datetimeFigureOut">
               <a:rPr lang="de-DE" smtClean="0"/>
-              <a:t>08.03.2026</a:t>
+              <a:t>16.03.2026</a:t>
             </a:fld>
             <a:endParaRPr lang="de-DE"/>
           </a:p>
@@ -4601,6 +4604,4806 @@
     <p:extLst>
       <p:ext uri="{BB962C8B-B14F-4D97-AF65-F5344CB8AC3E}">
         <p14:creationId xmlns:p14="http://schemas.microsoft.com/office/powerpoint/2010/main" val="2559367353"/>
+      </p:ext>
+    </p:extLst>
+  </p:cSld>
+  <p:clrMapOvr>
+    <a:masterClrMapping/>
+  </p:clrMapOvr>
+</p:sld>
+</file>
+
+<file path=ppt/slides/slide2.xml><?xml version="1.0" encoding="utf-8"?>
+<p:sld xmlns:a="http://schemas.openxmlformats.org/drawingml/2006/main" xmlns:r="http://schemas.openxmlformats.org/officeDocument/2006/relationships" xmlns:p="http://schemas.openxmlformats.org/presentationml/2006/main">
+  <p:cSld>
+    <p:spTree>
+      <p:nvGrpSpPr>
+        <p:cNvPr id="1" name=""/>
+        <p:cNvGrpSpPr/>
+        <p:nvPr/>
+      </p:nvGrpSpPr>
+      <p:grpSpPr>
+        <a:xfrm>
+          <a:off x="0" y="0"/>
+          <a:ext cx="0" cy="0"/>
+          <a:chOff x="0" y="0"/>
+          <a:chExt cx="0" cy="0"/>
+        </a:xfrm>
+      </p:grpSpPr>
+      <p:cxnSp>
+        <p:nvCxnSpPr>
+          <p:cNvPr id="9" name="Gerader Verbinder 8">
+            <a:extLst>
+              <a:ext uri="{FF2B5EF4-FFF2-40B4-BE49-F238E27FC236}">
+                <a16:creationId xmlns:a16="http://schemas.microsoft.com/office/drawing/2014/main" id="{01778097-3B51-0075-CE3F-68730958E662}"/>
+              </a:ext>
+            </a:extLst>
+          </p:cNvPr>
+          <p:cNvCxnSpPr>
+            <a:cxnSpLocks/>
+          </p:cNvCxnSpPr>
+          <p:nvPr/>
+        </p:nvCxnSpPr>
+        <p:spPr>
+          <a:xfrm flipH="1">
+            <a:off x="2783517" y="675007"/>
+            <a:ext cx="195694" cy="164927"/>
+          </a:xfrm>
+          <a:prstGeom prst="line">
+            <a:avLst/>
+          </a:prstGeom>
+          <a:ln w="12700" cap="rnd">
+            <a:solidFill>
+              <a:schemeClr val="tx1"/>
+            </a:solidFill>
+            <a:round/>
+          </a:ln>
+        </p:spPr>
+        <p:style>
+          <a:lnRef idx="2">
+            <a:schemeClr val="accent1"/>
+          </a:lnRef>
+          <a:fillRef idx="0">
+            <a:schemeClr val="accent1"/>
+          </a:fillRef>
+          <a:effectRef idx="1">
+            <a:schemeClr val="accent1"/>
+          </a:effectRef>
+          <a:fontRef idx="minor">
+            <a:schemeClr val="tx1"/>
+          </a:fontRef>
+        </p:style>
+      </p:cxnSp>
+      <p:cxnSp>
+        <p:nvCxnSpPr>
+          <p:cNvPr id="11" name="Gerader Verbinder 10">
+            <a:extLst>
+              <a:ext uri="{FF2B5EF4-FFF2-40B4-BE49-F238E27FC236}">
+                <a16:creationId xmlns:a16="http://schemas.microsoft.com/office/drawing/2014/main" id="{FC254872-63B1-4402-1337-718AB39BCBB6}"/>
+              </a:ext>
+            </a:extLst>
+          </p:cNvPr>
+          <p:cNvCxnSpPr>
+            <a:cxnSpLocks/>
+          </p:cNvCxnSpPr>
+          <p:nvPr/>
+        </p:nvCxnSpPr>
+        <p:spPr>
+          <a:xfrm flipH="1">
+            <a:off x="2785422" y="1645057"/>
+            <a:ext cx="195694" cy="164927"/>
+          </a:xfrm>
+          <a:prstGeom prst="line">
+            <a:avLst/>
+          </a:prstGeom>
+          <a:ln w="12700" cap="rnd">
+            <a:solidFill>
+              <a:schemeClr val="tx1"/>
+            </a:solidFill>
+            <a:round/>
+          </a:ln>
+        </p:spPr>
+        <p:style>
+          <a:lnRef idx="2">
+            <a:schemeClr val="accent1"/>
+          </a:lnRef>
+          <a:fillRef idx="0">
+            <a:schemeClr val="accent1"/>
+          </a:fillRef>
+          <a:effectRef idx="1">
+            <a:schemeClr val="accent1"/>
+          </a:effectRef>
+          <a:fontRef idx="minor">
+            <a:schemeClr val="tx1"/>
+          </a:fontRef>
+        </p:style>
+      </p:cxnSp>
+      <p:cxnSp>
+        <p:nvCxnSpPr>
+          <p:cNvPr id="12" name="Gerader Verbinder 11">
+            <a:extLst>
+              <a:ext uri="{FF2B5EF4-FFF2-40B4-BE49-F238E27FC236}">
+                <a16:creationId xmlns:a16="http://schemas.microsoft.com/office/drawing/2014/main" id="{7E9C4078-EB4E-F824-6263-56B7EE88453D}"/>
+              </a:ext>
+            </a:extLst>
+          </p:cNvPr>
+          <p:cNvCxnSpPr>
+            <a:cxnSpLocks/>
+          </p:cNvCxnSpPr>
+          <p:nvPr/>
+        </p:nvCxnSpPr>
+        <p:spPr>
+          <a:xfrm>
+            <a:off x="2937822" y="716109"/>
+            <a:ext cx="0" cy="961217"/>
+          </a:xfrm>
+          <a:prstGeom prst="line">
+            <a:avLst/>
+          </a:prstGeom>
+          <a:ln w="12700" cap="rnd">
+            <a:solidFill>
+              <a:schemeClr val="tx1"/>
+            </a:solidFill>
+            <a:round/>
+            <a:headEnd type="triangle" w="sm" len="med"/>
+            <a:tailEnd type="triangle" w="sm" len="med"/>
+          </a:ln>
+        </p:spPr>
+        <p:style>
+          <a:lnRef idx="2">
+            <a:schemeClr val="accent1"/>
+          </a:lnRef>
+          <a:fillRef idx="0">
+            <a:schemeClr val="accent1"/>
+          </a:fillRef>
+          <a:effectRef idx="1">
+            <a:schemeClr val="accent1"/>
+          </a:effectRef>
+          <a:fontRef idx="minor">
+            <a:schemeClr val="tx1"/>
+          </a:fontRef>
+        </p:style>
+      </p:cxnSp>
+      <p:sp>
+        <p:nvSpPr>
+          <p:cNvPr id="16" name="Textfeld 15">
+            <a:extLst>
+              <a:ext uri="{FF2B5EF4-FFF2-40B4-BE49-F238E27FC236}">
+                <a16:creationId xmlns:a16="http://schemas.microsoft.com/office/drawing/2014/main" id="{8C3BAF4E-0C5B-2149-F738-D3C3D850135E}"/>
+              </a:ext>
+            </a:extLst>
+          </p:cNvPr>
+          <p:cNvSpPr txBox="1"/>
+          <p:nvPr/>
+        </p:nvSpPr>
+        <p:spPr>
+          <a:xfrm>
+            <a:off x="2783517" y="1012051"/>
+            <a:ext cx="582460" cy="369332"/>
+          </a:xfrm>
+          <a:prstGeom prst="rect">
+            <a:avLst/>
+          </a:prstGeom>
+          <a:noFill/>
+        </p:spPr>
+        <p:txBody>
+          <a:bodyPr wrap="square" rtlCol="0" anchor="ctr">
+            <a:spAutoFit/>
+          </a:bodyPr>
+          <a:lstStyle/>
+          <a:p>
+            <a:pPr algn="ctr"/>
+            <a:r>
+              <a:rPr lang="de-DE" i="1" dirty="0">
+                <a:latin typeface="CMU Serif" panose="02000603000000000000" pitchFamily="2" charset="0"/>
+                <a:ea typeface="CMU Serif" panose="02000603000000000000" pitchFamily="2" charset="0"/>
+                <a:cs typeface="CMU Serif" panose="02000603000000000000" pitchFamily="2" charset="0"/>
+              </a:rPr>
+              <a:t>b</a:t>
+            </a:r>
+            <a:endParaRPr lang="de-DE" baseline="-25000" dirty="0">
+              <a:latin typeface="CMU Serif" panose="02000603000000000000" pitchFamily="2" charset="0"/>
+              <a:ea typeface="CMU Serif" panose="02000603000000000000" pitchFamily="2" charset="0"/>
+              <a:cs typeface="CMU Serif" panose="02000603000000000000" pitchFamily="2" charset="0"/>
+            </a:endParaRPr>
+          </a:p>
+        </p:txBody>
+      </p:sp>
+      <p:cxnSp>
+        <p:nvCxnSpPr>
+          <p:cNvPr id="17" name="Gerader Verbinder 16">
+            <a:extLst>
+              <a:ext uri="{FF2B5EF4-FFF2-40B4-BE49-F238E27FC236}">
+                <a16:creationId xmlns:a16="http://schemas.microsoft.com/office/drawing/2014/main" id="{416805AF-282C-FDB2-299E-49ED045A3F9B}"/>
+              </a:ext>
+            </a:extLst>
+          </p:cNvPr>
+          <p:cNvCxnSpPr>
+            <a:cxnSpLocks/>
+          </p:cNvCxnSpPr>
+          <p:nvPr/>
+        </p:nvCxnSpPr>
+        <p:spPr>
+          <a:xfrm flipV="1">
+            <a:off x="2786804" y="1807444"/>
+            <a:ext cx="0" cy="277583"/>
+          </a:xfrm>
+          <a:prstGeom prst="line">
+            <a:avLst/>
+          </a:prstGeom>
+          <a:ln w="12700" cap="rnd">
+            <a:solidFill>
+              <a:schemeClr val="tx1"/>
+            </a:solidFill>
+            <a:round/>
+          </a:ln>
+        </p:spPr>
+        <p:style>
+          <a:lnRef idx="2">
+            <a:schemeClr val="accent1"/>
+          </a:lnRef>
+          <a:fillRef idx="0">
+            <a:schemeClr val="accent1"/>
+          </a:fillRef>
+          <a:effectRef idx="1">
+            <a:schemeClr val="accent1"/>
+          </a:effectRef>
+          <a:fontRef idx="minor">
+            <a:schemeClr val="tx1"/>
+          </a:fontRef>
+        </p:style>
+      </p:cxnSp>
+      <p:cxnSp>
+        <p:nvCxnSpPr>
+          <p:cNvPr id="20" name="Gerader Verbinder 19">
+            <a:extLst>
+              <a:ext uri="{FF2B5EF4-FFF2-40B4-BE49-F238E27FC236}">
+                <a16:creationId xmlns:a16="http://schemas.microsoft.com/office/drawing/2014/main" id="{BD52E329-7B23-C993-AFA6-3109340C428B}"/>
+              </a:ext>
+            </a:extLst>
+          </p:cNvPr>
+          <p:cNvCxnSpPr>
+            <a:cxnSpLocks/>
+          </p:cNvCxnSpPr>
+          <p:nvPr/>
+        </p:nvCxnSpPr>
+        <p:spPr>
+          <a:xfrm flipV="1">
+            <a:off x="1828999" y="2613839"/>
+            <a:ext cx="0" cy="277583"/>
+          </a:xfrm>
+          <a:prstGeom prst="line">
+            <a:avLst/>
+          </a:prstGeom>
+          <a:ln w="12700" cap="rnd">
+            <a:solidFill>
+              <a:schemeClr val="tx1"/>
+            </a:solidFill>
+            <a:round/>
+          </a:ln>
+        </p:spPr>
+        <p:style>
+          <a:lnRef idx="2">
+            <a:schemeClr val="accent1"/>
+          </a:lnRef>
+          <a:fillRef idx="0">
+            <a:schemeClr val="accent1"/>
+          </a:fillRef>
+          <a:effectRef idx="1">
+            <a:schemeClr val="accent1"/>
+          </a:effectRef>
+          <a:fontRef idx="minor">
+            <a:schemeClr val="tx1"/>
+          </a:fontRef>
+        </p:style>
+      </p:cxnSp>
+      <p:cxnSp>
+        <p:nvCxnSpPr>
+          <p:cNvPr id="21" name="Gerader Verbinder 20">
+            <a:extLst>
+              <a:ext uri="{FF2B5EF4-FFF2-40B4-BE49-F238E27FC236}">
+                <a16:creationId xmlns:a16="http://schemas.microsoft.com/office/drawing/2014/main" id="{E9B46850-9D83-583F-3547-B9A84BA7B55D}"/>
+              </a:ext>
+            </a:extLst>
+          </p:cNvPr>
+          <p:cNvCxnSpPr>
+            <a:cxnSpLocks/>
+          </p:cNvCxnSpPr>
+          <p:nvPr/>
+        </p:nvCxnSpPr>
+        <p:spPr>
+          <a:xfrm flipH="1">
+            <a:off x="1831706" y="2039307"/>
+            <a:ext cx="951250" cy="806576"/>
+          </a:xfrm>
+          <a:prstGeom prst="line">
+            <a:avLst/>
+          </a:prstGeom>
+          <a:ln w="12700" cap="rnd">
+            <a:solidFill>
+              <a:schemeClr val="tx1"/>
+            </a:solidFill>
+            <a:round/>
+            <a:headEnd type="triangle" w="sm" len="med"/>
+            <a:tailEnd type="triangle" w="sm" len="med"/>
+          </a:ln>
+        </p:spPr>
+        <p:style>
+          <a:lnRef idx="2">
+            <a:schemeClr val="accent1"/>
+          </a:lnRef>
+          <a:fillRef idx="0">
+            <a:schemeClr val="accent1"/>
+          </a:fillRef>
+          <a:effectRef idx="1">
+            <a:schemeClr val="accent1"/>
+          </a:effectRef>
+          <a:fontRef idx="minor">
+            <a:schemeClr val="tx1"/>
+          </a:fontRef>
+        </p:style>
+      </p:cxnSp>
+      <p:sp>
+        <p:nvSpPr>
+          <p:cNvPr id="25" name="Textfeld 24">
+            <a:extLst>
+              <a:ext uri="{FF2B5EF4-FFF2-40B4-BE49-F238E27FC236}">
+                <a16:creationId xmlns:a16="http://schemas.microsoft.com/office/drawing/2014/main" id="{C8779267-D76A-9B99-DE01-D1C9A4DFC975}"/>
+              </a:ext>
+            </a:extLst>
+          </p:cNvPr>
+          <p:cNvSpPr txBox="1"/>
+          <p:nvPr/>
+        </p:nvSpPr>
+        <p:spPr>
+          <a:xfrm>
+            <a:off x="2122769" y="2363069"/>
+            <a:ext cx="582460" cy="369332"/>
+          </a:xfrm>
+          <a:prstGeom prst="rect">
+            <a:avLst/>
+          </a:prstGeom>
+          <a:noFill/>
+        </p:spPr>
+        <p:txBody>
+          <a:bodyPr wrap="square" rtlCol="0" anchor="ctr">
+            <a:spAutoFit/>
+          </a:bodyPr>
+          <a:lstStyle/>
+          <a:p>
+            <a:pPr algn="ctr"/>
+            <a:r>
+              <a:rPr lang="de-DE" i="1" dirty="0">
+                <a:latin typeface="CMU Serif" panose="02000603000000000000" pitchFamily="2" charset="0"/>
+                <a:ea typeface="CMU Serif" panose="02000603000000000000" pitchFamily="2" charset="0"/>
+                <a:cs typeface="CMU Serif" panose="02000603000000000000" pitchFamily="2" charset="0"/>
+              </a:rPr>
+              <a:t>a</a:t>
+            </a:r>
+            <a:endParaRPr lang="de-DE" baseline="-25000" dirty="0">
+              <a:latin typeface="CMU Serif" panose="02000603000000000000" pitchFamily="2" charset="0"/>
+              <a:ea typeface="CMU Serif" panose="02000603000000000000" pitchFamily="2" charset="0"/>
+              <a:cs typeface="CMU Serif" panose="02000603000000000000" pitchFamily="2" charset="0"/>
+            </a:endParaRPr>
+          </a:p>
+        </p:txBody>
+      </p:sp>
+      <p:cxnSp>
+        <p:nvCxnSpPr>
+          <p:cNvPr id="26" name="Gerader Verbinder 25">
+            <a:extLst>
+              <a:ext uri="{FF2B5EF4-FFF2-40B4-BE49-F238E27FC236}">
+                <a16:creationId xmlns:a16="http://schemas.microsoft.com/office/drawing/2014/main" id="{8A8D30F6-FAF2-FED1-79A6-0AA9F591F418}"/>
+              </a:ext>
+            </a:extLst>
+          </p:cNvPr>
+          <p:cNvCxnSpPr>
+            <a:cxnSpLocks/>
+          </p:cNvCxnSpPr>
+          <p:nvPr/>
+        </p:nvCxnSpPr>
+        <p:spPr>
+          <a:xfrm flipV="1">
+            <a:off x="621280" y="2623582"/>
+            <a:ext cx="0" cy="277583"/>
+          </a:xfrm>
+          <a:prstGeom prst="line">
+            <a:avLst/>
+          </a:prstGeom>
+          <a:ln w="12700" cap="rnd">
+            <a:solidFill>
+              <a:schemeClr val="tx1"/>
+            </a:solidFill>
+            <a:round/>
+          </a:ln>
+        </p:spPr>
+        <p:style>
+          <a:lnRef idx="2">
+            <a:schemeClr val="accent1"/>
+          </a:lnRef>
+          <a:fillRef idx="0">
+            <a:schemeClr val="accent1"/>
+          </a:fillRef>
+          <a:effectRef idx="1">
+            <a:schemeClr val="accent1"/>
+          </a:effectRef>
+          <a:fontRef idx="minor">
+            <a:schemeClr val="tx1"/>
+          </a:fontRef>
+        </p:style>
+      </p:cxnSp>
+      <p:cxnSp>
+        <p:nvCxnSpPr>
+          <p:cNvPr id="27" name="Gerader Verbinder 26">
+            <a:extLst>
+              <a:ext uri="{FF2B5EF4-FFF2-40B4-BE49-F238E27FC236}">
+                <a16:creationId xmlns:a16="http://schemas.microsoft.com/office/drawing/2014/main" id="{71E0438C-EBDB-B595-D4D9-ABDF7D236681}"/>
+              </a:ext>
+            </a:extLst>
+          </p:cNvPr>
+          <p:cNvCxnSpPr>
+            <a:cxnSpLocks/>
+          </p:cNvCxnSpPr>
+          <p:nvPr/>
+        </p:nvCxnSpPr>
+        <p:spPr>
+          <a:xfrm flipH="1">
+            <a:off x="621280" y="2837728"/>
+            <a:ext cx="1207719" cy="0"/>
+          </a:xfrm>
+          <a:prstGeom prst="line">
+            <a:avLst/>
+          </a:prstGeom>
+          <a:ln w="12700" cap="rnd">
+            <a:solidFill>
+              <a:schemeClr val="tx1"/>
+            </a:solidFill>
+            <a:round/>
+            <a:headEnd type="triangle" w="sm" len="med"/>
+            <a:tailEnd type="triangle" w="sm" len="med"/>
+          </a:ln>
+        </p:spPr>
+        <p:style>
+          <a:lnRef idx="2">
+            <a:schemeClr val="accent1"/>
+          </a:lnRef>
+          <a:fillRef idx="0">
+            <a:schemeClr val="accent1"/>
+          </a:fillRef>
+          <a:effectRef idx="1">
+            <a:schemeClr val="accent1"/>
+          </a:effectRef>
+          <a:fontRef idx="minor">
+            <a:schemeClr val="tx1"/>
+          </a:fontRef>
+        </p:style>
+      </p:cxnSp>
+      <p:sp>
+        <p:nvSpPr>
+          <p:cNvPr id="30" name="Textfeld 29">
+            <a:extLst>
+              <a:ext uri="{FF2B5EF4-FFF2-40B4-BE49-F238E27FC236}">
+                <a16:creationId xmlns:a16="http://schemas.microsoft.com/office/drawing/2014/main" id="{F2357EA2-FB61-845D-6606-43965A52666B}"/>
+              </a:ext>
+            </a:extLst>
+          </p:cNvPr>
+          <p:cNvSpPr txBox="1"/>
+          <p:nvPr/>
+        </p:nvSpPr>
+        <p:spPr>
+          <a:xfrm>
+            <a:off x="933909" y="2784709"/>
+            <a:ext cx="582460" cy="369332"/>
+          </a:xfrm>
+          <a:prstGeom prst="rect">
+            <a:avLst/>
+          </a:prstGeom>
+          <a:noFill/>
+        </p:spPr>
+        <p:txBody>
+          <a:bodyPr wrap="square" rtlCol="0" anchor="ctr">
+            <a:spAutoFit/>
+          </a:bodyPr>
+          <a:lstStyle/>
+          <a:p>
+            <a:pPr algn="ctr"/>
+            <a:r>
+              <a:rPr lang="de-DE" i="1" dirty="0">
+                <a:latin typeface="CMU Serif" panose="02000603000000000000" pitchFamily="2" charset="0"/>
+                <a:ea typeface="CMU Serif" panose="02000603000000000000" pitchFamily="2" charset="0"/>
+                <a:cs typeface="CMU Serif" panose="02000603000000000000" pitchFamily="2" charset="0"/>
+              </a:rPr>
+              <a:t>c</a:t>
+            </a:r>
+            <a:endParaRPr lang="de-DE" baseline="-25000" dirty="0">
+              <a:latin typeface="CMU Serif" panose="02000603000000000000" pitchFamily="2" charset="0"/>
+              <a:ea typeface="CMU Serif" panose="02000603000000000000" pitchFamily="2" charset="0"/>
+              <a:cs typeface="CMU Serif" panose="02000603000000000000" pitchFamily="2" charset="0"/>
+            </a:endParaRPr>
+          </a:p>
+        </p:txBody>
+      </p:sp>
+      <p:sp>
+        <p:nvSpPr>
+          <p:cNvPr id="4" name="Parallelogramm 3">
+            <a:extLst>
+              <a:ext uri="{FF2B5EF4-FFF2-40B4-BE49-F238E27FC236}">
+                <a16:creationId xmlns:a16="http://schemas.microsoft.com/office/drawing/2014/main" id="{CEAFF44E-B5DF-A531-7A43-C19B112AD620}"/>
+              </a:ext>
+            </a:extLst>
+          </p:cNvPr>
+          <p:cNvSpPr/>
+          <p:nvPr/>
+        </p:nvSpPr>
+        <p:spPr>
+          <a:xfrm rot="16200000" flipV="1">
+            <a:off x="212222" y="1255344"/>
+            <a:ext cx="1775174" cy="951977"/>
+          </a:xfrm>
+          <a:prstGeom prst="parallelogram">
+            <a:avLst>
+              <a:gd name="adj" fmla="val 85011"/>
+            </a:avLst>
+          </a:prstGeom>
+          <a:solidFill>
+            <a:schemeClr val="accent2">
+              <a:alpha val="50000"/>
+            </a:schemeClr>
+          </a:solidFill>
+          <a:ln cap="rnd">
+            <a:solidFill>
+              <a:schemeClr val="accent2">
+                <a:lumMod val="75000"/>
+              </a:schemeClr>
+            </a:solidFill>
+            <a:round/>
+          </a:ln>
+        </p:spPr>
+        <p:style>
+          <a:lnRef idx="2">
+            <a:schemeClr val="accent1">
+              <a:shade val="15000"/>
+            </a:schemeClr>
+          </a:lnRef>
+          <a:fillRef idx="1">
+            <a:schemeClr val="accent1"/>
+          </a:fillRef>
+          <a:effectRef idx="0">
+            <a:schemeClr val="accent1"/>
+          </a:effectRef>
+          <a:fontRef idx="minor">
+            <a:schemeClr val="lt1"/>
+          </a:fontRef>
+        </p:style>
+        <p:txBody>
+          <a:bodyPr rtlCol="0" anchor="ctr"/>
+          <a:lstStyle/>
+          <a:p>
+            <a:pPr algn="ctr"/>
+            <a:endParaRPr lang="de-DE"/>
+          </a:p>
+        </p:txBody>
+      </p:sp>
+      <p:sp>
+        <p:nvSpPr>
+          <p:cNvPr id="5" name="Parallelogramm 4">
+            <a:extLst>
+              <a:ext uri="{FF2B5EF4-FFF2-40B4-BE49-F238E27FC236}">
+                <a16:creationId xmlns:a16="http://schemas.microsoft.com/office/drawing/2014/main" id="{128E1A85-F78F-269B-C2F6-EAD7EBD78DC0}"/>
+              </a:ext>
+            </a:extLst>
+          </p:cNvPr>
+          <p:cNvSpPr/>
+          <p:nvPr/>
+        </p:nvSpPr>
+        <p:spPr>
+          <a:xfrm rot="16200000" flipV="1">
+            <a:off x="1419941" y="1255343"/>
+            <a:ext cx="1775174" cy="951977"/>
+          </a:xfrm>
+          <a:prstGeom prst="parallelogram">
+            <a:avLst>
+              <a:gd name="adj" fmla="val 85011"/>
+            </a:avLst>
+          </a:prstGeom>
+          <a:solidFill>
+            <a:schemeClr val="tx2">
+              <a:lumMod val="50000"/>
+              <a:lumOff val="50000"/>
+              <a:alpha val="50000"/>
+            </a:schemeClr>
+          </a:solidFill>
+          <a:ln cap="rnd">
+            <a:solidFill>
+              <a:schemeClr val="tx2">
+                <a:lumMod val="75000"/>
+                <a:lumOff val="25000"/>
+              </a:schemeClr>
+            </a:solidFill>
+            <a:round/>
+          </a:ln>
+        </p:spPr>
+        <p:style>
+          <a:lnRef idx="2">
+            <a:schemeClr val="accent1">
+              <a:shade val="15000"/>
+            </a:schemeClr>
+          </a:lnRef>
+          <a:fillRef idx="1">
+            <a:schemeClr val="accent1"/>
+          </a:fillRef>
+          <a:effectRef idx="0">
+            <a:schemeClr val="accent1"/>
+          </a:effectRef>
+          <a:fontRef idx="minor">
+            <a:schemeClr val="lt1"/>
+          </a:fontRef>
+        </p:style>
+        <p:txBody>
+          <a:bodyPr rtlCol="0" anchor="ctr"/>
+          <a:lstStyle/>
+          <a:p>
+            <a:pPr algn="ctr"/>
+            <a:endParaRPr lang="de-DE"/>
+          </a:p>
+        </p:txBody>
+      </p:sp>
+      <p:sp>
+        <p:nvSpPr>
+          <p:cNvPr id="6" name="Textfeld 5">
+            <a:extLst>
+              <a:ext uri="{FF2B5EF4-FFF2-40B4-BE49-F238E27FC236}">
+                <a16:creationId xmlns:a16="http://schemas.microsoft.com/office/drawing/2014/main" id="{7EA9D369-570A-2045-FB90-E54D9B5DCCAE}"/>
+              </a:ext>
+            </a:extLst>
+          </p:cNvPr>
+          <p:cNvSpPr txBox="1"/>
+          <p:nvPr/>
+        </p:nvSpPr>
+        <p:spPr>
+          <a:xfrm>
+            <a:off x="808579" y="1542854"/>
+            <a:ext cx="582460" cy="369332"/>
+          </a:xfrm>
+          <a:prstGeom prst="rect">
+            <a:avLst/>
+          </a:prstGeom>
+          <a:noFill/>
+        </p:spPr>
+        <p:txBody>
+          <a:bodyPr wrap="square" rtlCol="0" anchor="ctr">
+            <a:spAutoFit/>
+          </a:bodyPr>
+          <a:lstStyle/>
+          <a:p>
+            <a:pPr algn="ctr"/>
+            <a:r>
+              <a:rPr lang="de-DE" i="1" dirty="0">
+                <a:solidFill>
+                  <a:schemeClr val="accent2">
+                    <a:lumMod val="75000"/>
+                  </a:schemeClr>
+                </a:solidFill>
+                <a:latin typeface="CMU Serif" panose="02000603000000000000" pitchFamily="2" charset="0"/>
+                <a:ea typeface="CMU Serif" panose="02000603000000000000" pitchFamily="2" charset="0"/>
+                <a:cs typeface="CMU Serif" panose="02000603000000000000" pitchFamily="2" charset="0"/>
+              </a:rPr>
+              <a:t>A</a:t>
+            </a:r>
+            <a:r>
+              <a:rPr lang="de-DE" baseline="-25000" dirty="0">
+                <a:solidFill>
+                  <a:schemeClr val="accent2">
+                    <a:lumMod val="75000"/>
+                  </a:schemeClr>
+                </a:solidFill>
+                <a:latin typeface="CMU Serif" panose="02000603000000000000" pitchFamily="2" charset="0"/>
+                <a:ea typeface="CMU Serif" panose="02000603000000000000" pitchFamily="2" charset="0"/>
+                <a:cs typeface="CMU Serif" panose="02000603000000000000" pitchFamily="2" charset="0"/>
+              </a:rPr>
+              <a:t>1</a:t>
+            </a:r>
+          </a:p>
+        </p:txBody>
+      </p:sp>
+      <p:sp>
+        <p:nvSpPr>
+          <p:cNvPr id="7" name="Textfeld 6">
+            <a:extLst>
+              <a:ext uri="{FF2B5EF4-FFF2-40B4-BE49-F238E27FC236}">
+                <a16:creationId xmlns:a16="http://schemas.microsoft.com/office/drawing/2014/main" id="{97E353DF-00DF-DBC8-E37E-95FC998686DE}"/>
+              </a:ext>
+            </a:extLst>
+          </p:cNvPr>
+          <p:cNvSpPr txBox="1"/>
+          <p:nvPr/>
+        </p:nvSpPr>
+        <p:spPr>
+          <a:xfrm>
+            <a:off x="2016101" y="1542854"/>
+            <a:ext cx="582460" cy="369332"/>
+          </a:xfrm>
+          <a:prstGeom prst="rect">
+            <a:avLst/>
+          </a:prstGeom>
+          <a:noFill/>
+        </p:spPr>
+        <p:txBody>
+          <a:bodyPr wrap="square" rtlCol="0" anchor="ctr">
+            <a:spAutoFit/>
+          </a:bodyPr>
+          <a:lstStyle/>
+          <a:p>
+            <a:pPr algn="ctr"/>
+            <a:r>
+              <a:rPr lang="de-DE" i="1" dirty="0">
+                <a:solidFill>
+                  <a:schemeClr val="tx2">
+                    <a:lumMod val="75000"/>
+                    <a:lumOff val="25000"/>
+                  </a:schemeClr>
+                </a:solidFill>
+                <a:latin typeface="CMU Serif" panose="02000603000000000000" pitchFamily="2" charset="0"/>
+                <a:ea typeface="CMU Serif" panose="02000603000000000000" pitchFamily="2" charset="0"/>
+                <a:cs typeface="CMU Serif" panose="02000603000000000000" pitchFamily="2" charset="0"/>
+              </a:rPr>
+              <a:t>A</a:t>
+            </a:r>
+            <a:r>
+              <a:rPr lang="de-DE" baseline="-25000" dirty="0">
+                <a:solidFill>
+                  <a:schemeClr val="tx2">
+                    <a:lumMod val="75000"/>
+                    <a:lumOff val="25000"/>
+                  </a:schemeClr>
+                </a:solidFill>
+                <a:latin typeface="CMU Serif" panose="02000603000000000000" pitchFamily="2" charset="0"/>
+                <a:ea typeface="CMU Serif" panose="02000603000000000000" pitchFamily="2" charset="0"/>
+                <a:cs typeface="CMU Serif" panose="02000603000000000000" pitchFamily="2" charset="0"/>
+              </a:rPr>
+              <a:t>2</a:t>
+            </a:r>
+          </a:p>
+        </p:txBody>
+      </p:sp>
+    </p:spTree>
+    <p:extLst>
+      <p:ext uri="{BB962C8B-B14F-4D97-AF65-F5344CB8AC3E}">
+        <p14:creationId xmlns:p14="http://schemas.microsoft.com/office/powerpoint/2010/main" val="3605772299"/>
+      </p:ext>
+    </p:extLst>
+  </p:cSld>
+  <p:clrMapOvr>
+    <a:masterClrMapping/>
+  </p:clrMapOvr>
+</p:sld>
+</file>
+
+<file path=ppt/slides/slide3.xml><?xml version="1.0" encoding="utf-8"?>
+<p:sld xmlns:a="http://schemas.openxmlformats.org/drawingml/2006/main" xmlns:r="http://schemas.openxmlformats.org/officeDocument/2006/relationships" xmlns:p="http://schemas.openxmlformats.org/presentationml/2006/main">
+  <p:cSld>
+    <p:spTree>
+      <p:nvGrpSpPr>
+        <p:cNvPr id="1" name=""/>
+        <p:cNvGrpSpPr/>
+        <p:nvPr/>
+      </p:nvGrpSpPr>
+      <p:grpSpPr>
+        <a:xfrm>
+          <a:off x="0" y="0"/>
+          <a:ext cx="0" cy="0"/>
+          <a:chOff x="0" y="0"/>
+          <a:chExt cx="0" cy="0"/>
+        </a:xfrm>
+      </p:grpSpPr>
+      <p:sp>
+        <p:nvSpPr>
+          <p:cNvPr id="37" name="Parallelogramm 36">
+            <a:extLst>
+              <a:ext uri="{FF2B5EF4-FFF2-40B4-BE49-F238E27FC236}">
+                <a16:creationId xmlns:a16="http://schemas.microsoft.com/office/drawing/2014/main" id="{70478F71-F7D9-710D-A29E-D25708D830CC}"/>
+              </a:ext>
+            </a:extLst>
+          </p:cNvPr>
+          <p:cNvSpPr/>
+          <p:nvPr/>
+        </p:nvSpPr>
+        <p:spPr>
+          <a:xfrm rot="8886906" flipV="1">
+            <a:off x="892842" y="779259"/>
+            <a:ext cx="1083426" cy="256126"/>
+          </a:xfrm>
+          <a:prstGeom prst="parallelogram">
+            <a:avLst>
+              <a:gd name="adj" fmla="val 117404"/>
+            </a:avLst>
+          </a:prstGeom>
+          <a:solidFill>
+            <a:schemeClr val="tx2">
+              <a:lumMod val="50000"/>
+              <a:lumOff val="50000"/>
+            </a:schemeClr>
+          </a:solidFill>
+          <a:ln cap="rnd">
+            <a:solidFill>
+              <a:schemeClr val="tx2">
+                <a:lumMod val="90000"/>
+                <a:lumOff val="10000"/>
+              </a:schemeClr>
+            </a:solidFill>
+            <a:round/>
+          </a:ln>
+        </p:spPr>
+        <p:style>
+          <a:lnRef idx="2">
+            <a:schemeClr val="accent1">
+              <a:shade val="15000"/>
+            </a:schemeClr>
+          </a:lnRef>
+          <a:fillRef idx="1">
+            <a:schemeClr val="accent1"/>
+          </a:fillRef>
+          <a:effectRef idx="0">
+            <a:schemeClr val="accent1"/>
+          </a:effectRef>
+          <a:fontRef idx="minor">
+            <a:schemeClr val="lt1"/>
+          </a:fontRef>
+        </p:style>
+        <p:txBody>
+          <a:bodyPr rtlCol="0" anchor="ctr"/>
+          <a:lstStyle/>
+          <a:p>
+            <a:pPr algn="ctr"/>
+            <a:endParaRPr lang="de-DE"/>
+          </a:p>
+        </p:txBody>
+      </p:sp>
+      <p:sp>
+        <p:nvSpPr>
+          <p:cNvPr id="34" name="Parallelogramm 33">
+            <a:extLst>
+              <a:ext uri="{FF2B5EF4-FFF2-40B4-BE49-F238E27FC236}">
+                <a16:creationId xmlns:a16="http://schemas.microsoft.com/office/drawing/2014/main" id="{7B95E9ED-C892-96C0-FA8C-2985F8592131}"/>
+              </a:ext>
+            </a:extLst>
+          </p:cNvPr>
+          <p:cNvSpPr/>
+          <p:nvPr/>
+        </p:nvSpPr>
+        <p:spPr>
+          <a:xfrm rot="8886906" flipV="1">
+            <a:off x="1331976" y="766521"/>
+            <a:ext cx="1298501" cy="444503"/>
+          </a:xfrm>
+          <a:prstGeom prst="parallelogram">
+            <a:avLst>
+              <a:gd name="adj" fmla="val 117404"/>
+            </a:avLst>
+          </a:prstGeom>
+          <a:solidFill>
+            <a:schemeClr val="accent2">
+              <a:lumMod val="60000"/>
+              <a:lumOff val="40000"/>
+            </a:schemeClr>
+          </a:solidFill>
+          <a:ln cap="rnd">
+            <a:solidFill>
+              <a:schemeClr val="accent2">
+                <a:lumMod val="75000"/>
+              </a:schemeClr>
+            </a:solidFill>
+            <a:round/>
+          </a:ln>
+        </p:spPr>
+        <p:style>
+          <a:lnRef idx="2">
+            <a:schemeClr val="accent1">
+              <a:shade val="15000"/>
+            </a:schemeClr>
+          </a:lnRef>
+          <a:fillRef idx="1">
+            <a:schemeClr val="accent1"/>
+          </a:fillRef>
+          <a:effectRef idx="0">
+            <a:schemeClr val="accent1"/>
+          </a:effectRef>
+          <a:fontRef idx="minor">
+            <a:schemeClr val="lt1"/>
+          </a:fontRef>
+        </p:style>
+        <p:txBody>
+          <a:bodyPr rtlCol="0" anchor="ctr"/>
+          <a:lstStyle/>
+          <a:p>
+            <a:pPr algn="ctr"/>
+            <a:endParaRPr lang="de-DE"/>
+          </a:p>
+        </p:txBody>
+      </p:sp>
+      <p:sp>
+        <p:nvSpPr>
+          <p:cNvPr id="33" name="Parallelogramm 32">
+            <a:extLst>
+              <a:ext uri="{FF2B5EF4-FFF2-40B4-BE49-F238E27FC236}">
+                <a16:creationId xmlns:a16="http://schemas.microsoft.com/office/drawing/2014/main" id="{3E018C06-2011-04CB-4AC5-B4C93974848F}"/>
+              </a:ext>
+            </a:extLst>
+          </p:cNvPr>
+          <p:cNvSpPr/>
+          <p:nvPr/>
+        </p:nvSpPr>
+        <p:spPr>
+          <a:xfrm rot="8886906" flipV="1">
+            <a:off x="1981608" y="946891"/>
+            <a:ext cx="1083426" cy="256126"/>
+          </a:xfrm>
+          <a:prstGeom prst="parallelogram">
+            <a:avLst>
+              <a:gd name="adj" fmla="val 117404"/>
+            </a:avLst>
+          </a:prstGeom>
+          <a:solidFill>
+            <a:schemeClr val="accent6">
+              <a:lumMod val="40000"/>
+              <a:lumOff val="60000"/>
+            </a:schemeClr>
+          </a:solidFill>
+          <a:ln cap="rnd">
+            <a:solidFill>
+              <a:schemeClr val="accent6">
+                <a:lumMod val="75000"/>
+              </a:schemeClr>
+            </a:solidFill>
+            <a:round/>
+          </a:ln>
+        </p:spPr>
+        <p:style>
+          <a:lnRef idx="2">
+            <a:schemeClr val="accent1">
+              <a:shade val="15000"/>
+            </a:schemeClr>
+          </a:lnRef>
+          <a:fillRef idx="1">
+            <a:schemeClr val="accent1"/>
+          </a:fillRef>
+          <a:effectRef idx="0">
+            <a:schemeClr val="accent1"/>
+          </a:effectRef>
+          <a:fontRef idx="minor">
+            <a:schemeClr val="lt1"/>
+          </a:fontRef>
+        </p:style>
+        <p:txBody>
+          <a:bodyPr rtlCol="0" anchor="ctr"/>
+          <a:lstStyle/>
+          <a:p>
+            <a:pPr algn="ctr"/>
+            <a:endParaRPr lang="de-DE"/>
+          </a:p>
+        </p:txBody>
+      </p:sp>
+      <p:cxnSp>
+        <p:nvCxnSpPr>
+          <p:cNvPr id="12" name="Gerader Verbinder 11">
+            <a:extLst>
+              <a:ext uri="{FF2B5EF4-FFF2-40B4-BE49-F238E27FC236}">
+                <a16:creationId xmlns:a16="http://schemas.microsoft.com/office/drawing/2014/main" id="{F6F510C7-822F-964F-2BDD-34A1574BB063}"/>
+              </a:ext>
+            </a:extLst>
+          </p:cNvPr>
+          <p:cNvCxnSpPr>
+            <a:cxnSpLocks/>
+          </p:cNvCxnSpPr>
+          <p:nvPr/>
+        </p:nvCxnSpPr>
+        <p:spPr>
+          <a:xfrm flipV="1">
+            <a:off x="2386806" y="2726535"/>
+            <a:ext cx="0" cy="277583"/>
+          </a:xfrm>
+          <a:prstGeom prst="line">
+            <a:avLst/>
+          </a:prstGeom>
+          <a:ln w="12700" cap="rnd">
+            <a:solidFill>
+              <a:schemeClr val="tx1"/>
+            </a:solidFill>
+            <a:round/>
+          </a:ln>
+        </p:spPr>
+        <p:style>
+          <a:lnRef idx="2">
+            <a:schemeClr val="accent1"/>
+          </a:lnRef>
+          <a:fillRef idx="0">
+            <a:schemeClr val="accent1"/>
+          </a:fillRef>
+          <a:effectRef idx="1">
+            <a:schemeClr val="accent1"/>
+          </a:effectRef>
+          <a:fontRef idx="minor">
+            <a:schemeClr val="tx1"/>
+          </a:fontRef>
+        </p:style>
+      </p:cxnSp>
+      <p:sp>
+        <p:nvSpPr>
+          <p:cNvPr id="32" name="Parallelogramm 31">
+            <a:extLst>
+              <a:ext uri="{FF2B5EF4-FFF2-40B4-BE49-F238E27FC236}">
+                <a16:creationId xmlns:a16="http://schemas.microsoft.com/office/drawing/2014/main" id="{8E363910-024C-D3BF-B15E-0AEDB5DCF432}"/>
+              </a:ext>
+            </a:extLst>
+          </p:cNvPr>
+          <p:cNvSpPr/>
+          <p:nvPr/>
+        </p:nvSpPr>
+        <p:spPr>
+          <a:xfrm rot="16200000" flipV="1">
+            <a:off x="1802360" y="1479954"/>
+            <a:ext cx="1832319" cy="666920"/>
+          </a:xfrm>
+          <a:prstGeom prst="parallelogram">
+            <a:avLst>
+              <a:gd name="adj" fmla="val 62241"/>
+            </a:avLst>
+          </a:prstGeom>
+          <a:solidFill>
+            <a:schemeClr val="accent6">
+              <a:lumMod val="40000"/>
+              <a:lumOff val="60000"/>
+            </a:schemeClr>
+          </a:solidFill>
+          <a:ln cap="rnd">
+            <a:solidFill>
+              <a:schemeClr val="accent6">
+                <a:lumMod val="75000"/>
+              </a:schemeClr>
+            </a:solidFill>
+            <a:round/>
+          </a:ln>
+        </p:spPr>
+        <p:style>
+          <a:lnRef idx="2">
+            <a:schemeClr val="accent1">
+              <a:shade val="15000"/>
+            </a:schemeClr>
+          </a:lnRef>
+          <a:fillRef idx="1">
+            <a:schemeClr val="accent1"/>
+          </a:fillRef>
+          <a:effectRef idx="0">
+            <a:schemeClr val="accent1"/>
+          </a:effectRef>
+          <a:fontRef idx="minor">
+            <a:schemeClr val="lt1"/>
+          </a:fontRef>
+        </p:style>
+        <p:txBody>
+          <a:bodyPr rtlCol="0" anchor="ctr"/>
+          <a:lstStyle/>
+          <a:p>
+            <a:pPr algn="ctr"/>
+            <a:endParaRPr lang="de-DE"/>
+          </a:p>
+        </p:txBody>
+      </p:sp>
+      <p:cxnSp>
+        <p:nvCxnSpPr>
+          <p:cNvPr id="9" name="Gerader Verbinder 8">
+            <a:extLst>
+              <a:ext uri="{FF2B5EF4-FFF2-40B4-BE49-F238E27FC236}">
+                <a16:creationId xmlns:a16="http://schemas.microsoft.com/office/drawing/2014/main" id="{B1034CBB-05C1-4A84-AC19-11E0D019B95D}"/>
+              </a:ext>
+            </a:extLst>
+          </p:cNvPr>
+          <p:cNvCxnSpPr>
+            <a:cxnSpLocks/>
+          </p:cNvCxnSpPr>
+          <p:nvPr/>
+        </p:nvCxnSpPr>
+        <p:spPr>
+          <a:xfrm flipV="1">
+            <a:off x="902811" y="2505918"/>
+            <a:ext cx="0" cy="277583"/>
+          </a:xfrm>
+          <a:prstGeom prst="line">
+            <a:avLst/>
+          </a:prstGeom>
+          <a:ln w="12700" cap="rnd">
+            <a:solidFill>
+              <a:schemeClr val="tx1"/>
+            </a:solidFill>
+            <a:round/>
+          </a:ln>
+        </p:spPr>
+        <p:style>
+          <a:lnRef idx="2">
+            <a:schemeClr val="accent1"/>
+          </a:lnRef>
+          <a:fillRef idx="0">
+            <a:schemeClr val="accent1"/>
+          </a:fillRef>
+          <a:effectRef idx="1">
+            <a:schemeClr val="accent1"/>
+          </a:effectRef>
+          <a:fontRef idx="minor">
+            <a:schemeClr val="tx1"/>
+          </a:fontRef>
+        </p:style>
+      </p:cxnSp>
+      <p:cxnSp>
+        <p:nvCxnSpPr>
+          <p:cNvPr id="10" name="Gerader Verbinder 9">
+            <a:extLst>
+              <a:ext uri="{FF2B5EF4-FFF2-40B4-BE49-F238E27FC236}">
+                <a16:creationId xmlns:a16="http://schemas.microsoft.com/office/drawing/2014/main" id="{21FB3827-54AB-D030-1807-D9EA6AE7CBD4}"/>
+              </a:ext>
+            </a:extLst>
+          </p:cNvPr>
+          <p:cNvCxnSpPr>
+            <a:cxnSpLocks/>
+          </p:cNvCxnSpPr>
+          <p:nvPr/>
+        </p:nvCxnSpPr>
+        <p:spPr>
+          <a:xfrm flipV="1">
+            <a:off x="1299051" y="2567922"/>
+            <a:ext cx="0" cy="277583"/>
+          </a:xfrm>
+          <a:prstGeom prst="line">
+            <a:avLst/>
+          </a:prstGeom>
+          <a:ln w="12700" cap="rnd">
+            <a:solidFill>
+              <a:schemeClr val="tx1"/>
+            </a:solidFill>
+            <a:round/>
+          </a:ln>
+        </p:spPr>
+        <p:style>
+          <a:lnRef idx="2">
+            <a:schemeClr val="accent1"/>
+          </a:lnRef>
+          <a:fillRef idx="0">
+            <a:schemeClr val="accent1"/>
+          </a:fillRef>
+          <a:effectRef idx="1">
+            <a:schemeClr val="accent1"/>
+          </a:effectRef>
+          <a:fontRef idx="minor">
+            <a:schemeClr val="tx1"/>
+          </a:fontRef>
+        </p:style>
+      </p:cxnSp>
+      <p:cxnSp>
+        <p:nvCxnSpPr>
+          <p:cNvPr id="11" name="Gerader Verbinder 10">
+            <a:extLst>
+              <a:ext uri="{FF2B5EF4-FFF2-40B4-BE49-F238E27FC236}">
+                <a16:creationId xmlns:a16="http://schemas.microsoft.com/office/drawing/2014/main" id="{34E66948-962B-3EFF-95B8-381E1AE250A1}"/>
+              </a:ext>
+            </a:extLst>
+          </p:cNvPr>
+          <p:cNvCxnSpPr>
+            <a:cxnSpLocks/>
+          </p:cNvCxnSpPr>
+          <p:nvPr/>
+        </p:nvCxnSpPr>
+        <p:spPr>
+          <a:xfrm flipV="1">
+            <a:off x="1988411" y="2669474"/>
+            <a:ext cx="0" cy="277583"/>
+          </a:xfrm>
+          <a:prstGeom prst="line">
+            <a:avLst/>
+          </a:prstGeom>
+          <a:ln w="12700" cap="rnd">
+            <a:solidFill>
+              <a:schemeClr val="tx1"/>
+            </a:solidFill>
+            <a:round/>
+          </a:ln>
+        </p:spPr>
+        <p:style>
+          <a:lnRef idx="2">
+            <a:schemeClr val="accent1"/>
+          </a:lnRef>
+          <a:fillRef idx="0">
+            <a:schemeClr val="accent1"/>
+          </a:fillRef>
+          <a:effectRef idx="1">
+            <a:schemeClr val="accent1"/>
+          </a:effectRef>
+          <a:fontRef idx="minor">
+            <a:schemeClr val="tx1"/>
+          </a:fontRef>
+        </p:style>
+      </p:cxnSp>
+      <p:sp>
+        <p:nvSpPr>
+          <p:cNvPr id="4" name="Parallelogramm 3">
+            <a:extLst>
+              <a:ext uri="{FF2B5EF4-FFF2-40B4-BE49-F238E27FC236}">
+                <a16:creationId xmlns:a16="http://schemas.microsoft.com/office/drawing/2014/main" id="{B9AB4D4D-24DC-E75B-78E3-2831F3CDF3A8}"/>
+              </a:ext>
+            </a:extLst>
+          </p:cNvPr>
+          <p:cNvSpPr/>
+          <p:nvPr/>
+        </p:nvSpPr>
+        <p:spPr>
+          <a:xfrm rot="16200000">
+            <a:off x="884504" y="1573171"/>
+            <a:ext cx="1523999" cy="671278"/>
+          </a:xfrm>
+          <a:prstGeom prst="parallelogram">
+            <a:avLst>
+              <a:gd name="adj" fmla="val 15110"/>
+            </a:avLst>
+          </a:prstGeom>
+          <a:solidFill>
+            <a:schemeClr val="accent2">
+              <a:lumMod val="60000"/>
+              <a:lumOff val="40000"/>
+            </a:schemeClr>
+          </a:solidFill>
+          <a:ln cap="rnd">
+            <a:solidFill>
+              <a:schemeClr val="accent2">
+                <a:lumMod val="75000"/>
+              </a:schemeClr>
+            </a:solidFill>
+            <a:round/>
+          </a:ln>
+        </p:spPr>
+        <p:style>
+          <a:lnRef idx="2">
+            <a:schemeClr val="accent1">
+              <a:shade val="15000"/>
+            </a:schemeClr>
+          </a:lnRef>
+          <a:fillRef idx="1">
+            <a:schemeClr val="accent1"/>
+          </a:fillRef>
+          <a:effectRef idx="0">
+            <a:schemeClr val="accent1"/>
+          </a:effectRef>
+          <a:fontRef idx="minor">
+            <a:schemeClr val="lt1"/>
+          </a:fontRef>
+        </p:style>
+        <p:txBody>
+          <a:bodyPr rtlCol="0" anchor="ctr"/>
+          <a:lstStyle/>
+          <a:p>
+            <a:pPr algn="ctr"/>
+            <a:endParaRPr lang="de-DE"/>
+          </a:p>
+        </p:txBody>
+      </p:sp>
+      <p:sp>
+        <p:nvSpPr>
+          <p:cNvPr id="14" name="Parallelogramm 13">
+            <a:extLst>
+              <a:ext uri="{FF2B5EF4-FFF2-40B4-BE49-F238E27FC236}">
+                <a16:creationId xmlns:a16="http://schemas.microsoft.com/office/drawing/2014/main" id="{27DAB8A5-7D0C-CAEB-8AFC-0C23DE2FD779}"/>
+              </a:ext>
+            </a:extLst>
+          </p:cNvPr>
+          <p:cNvSpPr/>
+          <p:nvPr/>
+        </p:nvSpPr>
+        <p:spPr>
+          <a:xfrm rot="16200000">
+            <a:off x="1452623" y="1799433"/>
+            <a:ext cx="1480930" cy="385233"/>
+          </a:xfrm>
+          <a:prstGeom prst="parallelogram">
+            <a:avLst>
+              <a:gd name="adj" fmla="val 15110"/>
+            </a:avLst>
+          </a:prstGeom>
+          <a:solidFill>
+            <a:schemeClr val="accent6">
+              <a:lumMod val="60000"/>
+              <a:lumOff val="40000"/>
+            </a:schemeClr>
+          </a:solidFill>
+          <a:ln cap="rnd">
+            <a:solidFill>
+              <a:schemeClr val="accent6">
+                <a:lumMod val="75000"/>
+              </a:schemeClr>
+            </a:solidFill>
+            <a:round/>
+          </a:ln>
+        </p:spPr>
+        <p:style>
+          <a:lnRef idx="2">
+            <a:schemeClr val="accent1">
+              <a:shade val="15000"/>
+            </a:schemeClr>
+          </a:lnRef>
+          <a:fillRef idx="1">
+            <a:schemeClr val="accent1"/>
+          </a:fillRef>
+          <a:effectRef idx="0">
+            <a:schemeClr val="accent1"/>
+          </a:effectRef>
+          <a:fontRef idx="minor">
+            <a:schemeClr val="lt1"/>
+          </a:fontRef>
+        </p:style>
+        <p:txBody>
+          <a:bodyPr rtlCol="0" anchor="ctr"/>
+          <a:lstStyle/>
+          <a:p>
+            <a:pPr algn="ctr"/>
+            <a:endParaRPr lang="de-DE"/>
+          </a:p>
+        </p:txBody>
+      </p:sp>
+      <p:cxnSp>
+        <p:nvCxnSpPr>
+          <p:cNvPr id="43" name="Gerader Verbinder 42">
+            <a:extLst>
+              <a:ext uri="{FF2B5EF4-FFF2-40B4-BE49-F238E27FC236}">
+                <a16:creationId xmlns:a16="http://schemas.microsoft.com/office/drawing/2014/main" id="{814B0F21-9AA3-933D-02A3-B51537F33BDC}"/>
+              </a:ext>
+            </a:extLst>
+          </p:cNvPr>
+          <p:cNvCxnSpPr>
+            <a:cxnSpLocks/>
+          </p:cNvCxnSpPr>
+          <p:nvPr/>
+        </p:nvCxnSpPr>
+        <p:spPr>
+          <a:xfrm flipH="1" flipV="1">
+            <a:off x="472440" y="1477821"/>
+            <a:ext cx="472440" cy="71279"/>
+          </a:xfrm>
+          <a:prstGeom prst="line">
+            <a:avLst/>
+          </a:prstGeom>
+          <a:ln w="25400" cap="rnd">
+            <a:solidFill>
+              <a:srgbClr val="C00000"/>
+            </a:solidFill>
+            <a:round/>
+            <a:headEnd type="none" w="lg" len="lg"/>
+            <a:tailEnd type="none" w="sm" len="med"/>
+          </a:ln>
+        </p:spPr>
+        <p:style>
+          <a:lnRef idx="2">
+            <a:schemeClr val="accent1"/>
+          </a:lnRef>
+          <a:fillRef idx="0">
+            <a:schemeClr val="accent1"/>
+          </a:fillRef>
+          <a:effectRef idx="1">
+            <a:schemeClr val="accent1"/>
+          </a:effectRef>
+          <a:fontRef idx="minor">
+            <a:schemeClr val="tx1"/>
+          </a:fontRef>
+        </p:style>
+      </p:cxnSp>
+      <p:sp>
+        <p:nvSpPr>
+          <p:cNvPr id="2" name="Parallelogramm 1">
+            <a:extLst>
+              <a:ext uri="{FF2B5EF4-FFF2-40B4-BE49-F238E27FC236}">
+                <a16:creationId xmlns:a16="http://schemas.microsoft.com/office/drawing/2014/main" id="{99336128-AF37-C614-8F76-4C242C99D3BA}"/>
+              </a:ext>
+            </a:extLst>
+          </p:cNvPr>
+          <p:cNvSpPr/>
+          <p:nvPr/>
+        </p:nvSpPr>
+        <p:spPr>
+          <a:xfrm rot="16200000">
+            <a:off x="359663" y="1633454"/>
+            <a:ext cx="1478627" cy="385233"/>
+          </a:xfrm>
+          <a:prstGeom prst="parallelogram">
+            <a:avLst>
+              <a:gd name="adj" fmla="val 15110"/>
+            </a:avLst>
+          </a:prstGeom>
+          <a:solidFill>
+            <a:schemeClr val="tx2">
+              <a:lumMod val="50000"/>
+              <a:lumOff val="50000"/>
+            </a:schemeClr>
+          </a:solidFill>
+          <a:ln cap="rnd">
+            <a:solidFill>
+              <a:schemeClr val="tx2">
+                <a:lumMod val="90000"/>
+                <a:lumOff val="10000"/>
+              </a:schemeClr>
+            </a:solidFill>
+            <a:round/>
+          </a:ln>
+        </p:spPr>
+        <p:style>
+          <a:lnRef idx="2">
+            <a:schemeClr val="accent1">
+              <a:shade val="15000"/>
+            </a:schemeClr>
+          </a:lnRef>
+          <a:fillRef idx="1">
+            <a:schemeClr val="accent1"/>
+          </a:fillRef>
+          <a:effectRef idx="0">
+            <a:schemeClr val="accent1"/>
+          </a:effectRef>
+          <a:fontRef idx="minor">
+            <a:schemeClr val="lt1"/>
+          </a:fontRef>
+        </p:style>
+        <p:txBody>
+          <a:bodyPr rtlCol="0" anchor="ctr"/>
+          <a:lstStyle/>
+          <a:p>
+            <a:pPr algn="ctr"/>
+            <a:endParaRPr lang="de-DE"/>
+          </a:p>
+        </p:txBody>
+      </p:sp>
+      <p:cxnSp>
+        <p:nvCxnSpPr>
+          <p:cNvPr id="13" name="Gerader Verbinder 12">
+            <a:extLst>
+              <a:ext uri="{FF2B5EF4-FFF2-40B4-BE49-F238E27FC236}">
+                <a16:creationId xmlns:a16="http://schemas.microsoft.com/office/drawing/2014/main" id="{76B47B1E-3533-CC59-2C1E-D6D92F52A42E}"/>
+              </a:ext>
+            </a:extLst>
+          </p:cNvPr>
+          <p:cNvCxnSpPr>
+            <a:cxnSpLocks/>
+          </p:cNvCxnSpPr>
+          <p:nvPr/>
+        </p:nvCxnSpPr>
+        <p:spPr>
+          <a:xfrm flipH="1" flipV="1">
+            <a:off x="900424" y="2730791"/>
+            <a:ext cx="398627" cy="60142"/>
+          </a:xfrm>
+          <a:prstGeom prst="line">
+            <a:avLst/>
+          </a:prstGeom>
+          <a:ln w="12700" cap="rnd">
+            <a:solidFill>
+              <a:schemeClr val="tx1"/>
+            </a:solidFill>
+            <a:round/>
+            <a:headEnd type="triangle" w="sm" len="med"/>
+            <a:tailEnd type="triangle" w="sm" len="med"/>
+          </a:ln>
+        </p:spPr>
+        <p:style>
+          <a:lnRef idx="2">
+            <a:schemeClr val="accent1"/>
+          </a:lnRef>
+          <a:fillRef idx="0">
+            <a:schemeClr val="accent1"/>
+          </a:fillRef>
+          <a:effectRef idx="1">
+            <a:schemeClr val="accent1"/>
+          </a:effectRef>
+          <a:fontRef idx="minor">
+            <a:schemeClr val="tx1"/>
+          </a:fontRef>
+        </p:style>
+      </p:cxnSp>
+      <p:cxnSp>
+        <p:nvCxnSpPr>
+          <p:cNvPr id="17" name="Gerader Verbinder 16">
+            <a:extLst>
+              <a:ext uri="{FF2B5EF4-FFF2-40B4-BE49-F238E27FC236}">
+                <a16:creationId xmlns:a16="http://schemas.microsoft.com/office/drawing/2014/main" id="{06481EDF-217A-8297-75FB-EB6E5268372F}"/>
+              </a:ext>
+            </a:extLst>
+          </p:cNvPr>
+          <p:cNvCxnSpPr>
+            <a:cxnSpLocks/>
+          </p:cNvCxnSpPr>
+          <p:nvPr/>
+        </p:nvCxnSpPr>
+        <p:spPr>
+          <a:xfrm flipH="1" flipV="1">
+            <a:off x="1988411" y="2891311"/>
+            <a:ext cx="398627" cy="60142"/>
+          </a:xfrm>
+          <a:prstGeom prst="line">
+            <a:avLst/>
+          </a:prstGeom>
+          <a:ln w="12700" cap="rnd">
+            <a:solidFill>
+              <a:schemeClr val="tx1"/>
+            </a:solidFill>
+            <a:round/>
+            <a:headEnd type="triangle" w="sm" len="med"/>
+            <a:tailEnd type="triangle" w="sm" len="med"/>
+          </a:ln>
+        </p:spPr>
+        <p:style>
+          <a:lnRef idx="2">
+            <a:schemeClr val="accent1"/>
+          </a:lnRef>
+          <a:fillRef idx="0">
+            <a:schemeClr val="accent1"/>
+          </a:fillRef>
+          <a:effectRef idx="1">
+            <a:schemeClr val="accent1"/>
+          </a:effectRef>
+          <a:fontRef idx="minor">
+            <a:schemeClr val="tx1"/>
+          </a:fontRef>
+        </p:style>
+      </p:cxnSp>
+      <p:cxnSp>
+        <p:nvCxnSpPr>
+          <p:cNvPr id="18" name="Gerader Verbinder 17">
+            <a:extLst>
+              <a:ext uri="{FF2B5EF4-FFF2-40B4-BE49-F238E27FC236}">
+                <a16:creationId xmlns:a16="http://schemas.microsoft.com/office/drawing/2014/main" id="{22511571-B585-296B-2BAF-24307B778775}"/>
+              </a:ext>
+            </a:extLst>
+          </p:cNvPr>
+          <p:cNvCxnSpPr>
+            <a:cxnSpLocks/>
+          </p:cNvCxnSpPr>
+          <p:nvPr/>
+        </p:nvCxnSpPr>
+        <p:spPr>
+          <a:xfrm flipH="1" flipV="1">
+            <a:off x="1296604" y="2789028"/>
+            <a:ext cx="691806" cy="104374"/>
+          </a:xfrm>
+          <a:prstGeom prst="line">
+            <a:avLst/>
+          </a:prstGeom>
+          <a:ln w="12700" cap="rnd">
+            <a:solidFill>
+              <a:schemeClr val="tx1"/>
+            </a:solidFill>
+            <a:round/>
+            <a:headEnd type="triangle" w="sm" len="med"/>
+            <a:tailEnd type="triangle" w="sm" len="med"/>
+          </a:ln>
+        </p:spPr>
+        <p:style>
+          <a:lnRef idx="2">
+            <a:schemeClr val="accent1"/>
+          </a:lnRef>
+          <a:fillRef idx="0">
+            <a:schemeClr val="accent1"/>
+          </a:fillRef>
+          <a:effectRef idx="1">
+            <a:schemeClr val="accent1"/>
+          </a:effectRef>
+          <a:fontRef idx="minor">
+            <a:schemeClr val="tx1"/>
+          </a:fontRef>
+        </p:style>
+      </p:cxnSp>
+      <p:sp>
+        <p:nvSpPr>
+          <p:cNvPr id="20" name="Textfeld 19">
+            <a:extLst>
+              <a:ext uri="{FF2B5EF4-FFF2-40B4-BE49-F238E27FC236}">
+                <a16:creationId xmlns:a16="http://schemas.microsoft.com/office/drawing/2014/main" id="{FE0A3DF7-D524-D607-0969-E0E147F55B50}"/>
+              </a:ext>
+            </a:extLst>
+          </p:cNvPr>
+          <p:cNvSpPr txBox="1"/>
+          <p:nvPr/>
+        </p:nvSpPr>
+        <p:spPr>
+          <a:xfrm>
+            <a:off x="782486" y="2776813"/>
+            <a:ext cx="582460" cy="307777"/>
+          </a:xfrm>
+          <a:prstGeom prst="rect">
+            <a:avLst/>
+          </a:prstGeom>
+          <a:noFill/>
+        </p:spPr>
+        <p:txBody>
+          <a:bodyPr wrap="square" rtlCol="0" anchor="ctr">
+            <a:spAutoFit/>
+          </a:bodyPr>
+          <a:lstStyle/>
+          <a:p>
+            <a:pPr algn="ctr"/>
+            <a:r>
+              <a:rPr lang="de-DE" sz="1400" i="1" dirty="0">
+                <a:latin typeface="CMU Serif" panose="02000603000000000000" pitchFamily="2" charset="0"/>
+                <a:ea typeface="CMU Serif" panose="02000603000000000000" pitchFamily="2" charset="0"/>
+                <a:cs typeface="CMU Serif" panose="02000603000000000000" pitchFamily="2" charset="0"/>
+              </a:rPr>
+              <a:t>d</a:t>
+            </a:r>
+            <a:r>
+              <a:rPr lang="de-DE" sz="1400" baseline="-25000" dirty="0">
+                <a:latin typeface="CMU Serif" panose="02000603000000000000" pitchFamily="2" charset="0"/>
+                <a:ea typeface="CMU Serif" panose="02000603000000000000" pitchFamily="2" charset="0"/>
+                <a:cs typeface="CMU Serif" panose="02000603000000000000" pitchFamily="2" charset="0"/>
+              </a:rPr>
+              <a:t>1</a:t>
+            </a:r>
+          </a:p>
+        </p:txBody>
+      </p:sp>
+      <p:sp>
+        <p:nvSpPr>
+          <p:cNvPr id="21" name="Textfeld 20">
+            <a:extLst>
+              <a:ext uri="{FF2B5EF4-FFF2-40B4-BE49-F238E27FC236}">
+                <a16:creationId xmlns:a16="http://schemas.microsoft.com/office/drawing/2014/main" id="{3DC3760A-A00B-09E2-0493-5779912E66E1}"/>
+              </a:ext>
+            </a:extLst>
+          </p:cNvPr>
+          <p:cNvSpPr txBox="1"/>
+          <p:nvPr/>
+        </p:nvSpPr>
+        <p:spPr>
+          <a:xfrm>
+            <a:off x="1303440" y="2856089"/>
+            <a:ext cx="582460" cy="307777"/>
+          </a:xfrm>
+          <a:prstGeom prst="rect">
+            <a:avLst/>
+          </a:prstGeom>
+          <a:noFill/>
+        </p:spPr>
+        <p:txBody>
+          <a:bodyPr wrap="square" rtlCol="0" anchor="ctr">
+            <a:spAutoFit/>
+          </a:bodyPr>
+          <a:lstStyle/>
+          <a:p>
+            <a:pPr algn="ctr"/>
+            <a:r>
+              <a:rPr lang="de-DE" sz="1400" i="1" dirty="0">
+                <a:latin typeface="CMU Serif" panose="02000603000000000000" pitchFamily="2" charset="0"/>
+                <a:ea typeface="CMU Serif" panose="02000603000000000000" pitchFamily="2" charset="0"/>
+                <a:cs typeface="CMU Serif" panose="02000603000000000000" pitchFamily="2" charset="0"/>
+              </a:rPr>
+              <a:t>d</a:t>
+            </a:r>
+            <a:r>
+              <a:rPr lang="de-DE" sz="1400" baseline="-25000" dirty="0">
+                <a:latin typeface="CMU Serif" panose="02000603000000000000" pitchFamily="2" charset="0"/>
+                <a:ea typeface="CMU Serif" panose="02000603000000000000" pitchFamily="2" charset="0"/>
+                <a:cs typeface="CMU Serif" panose="02000603000000000000" pitchFamily="2" charset="0"/>
+              </a:rPr>
+              <a:t>2</a:t>
+            </a:r>
+          </a:p>
+        </p:txBody>
+      </p:sp>
+      <p:sp>
+        <p:nvSpPr>
+          <p:cNvPr id="22" name="Textfeld 21">
+            <a:extLst>
+              <a:ext uri="{FF2B5EF4-FFF2-40B4-BE49-F238E27FC236}">
+                <a16:creationId xmlns:a16="http://schemas.microsoft.com/office/drawing/2014/main" id="{59E373AB-39BE-4287-E867-7B31DF546302}"/>
+              </a:ext>
+            </a:extLst>
+          </p:cNvPr>
+          <p:cNvSpPr txBox="1"/>
+          <p:nvPr/>
+        </p:nvSpPr>
+        <p:spPr>
+          <a:xfrm>
+            <a:off x="1869824" y="2942860"/>
+            <a:ext cx="582460" cy="307777"/>
+          </a:xfrm>
+          <a:prstGeom prst="rect">
+            <a:avLst/>
+          </a:prstGeom>
+          <a:noFill/>
+        </p:spPr>
+        <p:txBody>
+          <a:bodyPr wrap="square" rtlCol="0" anchor="ctr">
+            <a:spAutoFit/>
+          </a:bodyPr>
+          <a:lstStyle/>
+          <a:p>
+            <a:pPr algn="ctr"/>
+            <a:r>
+              <a:rPr lang="de-DE" sz="1400" i="1" dirty="0">
+                <a:latin typeface="CMU Serif" panose="02000603000000000000" pitchFamily="2" charset="0"/>
+                <a:ea typeface="CMU Serif" panose="02000603000000000000" pitchFamily="2" charset="0"/>
+                <a:cs typeface="CMU Serif" panose="02000603000000000000" pitchFamily="2" charset="0"/>
+              </a:rPr>
+              <a:t>d</a:t>
+            </a:r>
+            <a:r>
+              <a:rPr lang="de-DE" sz="1400" baseline="-25000" dirty="0">
+                <a:latin typeface="CMU Serif" panose="02000603000000000000" pitchFamily="2" charset="0"/>
+                <a:ea typeface="CMU Serif" panose="02000603000000000000" pitchFamily="2" charset="0"/>
+                <a:cs typeface="CMU Serif" panose="02000603000000000000" pitchFamily="2" charset="0"/>
+              </a:rPr>
+              <a:t>3</a:t>
+            </a:r>
+          </a:p>
+        </p:txBody>
+      </p:sp>
+      <p:sp>
+        <p:nvSpPr>
+          <p:cNvPr id="25" name="Textfeld 24">
+            <a:extLst>
+              <a:ext uri="{FF2B5EF4-FFF2-40B4-BE49-F238E27FC236}">
+                <a16:creationId xmlns:a16="http://schemas.microsoft.com/office/drawing/2014/main" id="{FD6ECC37-C25A-F51C-CF61-C4D30EFEFF75}"/>
+              </a:ext>
+            </a:extLst>
+          </p:cNvPr>
+          <p:cNvSpPr txBox="1"/>
+          <p:nvPr/>
+        </p:nvSpPr>
+        <p:spPr>
+          <a:xfrm>
+            <a:off x="2443160" y="1329577"/>
+            <a:ext cx="582460" cy="307777"/>
+          </a:xfrm>
+          <a:prstGeom prst="rect">
+            <a:avLst/>
+          </a:prstGeom>
+          <a:noFill/>
+        </p:spPr>
+        <p:txBody>
+          <a:bodyPr wrap="square" rtlCol="0" anchor="ctr">
+            <a:spAutoFit/>
+          </a:bodyPr>
+          <a:lstStyle/>
+          <a:p>
+            <a:pPr algn="ctr"/>
+            <a:r>
+              <a:rPr lang="de-DE" sz="1400" i="1" dirty="0">
+                <a:solidFill>
+                  <a:schemeClr val="accent6">
+                    <a:lumMod val="50000"/>
+                  </a:schemeClr>
+                </a:solidFill>
+                <a:latin typeface="CMU Serif" panose="02000603000000000000" pitchFamily="2" charset="0"/>
+                <a:ea typeface="CMU Serif" panose="02000603000000000000" pitchFamily="2" charset="0"/>
+                <a:cs typeface="CMU Serif" panose="02000603000000000000" pitchFamily="2" charset="0"/>
+              </a:rPr>
+              <a:t>A</a:t>
+            </a:r>
+            <a:endParaRPr lang="de-DE" sz="1400" baseline="-25000" dirty="0">
+              <a:solidFill>
+                <a:schemeClr val="accent6">
+                  <a:lumMod val="50000"/>
+                </a:schemeClr>
+              </a:solidFill>
+              <a:latin typeface="CMU Serif" panose="02000603000000000000" pitchFamily="2" charset="0"/>
+              <a:ea typeface="CMU Serif" panose="02000603000000000000" pitchFamily="2" charset="0"/>
+              <a:cs typeface="CMU Serif" panose="02000603000000000000" pitchFamily="2" charset="0"/>
+            </a:endParaRPr>
+          </a:p>
+        </p:txBody>
+      </p:sp>
+      <p:cxnSp>
+        <p:nvCxnSpPr>
+          <p:cNvPr id="27" name="Gerader Verbinder 26">
+            <a:extLst>
+              <a:ext uri="{FF2B5EF4-FFF2-40B4-BE49-F238E27FC236}">
+                <a16:creationId xmlns:a16="http://schemas.microsoft.com/office/drawing/2014/main" id="{A774B7B9-51C0-4B15-77F1-B5F2BB02EA7F}"/>
+              </a:ext>
+            </a:extLst>
+          </p:cNvPr>
+          <p:cNvCxnSpPr>
+            <a:cxnSpLocks/>
+          </p:cNvCxnSpPr>
+          <p:nvPr/>
+        </p:nvCxnSpPr>
+        <p:spPr>
+          <a:xfrm flipH="1" flipV="1">
+            <a:off x="643276" y="2364639"/>
+            <a:ext cx="1730528" cy="261089"/>
+          </a:xfrm>
+          <a:prstGeom prst="line">
+            <a:avLst/>
+          </a:prstGeom>
+          <a:ln w="12700" cap="rnd">
+            <a:solidFill>
+              <a:schemeClr val="tx1"/>
+            </a:solidFill>
+            <a:round/>
+            <a:headEnd type="none" w="sm" len="med"/>
+            <a:tailEnd type="none" w="sm" len="med"/>
+          </a:ln>
+        </p:spPr>
+        <p:style>
+          <a:lnRef idx="2">
+            <a:schemeClr val="accent1"/>
+          </a:lnRef>
+          <a:fillRef idx="0">
+            <a:schemeClr val="accent1"/>
+          </a:fillRef>
+          <a:effectRef idx="1">
+            <a:schemeClr val="accent1"/>
+          </a:effectRef>
+          <a:fontRef idx="minor">
+            <a:schemeClr val="tx1"/>
+          </a:fontRef>
+        </p:style>
+      </p:cxnSp>
+      <p:cxnSp>
+        <p:nvCxnSpPr>
+          <p:cNvPr id="29" name="Gerader Verbinder 28">
+            <a:extLst>
+              <a:ext uri="{FF2B5EF4-FFF2-40B4-BE49-F238E27FC236}">
+                <a16:creationId xmlns:a16="http://schemas.microsoft.com/office/drawing/2014/main" id="{001D26D0-2D03-B832-C656-E9FDBF2F5358}"/>
+              </a:ext>
+            </a:extLst>
+          </p:cNvPr>
+          <p:cNvCxnSpPr>
+            <a:cxnSpLocks/>
+          </p:cNvCxnSpPr>
+          <p:nvPr/>
+        </p:nvCxnSpPr>
+        <p:spPr>
+          <a:xfrm flipH="1" flipV="1">
+            <a:off x="644616" y="1737583"/>
+            <a:ext cx="253903" cy="38307"/>
+          </a:xfrm>
+          <a:prstGeom prst="line">
+            <a:avLst/>
+          </a:prstGeom>
+          <a:ln w="12700" cap="rnd">
+            <a:solidFill>
+              <a:schemeClr val="tx1"/>
+            </a:solidFill>
+            <a:round/>
+            <a:headEnd type="none" w="sm" len="med"/>
+            <a:tailEnd type="none" w="sm" len="med"/>
+          </a:ln>
+        </p:spPr>
+        <p:style>
+          <a:lnRef idx="2">
+            <a:schemeClr val="accent1"/>
+          </a:lnRef>
+          <a:fillRef idx="0">
+            <a:schemeClr val="accent1"/>
+          </a:fillRef>
+          <a:effectRef idx="1">
+            <a:schemeClr val="accent1"/>
+          </a:effectRef>
+          <a:fontRef idx="minor">
+            <a:schemeClr val="tx1"/>
+          </a:fontRef>
+        </p:style>
+      </p:cxnSp>
+      <p:cxnSp>
+        <p:nvCxnSpPr>
+          <p:cNvPr id="30" name="Gerader Verbinder 29">
+            <a:extLst>
+              <a:ext uri="{FF2B5EF4-FFF2-40B4-BE49-F238E27FC236}">
+                <a16:creationId xmlns:a16="http://schemas.microsoft.com/office/drawing/2014/main" id="{E0281810-DD27-220C-5DAF-64BEF06A5BAC}"/>
+              </a:ext>
+            </a:extLst>
+          </p:cNvPr>
+          <p:cNvCxnSpPr>
+            <a:cxnSpLocks/>
+          </p:cNvCxnSpPr>
+          <p:nvPr/>
+        </p:nvCxnSpPr>
+        <p:spPr>
+          <a:xfrm>
+            <a:off x="683461" y="1742339"/>
+            <a:ext cx="0" cy="626110"/>
+          </a:xfrm>
+          <a:prstGeom prst="line">
+            <a:avLst/>
+          </a:prstGeom>
+          <a:ln w="12700" cap="rnd">
+            <a:solidFill>
+              <a:schemeClr val="tx1"/>
+            </a:solidFill>
+            <a:round/>
+            <a:headEnd type="triangle" w="sm" len="med"/>
+            <a:tailEnd type="triangle" w="sm" len="med"/>
+          </a:ln>
+        </p:spPr>
+        <p:style>
+          <a:lnRef idx="2">
+            <a:schemeClr val="accent1"/>
+          </a:lnRef>
+          <a:fillRef idx="0">
+            <a:schemeClr val="accent1"/>
+          </a:fillRef>
+          <a:effectRef idx="1">
+            <a:schemeClr val="accent1"/>
+          </a:effectRef>
+          <a:fontRef idx="minor">
+            <a:schemeClr val="tx1"/>
+          </a:fontRef>
+        </p:style>
+      </p:cxnSp>
+      <p:cxnSp>
+        <p:nvCxnSpPr>
+          <p:cNvPr id="38" name="Gerader Verbinder 37">
+            <a:extLst>
+              <a:ext uri="{FF2B5EF4-FFF2-40B4-BE49-F238E27FC236}">
+                <a16:creationId xmlns:a16="http://schemas.microsoft.com/office/drawing/2014/main" id="{21C9E3E7-9AE7-8BAB-D673-AA289A0BF627}"/>
+              </a:ext>
+            </a:extLst>
+          </p:cNvPr>
+          <p:cNvCxnSpPr>
+            <a:cxnSpLocks/>
+          </p:cNvCxnSpPr>
+          <p:nvPr/>
+        </p:nvCxnSpPr>
+        <p:spPr>
+          <a:xfrm flipH="1" flipV="1">
+            <a:off x="2743185" y="1819850"/>
+            <a:ext cx="553445" cy="83500"/>
+          </a:xfrm>
+          <a:prstGeom prst="line">
+            <a:avLst/>
+          </a:prstGeom>
+          <a:ln w="25400" cap="rnd">
+            <a:solidFill>
+              <a:srgbClr val="C00000"/>
+            </a:solidFill>
+            <a:round/>
+            <a:headEnd type="triangle" w="lg" len="lg"/>
+            <a:tailEnd type="none" w="sm" len="med"/>
+          </a:ln>
+        </p:spPr>
+        <p:style>
+          <a:lnRef idx="2">
+            <a:schemeClr val="accent1"/>
+          </a:lnRef>
+          <a:fillRef idx="0">
+            <a:schemeClr val="accent1"/>
+          </a:fillRef>
+          <a:effectRef idx="1">
+            <a:schemeClr val="accent1"/>
+          </a:effectRef>
+          <a:fontRef idx="minor">
+            <a:schemeClr val="tx1"/>
+          </a:fontRef>
+        </p:style>
+      </p:cxnSp>
+      <p:grpSp>
+        <p:nvGrpSpPr>
+          <p:cNvPr id="58" name="Gruppieren 57">
+            <a:extLst>
+              <a:ext uri="{FF2B5EF4-FFF2-40B4-BE49-F238E27FC236}">
+                <a16:creationId xmlns:a16="http://schemas.microsoft.com/office/drawing/2014/main" id="{08A1E4E0-A6EF-87C4-F7C2-C2B132350C0C}"/>
+              </a:ext>
+            </a:extLst>
+          </p:cNvPr>
+          <p:cNvGrpSpPr/>
+          <p:nvPr/>
+        </p:nvGrpSpPr>
+        <p:grpSpPr>
+          <a:xfrm>
+            <a:off x="2934387" y="1366412"/>
+            <a:ext cx="616419" cy="457149"/>
+            <a:chOff x="3066650" y="1392188"/>
+            <a:chExt cx="616419" cy="457149"/>
+          </a:xfrm>
+        </p:grpSpPr>
+        <p:sp>
+          <p:nvSpPr>
+            <p:cNvPr id="41" name="Textfeld 40">
+              <a:extLst>
+                <a:ext uri="{FF2B5EF4-FFF2-40B4-BE49-F238E27FC236}">
+                  <a16:creationId xmlns:a16="http://schemas.microsoft.com/office/drawing/2014/main" id="{365B5B80-3EE6-8469-65B6-4658D8B9ADDD}"/>
+                </a:ext>
+              </a:extLst>
+            </p:cNvPr>
+            <p:cNvSpPr txBox="1"/>
+            <p:nvPr/>
+          </p:nvSpPr>
+          <p:spPr>
+            <a:xfrm>
+              <a:off x="3066650" y="1541560"/>
+              <a:ext cx="582460" cy="307777"/>
+            </a:xfrm>
+            <a:prstGeom prst="rect">
+              <a:avLst/>
+            </a:prstGeom>
+            <a:noFill/>
+          </p:spPr>
+          <p:txBody>
+            <a:bodyPr wrap="square" rtlCol="0" anchor="ctr">
+              <a:spAutoFit/>
+            </a:bodyPr>
+            <a:lstStyle/>
+            <a:p>
+              <a:pPr algn="ctr"/>
+              <a:r>
+                <a:rPr lang="de-DE" sz="1400" i="1" dirty="0">
+                  <a:solidFill>
+                    <a:srgbClr val="C00000"/>
+                  </a:solidFill>
+                  <a:latin typeface="CMU Serif" panose="02000603000000000000" pitchFamily="2" charset="0"/>
+                  <a:ea typeface="CMU Serif" panose="02000603000000000000" pitchFamily="2" charset="0"/>
+                  <a:cs typeface="CMU Serif" panose="02000603000000000000" pitchFamily="2" charset="0"/>
+                </a:rPr>
+                <a:t>Q</a:t>
+              </a:r>
+              <a:endParaRPr lang="de-DE" sz="1400" dirty="0">
+                <a:solidFill>
+                  <a:srgbClr val="C00000"/>
+                </a:solidFill>
+                <a:latin typeface="CMU Serif" panose="02000603000000000000" pitchFamily="2" charset="0"/>
+                <a:ea typeface="CMU Serif" panose="02000603000000000000" pitchFamily="2" charset="0"/>
+                <a:cs typeface="CMU Serif" panose="02000603000000000000" pitchFamily="2" charset="0"/>
+              </a:endParaRPr>
+            </a:p>
+          </p:txBody>
+        </p:sp>
+        <p:sp>
+          <p:nvSpPr>
+            <p:cNvPr id="42" name="Textfeld 41">
+              <a:extLst>
+                <a:ext uri="{FF2B5EF4-FFF2-40B4-BE49-F238E27FC236}">
+                  <a16:creationId xmlns:a16="http://schemas.microsoft.com/office/drawing/2014/main" id="{68A2893C-C24D-2DCC-6B63-EAC7BEF1A23E}"/>
+                </a:ext>
+              </a:extLst>
+            </p:cNvPr>
+            <p:cNvSpPr txBox="1"/>
+            <p:nvPr/>
+          </p:nvSpPr>
+          <p:spPr>
+            <a:xfrm>
+              <a:off x="3100609" y="1392188"/>
+              <a:ext cx="582460" cy="307777"/>
+            </a:xfrm>
+            <a:prstGeom prst="rect">
+              <a:avLst/>
+            </a:prstGeom>
+            <a:noFill/>
+          </p:spPr>
+          <p:txBody>
+            <a:bodyPr wrap="square" rtlCol="0" anchor="ctr">
+              <a:spAutoFit/>
+            </a:bodyPr>
+            <a:lstStyle/>
+            <a:p>
+              <a:pPr algn="ctr"/>
+              <a:r>
+                <a:rPr lang="de-DE" sz="1400" dirty="0">
+                  <a:solidFill>
+                    <a:srgbClr val="C00000"/>
+                  </a:solidFill>
+                  <a:latin typeface="CMU Serif" panose="02000603000000000000" pitchFamily="2" charset="0"/>
+                  <a:ea typeface="CMU Serif" panose="02000603000000000000" pitchFamily="2" charset="0"/>
+                  <a:cs typeface="CMU Serif" panose="02000603000000000000" pitchFamily="2" charset="0"/>
+                </a:rPr>
+                <a:t>.</a:t>
+              </a:r>
+            </a:p>
+          </p:txBody>
+        </p:sp>
+      </p:grpSp>
+      <p:sp>
+        <p:nvSpPr>
+          <p:cNvPr id="48" name="Textfeld 47">
+            <a:extLst>
+              <a:ext uri="{FF2B5EF4-FFF2-40B4-BE49-F238E27FC236}">
+                <a16:creationId xmlns:a16="http://schemas.microsoft.com/office/drawing/2014/main" id="{1D668DC4-9DFD-9A55-B2ED-FF06B0D89725}"/>
+              </a:ext>
+            </a:extLst>
+          </p:cNvPr>
+          <p:cNvSpPr txBox="1"/>
+          <p:nvPr/>
+        </p:nvSpPr>
+        <p:spPr>
+          <a:xfrm>
+            <a:off x="-89420" y="1900871"/>
+            <a:ext cx="984679" cy="307777"/>
+          </a:xfrm>
+          <a:prstGeom prst="rect">
+            <a:avLst/>
+          </a:prstGeom>
+          <a:noFill/>
+        </p:spPr>
+        <p:txBody>
+          <a:bodyPr wrap="square" rtlCol="0" anchor="ctr">
+            <a:spAutoFit/>
+          </a:bodyPr>
+          <a:lstStyle/>
+          <a:p>
+            <a:pPr algn="ctr"/>
+            <a:r>
+              <a:rPr lang="de-DE" sz="1400" dirty="0" err="1">
+                <a:latin typeface="Latin Modern Math" panose="02000503000000000000" pitchFamily="50" charset="0"/>
+                <a:ea typeface="Latin Modern Math" panose="02000503000000000000" pitchFamily="50" charset="0"/>
+                <a:cs typeface="CMU Serif" panose="02000603000000000000" pitchFamily="2" charset="0"/>
+              </a:rPr>
+              <a:t>Δ</a:t>
+            </a:r>
+            <a:r>
+              <a:rPr lang="de-DE" sz="1400" i="1" dirty="0" err="1">
+                <a:latin typeface="CMU Serif" panose="02000603000000000000" pitchFamily="2" charset="0"/>
+                <a:ea typeface="CMU Serif" panose="02000603000000000000" pitchFamily="2" charset="0"/>
+                <a:cs typeface="CMU Serif" panose="02000603000000000000" pitchFamily="2" charset="0"/>
+              </a:rPr>
+              <a:t>T</a:t>
+            </a:r>
+            <a:r>
+              <a:rPr lang="de-DE" sz="1400" baseline="-25000" dirty="0" err="1">
+                <a:latin typeface="CMU Serif" panose="02000603000000000000" pitchFamily="2" charset="0"/>
+                <a:ea typeface="CMU Serif" panose="02000603000000000000" pitchFamily="2" charset="0"/>
+                <a:cs typeface="CMU Serif" panose="02000603000000000000" pitchFamily="2" charset="0"/>
+              </a:rPr>
+              <a:t>ges</a:t>
+            </a:r>
+            <a:endParaRPr lang="de-DE" sz="1400" baseline="-25000" dirty="0">
+              <a:latin typeface="CMU Serif" panose="02000603000000000000" pitchFamily="2" charset="0"/>
+              <a:ea typeface="CMU Serif" panose="02000603000000000000" pitchFamily="2" charset="0"/>
+              <a:cs typeface="CMU Serif" panose="02000603000000000000" pitchFamily="2" charset="0"/>
+            </a:endParaRPr>
+          </a:p>
+        </p:txBody>
+      </p:sp>
+      <p:sp>
+        <p:nvSpPr>
+          <p:cNvPr id="49" name="Textfeld 48">
+            <a:extLst>
+              <a:ext uri="{FF2B5EF4-FFF2-40B4-BE49-F238E27FC236}">
+                <a16:creationId xmlns:a16="http://schemas.microsoft.com/office/drawing/2014/main" id="{950196FA-5767-6E8A-6328-05420E91C2AE}"/>
+              </a:ext>
+            </a:extLst>
+          </p:cNvPr>
+          <p:cNvSpPr txBox="1"/>
+          <p:nvPr/>
+        </p:nvSpPr>
+        <p:spPr>
+          <a:xfrm>
+            <a:off x="821056" y="1543059"/>
+            <a:ext cx="386480" cy="307777"/>
+          </a:xfrm>
+          <a:prstGeom prst="rect">
+            <a:avLst/>
+          </a:prstGeom>
+          <a:noFill/>
+        </p:spPr>
+        <p:txBody>
+          <a:bodyPr wrap="square" rtlCol="0" anchor="ctr">
+            <a:spAutoFit/>
+          </a:bodyPr>
+          <a:lstStyle/>
+          <a:p>
+            <a:pPr algn="ctr"/>
+            <a:r>
+              <a:rPr lang="de-DE" sz="1400" i="1" dirty="0">
+                <a:latin typeface="CMU Serif" panose="02000603000000000000" pitchFamily="2" charset="0"/>
+                <a:ea typeface="CMU Serif" panose="02000603000000000000" pitchFamily="2" charset="0"/>
+                <a:cs typeface="CMU Serif" panose="02000603000000000000" pitchFamily="2" charset="0"/>
+              </a:rPr>
+              <a:t>T</a:t>
+            </a:r>
+            <a:r>
+              <a:rPr lang="de-DE" sz="1400" baseline="-25000" dirty="0">
+                <a:latin typeface="CMU Serif" panose="02000603000000000000" pitchFamily="2" charset="0"/>
+                <a:ea typeface="CMU Serif" panose="02000603000000000000" pitchFamily="2" charset="0"/>
+                <a:cs typeface="CMU Serif" panose="02000603000000000000" pitchFamily="2" charset="0"/>
+              </a:rPr>
+              <a:t>1</a:t>
+            </a:r>
+          </a:p>
+        </p:txBody>
+      </p:sp>
+      <p:cxnSp>
+        <p:nvCxnSpPr>
+          <p:cNvPr id="50" name="Gerader Verbinder 49">
+            <a:extLst>
+              <a:ext uri="{FF2B5EF4-FFF2-40B4-BE49-F238E27FC236}">
+                <a16:creationId xmlns:a16="http://schemas.microsoft.com/office/drawing/2014/main" id="{84335923-80FA-FE9D-6195-95DAAB2B9B1F}"/>
+              </a:ext>
+            </a:extLst>
+          </p:cNvPr>
+          <p:cNvCxnSpPr>
+            <a:cxnSpLocks/>
+          </p:cNvCxnSpPr>
+          <p:nvPr/>
+        </p:nvCxnSpPr>
+        <p:spPr>
+          <a:xfrm flipH="1" flipV="1">
+            <a:off x="902970" y="1779270"/>
+            <a:ext cx="394335" cy="270510"/>
+          </a:xfrm>
+          <a:prstGeom prst="line">
+            <a:avLst/>
+          </a:prstGeom>
+          <a:ln w="12700" cap="rnd">
+            <a:solidFill>
+              <a:schemeClr val="tx1"/>
+            </a:solidFill>
+            <a:round/>
+            <a:headEnd type="none" w="sm" len="med"/>
+            <a:tailEnd type="none" w="sm" len="med"/>
+          </a:ln>
+        </p:spPr>
+        <p:style>
+          <a:lnRef idx="2">
+            <a:schemeClr val="accent1"/>
+          </a:lnRef>
+          <a:fillRef idx="0">
+            <a:schemeClr val="accent1"/>
+          </a:fillRef>
+          <a:effectRef idx="1">
+            <a:schemeClr val="accent1"/>
+          </a:effectRef>
+          <a:fontRef idx="minor">
+            <a:schemeClr val="tx1"/>
+          </a:fontRef>
+        </p:style>
+      </p:cxnSp>
+      <p:cxnSp>
+        <p:nvCxnSpPr>
+          <p:cNvPr id="52" name="Gerader Verbinder 51">
+            <a:extLst>
+              <a:ext uri="{FF2B5EF4-FFF2-40B4-BE49-F238E27FC236}">
+                <a16:creationId xmlns:a16="http://schemas.microsoft.com/office/drawing/2014/main" id="{0FA7C418-FC7F-7408-ECE4-F5C0928B4377}"/>
+              </a:ext>
+            </a:extLst>
+          </p:cNvPr>
+          <p:cNvCxnSpPr>
+            <a:cxnSpLocks/>
+          </p:cNvCxnSpPr>
+          <p:nvPr/>
+        </p:nvCxnSpPr>
+        <p:spPr>
+          <a:xfrm flipH="1" flipV="1">
+            <a:off x="1299210" y="2047875"/>
+            <a:ext cx="689610" cy="285750"/>
+          </a:xfrm>
+          <a:prstGeom prst="line">
+            <a:avLst/>
+          </a:prstGeom>
+          <a:ln w="12700" cap="rnd">
+            <a:solidFill>
+              <a:schemeClr val="tx1"/>
+            </a:solidFill>
+            <a:round/>
+            <a:headEnd type="none" w="sm" len="med"/>
+            <a:tailEnd type="none" w="sm" len="med"/>
+          </a:ln>
+        </p:spPr>
+        <p:style>
+          <a:lnRef idx="2">
+            <a:schemeClr val="accent1"/>
+          </a:lnRef>
+          <a:fillRef idx="0">
+            <a:schemeClr val="accent1"/>
+          </a:fillRef>
+          <a:effectRef idx="1">
+            <a:schemeClr val="accent1"/>
+          </a:effectRef>
+          <a:fontRef idx="minor">
+            <a:schemeClr val="tx1"/>
+          </a:fontRef>
+        </p:style>
+      </p:cxnSp>
+      <p:cxnSp>
+        <p:nvCxnSpPr>
+          <p:cNvPr id="54" name="Gerader Verbinder 53">
+            <a:extLst>
+              <a:ext uri="{FF2B5EF4-FFF2-40B4-BE49-F238E27FC236}">
+                <a16:creationId xmlns:a16="http://schemas.microsoft.com/office/drawing/2014/main" id="{A2DB5E5F-AAC0-7C8F-FC63-749A0546CCD2}"/>
+              </a:ext>
+            </a:extLst>
+          </p:cNvPr>
+          <p:cNvCxnSpPr>
+            <a:cxnSpLocks/>
+          </p:cNvCxnSpPr>
+          <p:nvPr/>
+        </p:nvCxnSpPr>
+        <p:spPr>
+          <a:xfrm flipH="1" flipV="1">
+            <a:off x="1986915" y="2333625"/>
+            <a:ext cx="400050" cy="289560"/>
+          </a:xfrm>
+          <a:prstGeom prst="line">
+            <a:avLst/>
+          </a:prstGeom>
+          <a:ln w="12700" cap="rnd">
+            <a:solidFill>
+              <a:schemeClr val="tx1"/>
+            </a:solidFill>
+            <a:round/>
+            <a:headEnd type="none" w="sm" len="med"/>
+            <a:tailEnd type="none" w="sm" len="med"/>
+          </a:ln>
+        </p:spPr>
+        <p:style>
+          <a:lnRef idx="2">
+            <a:schemeClr val="accent1"/>
+          </a:lnRef>
+          <a:fillRef idx="0">
+            <a:schemeClr val="accent1"/>
+          </a:fillRef>
+          <a:effectRef idx="1">
+            <a:schemeClr val="accent1"/>
+          </a:effectRef>
+          <a:fontRef idx="minor">
+            <a:schemeClr val="tx1"/>
+          </a:fontRef>
+        </p:style>
+      </p:cxnSp>
+      <p:sp>
+        <p:nvSpPr>
+          <p:cNvPr id="60" name="Ellipse 59">
+            <a:extLst>
+              <a:ext uri="{FF2B5EF4-FFF2-40B4-BE49-F238E27FC236}">
+                <a16:creationId xmlns:a16="http://schemas.microsoft.com/office/drawing/2014/main" id="{4FA2E2AE-C99A-5DAB-8B2D-236B97740638}"/>
+              </a:ext>
+            </a:extLst>
+          </p:cNvPr>
+          <p:cNvSpPr/>
+          <p:nvPr/>
+        </p:nvSpPr>
+        <p:spPr>
+          <a:xfrm>
+            <a:off x="868280" y="1746149"/>
+            <a:ext cx="68803" cy="68803"/>
+          </a:xfrm>
+          <a:prstGeom prst="ellipse">
+            <a:avLst/>
+          </a:prstGeom>
+          <a:solidFill>
+            <a:schemeClr val="tx1"/>
+          </a:solidFill>
+          <a:ln>
+            <a:noFill/>
+          </a:ln>
+        </p:spPr>
+        <p:style>
+          <a:lnRef idx="2">
+            <a:schemeClr val="accent1">
+              <a:shade val="15000"/>
+            </a:schemeClr>
+          </a:lnRef>
+          <a:fillRef idx="1">
+            <a:schemeClr val="accent1"/>
+          </a:fillRef>
+          <a:effectRef idx="0">
+            <a:schemeClr val="accent1"/>
+          </a:effectRef>
+          <a:fontRef idx="minor">
+            <a:schemeClr val="lt1"/>
+          </a:fontRef>
+        </p:style>
+        <p:txBody>
+          <a:bodyPr rtlCol="0" anchor="ctr"/>
+          <a:lstStyle/>
+          <a:p>
+            <a:pPr algn="ctr"/>
+            <a:endParaRPr lang="de-DE"/>
+          </a:p>
+        </p:txBody>
+      </p:sp>
+      <p:sp>
+        <p:nvSpPr>
+          <p:cNvPr id="61" name="Ellipse 60">
+            <a:extLst>
+              <a:ext uri="{FF2B5EF4-FFF2-40B4-BE49-F238E27FC236}">
+                <a16:creationId xmlns:a16="http://schemas.microsoft.com/office/drawing/2014/main" id="{267E79CD-CCA5-C621-7E17-260F829E394D}"/>
+              </a:ext>
+            </a:extLst>
+          </p:cNvPr>
+          <p:cNvSpPr/>
+          <p:nvPr/>
+        </p:nvSpPr>
+        <p:spPr>
+          <a:xfrm>
+            <a:off x="1263323" y="2015708"/>
+            <a:ext cx="68803" cy="68803"/>
+          </a:xfrm>
+          <a:prstGeom prst="ellipse">
+            <a:avLst/>
+          </a:prstGeom>
+          <a:solidFill>
+            <a:schemeClr val="tx1"/>
+          </a:solidFill>
+          <a:ln>
+            <a:noFill/>
+          </a:ln>
+        </p:spPr>
+        <p:style>
+          <a:lnRef idx="2">
+            <a:schemeClr val="accent1">
+              <a:shade val="15000"/>
+            </a:schemeClr>
+          </a:lnRef>
+          <a:fillRef idx="1">
+            <a:schemeClr val="accent1"/>
+          </a:fillRef>
+          <a:effectRef idx="0">
+            <a:schemeClr val="accent1"/>
+          </a:effectRef>
+          <a:fontRef idx="minor">
+            <a:schemeClr val="lt1"/>
+          </a:fontRef>
+        </p:style>
+        <p:txBody>
+          <a:bodyPr rtlCol="0" anchor="ctr"/>
+          <a:lstStyle/>
+          <a:p>
+            <a:pPr algn="ctr"/>
+            <a:endParaRPr lang="de-DE"/>
+          </a:p>
+        </p:txBody>
+      </p:sp>
+      <p:sp>
+        <p:nvSpPr>
+          <p:cNvPr id="62" name="Ellipse 61">
+            <a:extLst>
+              <a:ext uri="{FF2B5EF4-FFF2-40B4-BE49-F238E27FC236}">
+                <a16:creationId xmlns:a16="http://schemas.microsoft.com/office/drawing/2014/main" id="{3E90ED9D-0334-7239-72A4-54A1500667C0}"/>
+              </a:ext>
+            </a:extLst>
+          </p:cNvPr>
+          <p:cNvSpPr/>
+          <p:nvPr/>
+        </p:nvSpPr>
+        <p:spPr>
+          <a:xfrm>
+            <a:off x="1954748" y="2299996"/>
+            <a:ext cx="68803" cy="68803"/>
+          </a:xfrm>
+          <a:prstGeom prst="ellipse">
+            <a:avLst/>
+          </a:prstGeom>
+          <a:solidFill>
+            <a:schemeClr val="tx1"/>
+          </a:solidFill>
+          <a:ln>
+            <a:noFill/>
+          </a:ln>
+        </p:spPr>
+        <p:style>
+          <a:lnRef idx="2">
+            <a:schemeClr val="accent1">
+              <a:shade val="15000"/>
+            </a:schemeClr>
+          </a:lnRef>
+          <a:fillRef idx="1">
+            <a:schemeClr val="accent1"/>
+          </a:fillRef>
+          <a:effectRef idx="0">
+            <a:schemeClr val="accent1"/>
+          </a:effectRef>
+          <a:fontRef idx="minor">
+            <a:schemeClr val="lt1"/>
+          </a:fontRef>
+        </p:style>
+        <p:txBody>
+          <a:bodyPr rtlCol="0" anchor="ctr"/>
+          <a:lstStyle/>
+          <a:p>
+            <a:pPr algn="ctr"/>
+            <a:endParaRPr lang="de-DE"/>
+          </a:p>
+        </p:txBody>
+      </p:sp>
+      <p:sp>
+        <p:nvSpPr>
+          <p:cNvPr id="63" name="Ellipse 62">
+            <a:extLst>
+              <a:ext uri="{FF2B5EF4-FFF2-40B4-BE49-F238E27FC236}">
+                <a16:creationId xmlns:a16="http://schemas.microsoft.com/office/drawing/2014/main" id="{0939467D-AEC9-AC58-D5A9-1EDDBCD0C181}"/>
+              </a:ext>
+            </a:extLst>
+          </p:cNvPr>
+          <p:cNvSpPr/>
+          <p:nvPr/>
+        </p:nvSpPr>
+        <p:spPr>
+          <a:xfrm>
+            <a:off x="2351447" y="2590636"/>
+            <a:ext cx="68803" cy="68803"/>
+          </a:xfrm>
+          <a:prstGeom prst="ellipse">
+            <a:avLst/>
+          </a:prstGeom>
+          <a:solidFill>
+            <a:schemeClr val="tx1"/>
+          </a:solidFill>
+          <a:ln>
+            <a:noFill/>
+          </a:ln>
+        </p:spPr>
+        <p:style>
+          <a:lnRef idx="2">
+            <a:schemeClr val="accent1">
+              <a:shade val="15000"/>
+            </a:schemeClr>
+          </a:lnRef>
+          <a:fillRef idx="1">
+            <a:schemeClr val="accent1"/>
+          </a:fillRef>
+          <a:effectRef idx="0">
+            <a:schemeClr val="accent1"/>
+          </a:effectRef>
+          <a:fontRef idx="minor">
+            <a:schemeClr val="lt1"/>
+          </a:fontRef>
+        </p:style>
+        <p:txBody>
+          <a:bodyPr rtlCol="0" anchor="ctr"/>
+          <a:lstStyle/>
+          <a:p>
+            <a:pPr algn="ctr"/>
+            <a:endParaRPr lang="de-DE"/>
+          </a:p>
+        </p:txBody>
+      </p:sp>
+      <p:sp>
+        <p:nvSpPr>
+          <p:cNvPr id="64" name="Textfeld 63">
+            <a:extLst>
+              <a:ext uri="{FF2B5EF4-FFF2-40B4-BE49-F238E27FC236}">
+                <a16:creationId xmlns:a16="http://schemas.microsoft.com/office/drawing/2014/main" id="{BA29675E-6ED1-0F97-3FB6-9D112FCA11DA}"/>
+              </a:ext>
+            </a:extLst>
+          </p:cNvPr>
+          <p:cNvSpPr txBox="1"/>
+          <p:nvPr/>
+        </p:nvSpPr>
+        <p:spPr>
+          <a:xfrm>
+            <a:off x="1222619" y="1807215"/>
+            <a:ext cx="391632" cy="307777"/>
+          </a:xfrm>
+          <a:prstGeom prst="rect">
+            <a:avLst/>
+          </a:prstGeom>
+          <a:noFill/>
+        </p:spPr>
+        <p:txBody>
+          <a:bodyPr wrap="square" rtlCol="0" anchor="ctr">
+            <a:spAutoFit/>
+          </a:bodyPr>
+          <a:lstStyle/>
+          <a:p>
+            <a:pPr algn="ctr"/>
+            <a:r>
+              <a:rPr lang="de-DE" sz="1400" i="1" dirty="0">
+                <a:latin typeface="CMU Serif" panose="02000603000000000000" pitchFamily="2" charset="0"/>
+                <a:ea typeface="CMU Serif" panose="02000603000000000000" pitchFamily="2" charset="0"/>
+                <a:cs typeface="CMU Serif" panose="02000603000000000000" pitchFamily="2" charset="0"/>
+              </a:rPr>
+              <a:t>T</a:t>
+            </a:r>
+            <a:r>
+              <a:rPr lang="de-DE" sz="1400" baseline="-25000" dirty="0">
+                <a:latin typeface="CMU Serif" panose="02000603000000000000" pitchFamily="2" charset="0"/>
+                <a:ea typeface="CMU Serif" panose="02000603000000000000" pitchFamily="2" charset="0"/>
+                <a:cs typeface="CMU Serif" panose="02000603000000000000" pitchFamily="2" charset="0"/>
+              </a:rPr>
+              <a:t>2</a:t>
+            </a:r>
+          </a:p>
+        </p:txBody>
+      </p:sp>
+      <p:sp>
+        <p:nvSpPr>
+          <p:cNvPr id="65" name="Textfeld 64">
+            <a:extLst>
+              <a:ext uri="{FF2B5EF4-FFF2-40B4-BE49-F238E27FC236}">
+                <a16:creationId xmlns:a16="http://schemas.microsoft.com/office/drawing/2014/main" id="{A24E35AC-3F3A-0269-66A3-13120EF1E328}"/>
+              </a:ext>
+            </a:extLst>
+          </p:cNvPr>
+          <p:cNvSpPr txBox="1"/>
+          <p:nvPr/>
+        </p:nvSpPr>
+        <p:spPr>
+          <a:xfrm>
+            <a:off x="1658470" y="2002727"/>
+            <a:ext cx="377904" cy="307777"/>
+          </a:xfrm>
+          <a:prstGeom prst="rect">
+            <a:avLst/>
+          </a:prstGeom>
+          <a:noFill/>
+        </p:spPr>
+        <p:txBody>
+          <a:bodyPr wrap="square" rtlCol="0" anchor="ctr">
+            <a:spAutoFit/>
+          </a:bodyPr>
+          <a:lstStyle/>
+          <a:p>
+            <a:pPr algn="ctr"/>
+            <a:r>
+              <a:rPr lang="de-DE" sz="1400" i="1" dirty="0">
+                <a:latin typeface="CMU Serif" panose="02000603000000000000" pitchFamily="2" charset="0"/>
+                <a:ea typeface="CMU Serif" panose="02000603000000000000" pitchFamily="2" charset="0"/>
+                <a:cs typeface="CMU Serif" panose="02000603000000000000" pitchFamily="2" charset="0"/>
+              </a:rPr>
+              <a:t>T</a:t>
+            </a:r>
+            <a:r>
+              <a:rPr lang="de-DE" sz="1400" baseline="-25000" dirty="0">
+                <a:latin typeface="CMU Serif" panose="02000603000000000000" pitchFamily="2" charset="0"/>
+                <a:ea typeface="CMU Serif" panose="02000603000000000000" pitchFamily="2" charset="0"/>
+                <a:cs typeface="CMU Serif" panose="02000603000000000000" pitchFamily="2" charset="0"/>
+              </a:rPr>
+              <a:t>3</a:t>
+            </a:r>
+          </a:p>
+        </p:txBody>
+      </p:sp>
+      <p:sp>
+        <p:nvSpPr>
+          <p:cNvPr id="66" name="Textfeld 65">
+            <a:extLst>
+              <a:ext uri="{FF2B5EF4-FFF2-40B4-BE49-F238E27FC236}">
+                <a16:creationId xmlns:a16="http://schemas.microsoft.com/office/drawing/2014/main" id="{5D0A79CB-F1E1-4A87-E368-59480389E581}"/>
+              </a:ext>
+            </a:extLst>
+          </p:cNvPr>
+          <p:cNvSpPr txBox="1"/>
+          <p:nvPr/>
+        </p:nvSpPr>
+        <p:spPr>
+          <a:xfrm>
+            <a:off x="2064035" y="2231697"/>
+            <a:ext cx="376264" cy="307777"/>
+          </a:xfrm>
+          <a:prstGeom prst="rect">
+            <a:avLst/>
+          </a:prstGeom>
+          <a:noFill/>
+        </p:spPr>
+        <p:txBody>
+          <a:bodyPr wrap="square" rtlCol="0" anchor="ctr">
+            <a:spAutoFit/>
+          </a:bodyPr>
+          <a:lstStyle/>
+          <a:p>
+            <a:pPr algn="ctr"/>
+            <a:r>
+              <a:rPr lang="de-DE" sz="1400" i="1" dirty="0">
+                <a:latin typeface="CMU Serif" panose="02000603000000000000" pitchFamily="2" charset="0"/>
+                <a:ea typeface="CMU Serif" panose="02000603000000000000" pitchFamily="2" charset="0"/>
+                <a:cs typeface="CMU Serif" panose="02000603000000000000" pitchFamily="2" charset="0"/>
+              </a:rPr>
+              <a:t>T</a:t>
+            </a:r>
+            <a:r>
+              <a:rPr lang="de-DE" sz="1400" baseline="-25000" dirty="0">
+                <a:latin typeface="CMU Serif" panose="02000603000000000000" pitchFamily="2" charset="0"/>
+                <a:ea typeface="CMU Serif" panose="02000603000000000000" pitchFamily="2" charset="0"/>
+                <a:cs typeface="CMU Serif" panose="02000603000000000000" pitchFamily="2" charset="0"/>
+              </a:rPr>
+              <a:t>4</a:t>
+            </a:r>
+          </a:p>
+        </p:txBody>
+      </p:sp>
+      <p:sp>
+        <p:nvSpPr>
+          <p:cNvPr id="68" name="Textfeld 67">
+            <a:extLst>
+              <a:ext uri="{FF2B5EF4-FFF2-40B4-BE49-F238E27FC236}">
+                <a16:creationId xmlns:a16="http://schemas.microsoft.com/office/drawing/2014/main" id="{E5B2F927-9CC4-5CD4-0CF5-87790FF9898F}"/>
+              </a:ext>
+            </a:extLst>
+          </p:cNvPr>
+          <p:cNvSpPr txBox="1"/>
+          <p:nvPr/>
+        </p:nvSpPr>
+        <p:spPr>
+          <a:xfrm>
+            <a:off x="908645" y="1117042"/>
+            <a:ext cx="369564" cy="307777"/>
+          </a:xfrm>
+          <a:prstGeom prst="rect">
+            <a:avLst/>
+          </a:prstGeom>
+          <a:noFill/>
+        </p:spPr>
+        <p:txBody>
+          <a:bodyPr wrap="square" rtlCol="0" anchor="ctr">
+            <a:spAutoFit/>
+          </a:bodyPr>
+          <a:lstStyle/>
+          <a:p>
+            <a:pPr algn="ctr"/>
+            <a:r>
+              <a:rPr lang="de-DE" sz="1400" i="1" dirty="0">
+                <a:solidFill>
+                  <a:schemeClr val="tx2"/>
+                </a:solidFill>
+                <a:latin typeface="Latin Modern Math" panose="02000503000000000000" pitchFamily="50" charset="0"/>
+                <a:ea typeface="Latin Modern Math" panose="02000503000000000000" pitchFamily="50" charset="0"/>
+                <a:cs typeface="CMU Serif" panose="02000603000000000000" pitchFamily="2" charset="0"/>
+              </a:rPr>
+              <a:t>λ</a:t>
+            </a:r>
+            <a:r>
+              <a:rPr lang="de-DE" sz="1400" baseline="-25000" dirty="0">
+                <a:solidFill>
+                  <a:schemeClr val="tx2"/>
+                </a:solidFill>
+                <a:latin typeface="CMU Serif" panose="02000603000000000000" pitchFamily="2" charset="0"/>
+                <a:ea typeface="CMU Serif" panose="02000603000000000000" pitchFamily="2" charset="0"/>
+                <a:cs typeface="CMU Serif" panose="02000603000000000000" pitchFamily="2" charset="0"/>
+              </a:rPr>
+              <a:t>1</a:t>
+            </a:r>
+          </a:p>
+        </p:txBody>
+      </p:sp>
+      <p:sp>
+        <p:nvSpPr>
+          <p:cNvPr id="69" name="Textfeld 68">
+            <a:extLst>
+              <a:ext uri="{FF2B5EF4-FFF2-40B4-BE49-F238E27FC236}">
+                <a16:creationId xmlns:a16="http://schemas.microsoft.com/office/drawing/2014/main" id="{6792AD19-9AC5-60B3-5A4A-8C90BB0D967E}"/>
+              </a:ext>
+            </a:extLst>
+          </p:cNvPr>
+          <p:cNvSpPr txBox="1"/>
+          <p:nvPr/>
+        </p:nvSpPr>
+        <p:spPr>
+          <a:xfrm>
+            <a:off x="1459233" y="1205036"/>
+            <a:ext cx="369564" cy="307777"/>
+          </a:xfrm>
+          <a:prstGeom prst="rect">
+            <a:avLst/>
+          </a:prstGeom>
+          <a:noFill/>
+        </p:spPr>
+        <p:txBody>
+          <a:bodyPr wrap="square" rtlCol="0" anchor="ctr">
+            <a:spAutoFit/>
+          </a:bodyPr>
+          <a:lstStyle/>
+          <a:p>
+            <a:pPr algn="ctr"/>
+            <a:r>
+              <a:rPr lang="de-DE" sz="1400" i="1" dirty="0">
+                <a:solidFill>
+                  <a:schemeClr val="accent2">
+                    <a:lumMod val="50000"/>
+                  </a:schemeClr>
+                </a:solidFill>
+                <a:latin typeface="Latin Modern Math" panose="02000503000000000000" pitchFamily="50" charset="0"/>
+                <a:ea typeface="Latin Modern Math" panose="02000503000000000000" pitchFamily="50" charset="0"/>
+                <a:cs typeface="CMU Serif" panose="02000603000000000000" pitchFamily="2" charset="0"/>
+              </a:rPr>
+              <a:t>λ</a:t>
+            </a:r>
+            <a:r>
+              <a:rPr lang="de-DE" sz="1400" baseline="-25000" dirty="0">
+                <a:solidFill>
+                  <a:schemeClr val="accent2">
+                    <a:lumMod val="50000"/>
+                  </a:schemeClr>
+                </a:solidFill>
+                <a:latin typeface="CMU Serif" panose="02000603000000000000" pitchFamily="2" charset="0"/>
+                <a:ea typeface="CMU Serif" panose="02000603000000000000" pitchFamily="2" charset="0"/>
+                <a:cs typeface="CMU Serif" panose="02000603000000000000" pitchFamily="2" charset="0"/>
+              </a:rPr>
+              <a:t>2</a:t>
+            </a:r>
+          </a:p>
+        </p:txBody>
+      </p:sp>
+      <p:sp>
+        <p:nvSpPr>
+          <p:cNvPr id="70" name="Textfeld 69">
+            <a:extLst>
+              <a:ext uri="{FF2B5EF4-FFF2-40B4-BE49-F238E27FC236}">
+                <a16:creationId xmlns:a16="http://schemas.microsoft.com/office/drawing/2014/main" id="{E5E0C786-34D1-D3C7-42BD-D7A7463C0A42}"/>
+              </a:ext>
+            </a:extLst>
+          </p:cNvPr>
+          <p:cNvSpPr txBox="1"/>
+          <p:nvPr/>
+        </p:nvSpPr>
+        <p:spPr>
+          <a:xfrm>
+            <a:off x="2007983" y="1291181"/>
+            <a:ext cx="369564" cy="307777"/>
+          </a:xfrm>
+          <a:prstGeom prst="rect">
+            <a:avLst/>
+          </a:prstGeom>
+          <a:noFill/>
+        </p:spPr>
+        <p:txBody>
+          <a:bodyPr wrap="square" rtlCol="0" anchor="ctr">
+            <a:spAutoFit/>
+          </a:bodyPr>
+          <a:lstStyle/>
+          <a:p>
+            <a:pPr algn="ctr"/>
+            <a:r>
+              <a:rPr lang="de-DE" sz="1400" i="1" dirty="0">
+                <a:solidFill>
+                  <a:schemeClr val="accent6">
+                    <a:lumMod val="50000"/>
+                  </a:schemeClr>
+                </a:solidFill>
+                <a:latin typeface="Latin Modern Math" panose="02000503000000000000" pitchFamily="50" charset="0"/>
+                <a:ea typeface="Latin Modern Math" panose="02000503000000000000" pitchFamily="50" charset="0"/>
+                <a:cs typeface="CMU Serif" panose="02000603000000000000" pitchFamily="2" charset="0"/>
+              </a:rPr>
+              <a:t>λ</a:t>
+            </a:r>
+            <a:r>
+              <a:rPr lang="de-DE" sz="1400" baseline="-25000" dirty="0">
+                <a:solidFill>
+                  <a:schemeClr val="accent6">
+                    <a:lumMod val="50000"/>
+                  </a:schemeClr>
+                </a:solidFill>
+                <a:latin typeface="CMU Serif" panose="02000603000000000000" pitchFamily="2" charset="0"/>
+                <a:ea typeface="CMU Serif" panose="02000603000000000000" pitchFamily="2" charset="0"/>
+                <a:cs typeface="CMU Serif" panose="02000603000000000000" pitchFamily="2" charset="0"/>
+              </a:rPr>
+              <a:t>3</a:t>
+            </a:r>
+          </a:p>
+        </p:txBody>
+      </p:sp>
+    </p:spTree>
+    <p:extLst>
+      <p:ext uri="{BB962C8B-B14F-4D97-AF65-F5344CB8AC3E}">
+        <p14:creationId xmlns:p14="http://schemas.microsoft.com/office/powerpoint/2010/main" val="3736193757"/>
+      </p:ext>
+    </p:extLst>
+  </p:cSld>
+  <p:clrMapOvr>
+    <a:masterClrMapping/>
+  </p:clrMapOvr>
+</p:sld>
+</file>
+
+<file path=ppt/slides/slide4.xml><?xml version="1.0" encoding="utf-8"?>
+<p:sld xmlns:a="http://schemas.openxmlformats.org/drawingml/2006/main" xmlns:r="http://schemas.openxmlformats.org/officeDocument/2006/relationships" xmlns:p="http://schemas.openxmlformats.org/presentationml/2006/main">
+  <p:cSld>
+    <p:spTree>
+      <p:nvGrpSpPr>
+        <p:cNvPr id="1" name="">
+          <a:extLst>
+            <a:ext uri="{FF2B5EF4-FFF2-40B4-BE49-F238E27FC236}">
+              <a16:creationId xmlns:a16="http://schemas.microsoft.com/office/drawing/2014/main" id="{BB307E45-6C70-E83E-8589-55ACF1F9DF5C}"/>
+            </a:ext>
+          </a:extLst>
+        </p:cNvPr>
+        <p:cNvGrpSpPr/>
+        <p:nvPr/>
+      </p:nvGrpSpPr>
+      <p:grpSpPr>
+        <a:xfrm>
+          <a:off x="0" y="0"/>
+          <a:ext cx="0" cy="0"/>
+          <a:chOff x="0" y="0"/>
+          <a:chExt cx="0" cy="0"/>
+        </a:xfrm>
+      </p:grpSpPr>
+      <p:cxnSp>
+        <p:nvCxnSpPr>
+          <p:cNvPr id="57" name="Gerader Verbinder 56">
+            <a:extLst>
+              <a:ext uri="{FF2B5EF4-FFF2-40B4-BE49-F238E27FC236}">
+                <a16:creationId xmlns:a16="http://schemas.microsoft.com/office/drawing/2014/main" id="{AC86488C-5FC4-E403-D574-1E0AED2CDF01}"/>
+              </a:ext>
+            </a:extLst>
+          </p:cNvPr>
+          <p:cNvCxnSpPr>
+            <a:cxnSpLocks/>
+          </p:cNvCxnSpPr>
+          <p:nvPr/>
+        </p:nvCxnSpPr>
+        <p:spPr>
+          <a:xfrm flipV="1">
+            <a:off x="2621814" y="2157218"/>
+            <a:ext cx="0" cy="296944"/>
+          </a:xfrm>
+          <a:prstGeom prst="line">
+            <a:avLst/>
+          </a:prstGeom>
+          <a:ln w="12700" cap="rnd">
+            <a:solidFill>
+              <a:schemeClr val="tx1"/>
+            </a:solidFill>
+            <a:round/>
+          </a:ln>
+        </p:spPr>
+        <p:style>
+          <a:lnRef idx="2">
+            <a:schemeClr val="accent1"/>
+          </a:lnRef>
+          <a:fillRef idx="0">
+            <a:schemeClr val="accent1"/>
+          </a:fillRef>
+          <a:effectRef idx="1">
+            <a:schemeClr val="accent1"/>
+          </a:effectRef>
+          <a:fontRef idx="minor">
+            <a:schemeClr val="tx1"/>
+          </a:fontRef>
+        </p:style>
+      </p:cxnSp>
+      <p:cxnSp>
+        <p:nvCxnSpPr>
+          <p:cNvPr id="43" name="Gerader Verbinder 42">
+            <a:extLst>
+              <a:ext uri="{FF2B5EF4-FFF2-40B4-BE49-F238E27FC236}">
+                <a16:creationId xmlns:a16="http://schemas.microsoft.com/office/drawing/2014/main" id="{34F500AD-ADF2-7201-6988-8EF32848DF01}"/>
+              </a:ext>
+            </a:extLst>
+          </p:cNvPr>
+          <p:cNvCxnSpPr>
+            <a:cxnSpLocks/>
+          </p:cNvCxnSpPr>
+          <p:nvPr/>
+        </p:nvCxnSpPr>
+        <p:spPr>
+          <a:xfrm flipH="1" flipV="1">
+            <a:off x="359006" y="1407429"/>
+            <a:ext cx="427281" cy="64466"/>
+          </a:xfrm>
+          <a:prstGeom prst="line">
+            <a:avLst/>
+          </a:prstGeom>
+          <a:ln w="25400" cap="rnd">
+            <a:solidFill>
+              <a:srgbClr val="C00000"/>
+            </a:solidFill>
+            <a:round/>
+            <a:headEnd type="none" w="lg" len="lg"/>
+            <a:tailEnd type="none" w="sm" len="med"/>
+          </a:ln>
+        </p:spPr>
+        <p:style>
+          <a:lnRef idx="2">
+            <a:schemeClr val="accent1"/>
+          </a:lnRef>
+          <a:fillRef idx="0">
+            <a:schemeClr val="accent1"/>
+          </a:fillRef>
+          <a:effectRef idx="1">
+            <a:schemeClr val="accent1"/>
+          </a:effectRef>
+          <a:fontRef idx="minor">
+            <a:schemeClr val="tx1"/>
+          </a:fontRef>
+        </p:style>
+      </p:cxnSp>
+      <p:grpSp>
+        <p:nvGrpSpPr>
+          <p:cNvPr id="5" name="Gruppieren 4">
+            <a:extLst>
+              <a:ext uri="{FF2B5EF4-FFF2-40B4-BE49-F238E27FC236}">
+                <a16:creationId xmlns:a16="http://schemas.microsoft.com/office/drawing/2014/main" id="{EB996453-B2C3-4DA6-0C23-941E24C4C15F}"/>
+              </a:ext>
+            </a:extLst>
+          </p:cNvPr>
+          <p:cNvGrpSpPr/>
+          <p:nvPr/>
+        </p:nvGrpSpPr>
+        <p:grpSpPr>
+          <a:xfrm rot="15688430">
+            <a:off x="2023266" y="1138716"/>
+            <a:ext cx="1486614" cy="498200"/>
+            <a:chOff x="1522283" y="2706438"/>
+            <a:chExt cx="1486614" cy="498200"/>
+          </a:xfrm>
+        </p:grpSpPr>
+        <p:cxnSp>
+          <p:nvCxnSpPr>
+            <p:cNvPr id="12" name="Gerader Verbinder 11">
+              <a:extLst>
+                <a:ext uri="{FF2B5EF4-FFF2-40B4-BE49-F238E27FC236}">
+                  <a16:creationId xmlns:a16="http://schemas.microsoft.com/office/drawing/2014/main" id="{4918A34A-BB1E-5266-8AC5-3881B2C32ABD}"/>
+                </a:ext>
+              </a:extLst>
+            </p:cNvPr>
+            <p:cNvCxnSpPr>
+              <a:cxnSpLocks/>
+            </p:cNvCxnSpPr>
+            <p:nvPr/>
+          </p:nvCxnSpPr>
+          <p:spPr>
+            <a:xfrm flipV="1">
+              <a:off x="3008665" y="2927055"/>
+              <a:ext cx="0" cy="277583"/>
+            </a:xfrm>
+            <a:prstGeom prst="line">
+              <a:avLst/>
+            </a:prstGeom>
+            <a:ln w="12700" cap="rnd">
+              <a:solidFill>
+                <a:schemeClr val="tx1"/>
+              </a:solidFill>
+              <a:round/>
+            </a:ln>
+          </p:spPr>
+          <p:style>
+            <a:lnRef idx="2">
+              <a:schemeClr val="accent1"/>
+            </a:lnRef>
+            <a:fillRef idx="0">
+              <a:schemeClr val="accent1"/>
+            </a:fillRef>
+            <a:effectRef idx="1">
+              <a:schemeClr val="accent1"/>
+            </a:effectRef>
+            <a:fontRef idx="minor">
+              <a:schemeClr val="tx1"/>
+            </a:fontRef>
+          </p:style>
+        </p:cxnSp>
+        <p:cxnSp>
+          <p:nvCxnSpPr>
+            <p:cNvPr id="9" name="Gerader Verbinder 8">
+              <a:extLst>
+                <a:ext uri="{FF2B5EF4-FFF2-40B4-BE49-F238E27FC236}">
+                  <a16:creationId xmlns:a16="http://schemas.microsoft.com/office/drawing/2014/main" id="{2F9486E2-7281-4342-4A42-2A1B6F9FD2A9}"/>
+                </a:ext>
+              </a:extLst>
+            </p:cNvPr>
+            <p:cNvCxnSpPr>
+              <a:cxnSpLocks/>
+            </p:cNvCxnSpPr>
+            <p:nvPr/>
+          </p:nvCxnSpPr>
+          <p:spPr>
+            <a:xfrm flipV="1">
+              <a:off x="1524670" y="2706438"/>
+              <a:ext cx="0" cy="277583"/>
+            </a:xfrm>
+            <a:prstGeom prst="line">
+              <a:avLst/>
+            </a:prstGeom>
+            <a:ln w="12700" cap="rnd">
+              <a:solidFill>
+                <a:schemeClr val="tx1"/>
+              </a:solidFill>
+              <a:round/>
+            </a:ln>
+          </p:spPr>
+          <p:style>
+            <a:lnRef idx="2">
+              <a:schemeClr val="accent1"/>
+            </a:lnRef>
+            <a:fillRef idx="0">
+              <a:schemeClr val="accent1"/>
+            </a:fillRef>
+            <a:effectRef idx="1">
+              <a:schemeClr val="accent1"/>
+            </a:effectRef>
+            <a:fontRef idx="minor">
+              <a:schemeClr val="tx1"/>
+            </a:fontRef>
+          </p:style>
+        </p:cxnSp>
+        <p:cxnSp>
+          <p:nvCxnSpPr>
+            <p:cNvPr id="10" name="Gerader Verbinder 9">
+              <a:extLst>
+                <a:ext uri="{FF2B5EF4-FFF2-40B4-BE49-F238E27FC236}">
+                  <a16:creationId xmlns:a16="http://schemas.microsoft.com/office/drawing/2014/main" id="{61C0D1C3-B807-4B4B-42BC-B04E17A8F2DF}"/>
+                </a:ext>
+              </a:extLst>
+            </p:cNvPr>
+            <p:cNvCxnSpPr>
+              <a:cxnSpLocks/>
+            </p:cNvCxnSpPr>
+            <p:nvPr/>
+          </p:nvCxnSpPr>
+          <p:spPr>
+            <a:xfrm flipV="1">
+              <a:off x="1920910" y="2768442"/>
+              <a:ext cx="0" cy="277583"/>
+            </a:xfrm>
+            <a:prstGeom prst="line">
+              <a:avLst/>
+            </a:prstGeom>
+            <a:ln w="12700" cap="rnd">
+              <a:solidFill>
+                <a:schemeClr val="tx1"/>
+              </a:solidFill>
+              <a:round/>
+            </a:ln>
+          </p:spPr>
+          <p:style>
+            <a:lnRef idx="2">
+              <a:schemeClr val="accent1"/>
+            </a:lnRef>
+            <a:fillRef idx="0">
+              <a:schemeClr val="accent1"/>
+            </a:fillRef>
+            <a:effectRef idx="1">
+              <a:schemeClr val="accent1"/>
+            </a:effectRef>
+            <a:fontRef idx="minor">
+              <a:schemeClr val="tx1"/>
+            </a:fontRef>
+          </p:style>
+        </p:cxnSp>
+        <p:cxnSp>
+          <p:nvCxnSpPr>
+            <p:cNvPr id="11" name="Gerader Verbinder 10">
+              <a:extLst>
+                <a:ext uri="{FF2B5EF4-FFF2-40B4-BE49-F238E27FC236}">
+                  <a16:creationId xmlns:a16="http://schemas.microsoft.com/office/drawing/2014/main" id="{72BB0515-7F19-9D5B-6793-AD924992E978}"/>
+                </a:ext>
+              </a:extLst>
+            </p:cNvPr>
+            <p:cNvCxnSpPr>
+              <a:cxnSpLocks/>
+            </p:cNvCxnSpPr>
+            <p:nvPr/>
+          </p:nvCxnSpPr>
+          <p:spPr>
+            <a:xfrm flipV="1">
+              <a:off x="2610270" y="2869994"/>
+              <a:ext cx="0" cy="277583"/>
+            </a:xfrm>
+            <a:prstGeom prst="line">
+              <a:avLst/>
+            </a:prstGeom>
+            <a:ln w="12700" cap="rnd">
+              <a:solidFill>
+                <a:schemeClr val="tx1"/>
+              </a:solidFill>
+              <a:round/>
+            </a:ln>
+          </p:spPr>
+          <p:style>
+            <a:lnRef idx="2">
+              <a:schemeClr val="accent1"/>
+            </a:lnRef>
+            <a:fillRef idx="0">
+              <a:schemeClr val="accent1"/>
+            </a:fillRef>
+            <a:effectRef idx="1">
+              <a:schemeClr val="accent1"/>
+            </a:effectRef>
+            <a:fontRef idx="minor">
+              <a:schemeClr val="tx1"/>
+            </a:fontRef>
+          </p:style>
+        </p:cxnSp>
+        <p:cxnSp>
+          <p:nvCxnSpPr>
+            <p:cNvPr id="13" name="Gerader Verbinder 12">
+              <a:extLst>
+                <a:ext uri="{FF2B5EF4-FFF2-40B4-BE49-F238E27FC236}">
+                  <a16:creationId xmlns:a16="http://schemas.microsoft.com/office/drawing/2014/main" id="{C1F10D7C-3214-00EF-9771-96537FEAE7A3}"/>
+                </a:ext>
+              </a:extLst>
+            </p:cNvPr>
+            <p:cNvCxnSpPr>
+              <a:cxnSpLocks/>
+            </p:cNvCxnSpPr>
+            <p:nvPr/>
+          </p:nvCxnSpPr>
+          <p:spPr>
+            <a:xfrm flipH="1" flipV="1">
+              <a:off x="1522283" y="2931311"/>
+              <a:ext cx="398627" cy="60142"/>
+            </a:xfrm>
+            <a:prstGeom prst="line">
+              <a:avLst/>
+            </a:prstGeom>
+            <a:ln w="12700" cap="rnd">
+              <a:solidFill>
+                <a:schemeClr val="tx1"/>
+              </a:solidFill>
+              <a:round/>
+              <a:headEnd type="triangle" w="sm" len="med"/>
+              <a:tailEnd type="triangle" w="sm" len="med"/>
+            </a:ln>
+          </p:spPr>
+          <p:style>
+            <a:lnRef idx="2">
+              <a:schemeClr val="accent1"/>
+            </a:lnRef>
+            <a:fillRef idx="0">
+              <a:schemeClr val="accent1"/>
+            </a:fillRef>
+            <a:effectRef idx="1">
+              <a:schemeClr val="accent1"/>
+            </a:effectRef>
+            <a:fontRef idx="minor">
+              <a:schemeClr val="tx1"/>
+            </a:fontRef>
+          </p:style>
+        </p:cxnSp>
+        <p:cxnSp>
+          <p:nvCxnSpPr>
+            <p:cNvPr id="17" name="Gerader Verbinder 16">
+              <a:extLst>
+                <a:ext uri="{FF2B5EF4-FFF2-40B4-BE49-F238E27FC236}">
+                  <a16:creationId xmlns:a16="http://schemas.microsoft.com/office/drawing/2014/main" id="{552B5E6A-6E5C-8CD0-EBD3-850EC15F1DC3}"/>
+                </a:ext>
+              </a:extLst>
+            </p:cNvPr>
+            <p:cNvCxnSpPr>
+              <a:cxnSpLocks/>
+            </p:cNvCxnSpPr>
+            <p:nvPr/>
+          </p:nvCxnSpPr>
+          <p:spPr>
+            <a:xfrm flipH="1" flipV="1">
+              <a:off x="2610270" y="3091831"/>
+              <a:ext cx="398627" cy="60142"/>
+            </a:xfrm>
+            <a:prstGeom prst="line">
+              <a:avLst/>
+            </a:prstGeom>
+            <a:ln w="12700" cap="rnd">
+              <a:solidFill>
+                <a:schemeClr val="tx1"/>
+              </a:solidFill>
+              <a:round/>
+              <a:headEnd type="triangle" w="sm" len="med"/>
+              <a:tailEnd type="triangle" w="sm" len="med"/>
+            </a:ln>
+          </p:spPr>
+          <p:style>
+            <a:lnRef idx="2">
+              <a:schemeClr val="accent1"/>
+            </a:lnRef>
+            <a:fillRef idx="0">
+              <a:schemeClr val="accent1"/>
+            </a:fillRef>
+            <a:effectRef idx="1">
+              <a:schemeClr val="accent1"/>
+            </a:effectRef>
+            <a:fontRef idx="minor">
+              <a:schemeClr val="tx1"/>
+            </a:fontRef>
+          </p:style>
+        </p:cxnSp>
+        <p:cxnSp>
+          <p:nvCxnSpPr>
+            <p:cNvPr id="18" name="Gerader Verbinder 17">
+              <a:extLst>
+                <a:ext uri="{FF2B5EF4-FFF2-40B4-BE49-F238E27FC236}">
+                  <a16:creationId xmlns:a16="http://schemas.microsoft.com/office/drawing/2014/main" id="{119EDF62-1D5B-689C-4BF4-717B9880DD7A}"/>
+                </a:ext>
+              </a:extLst>
+            </p:cNvPr>
+            <p:cNvCxnSpPr>
+              <a:cxnSpLocks/>
+            </p:cNvCxnSpPr>
+            <p:nvPr/>
+          </p:nvCxnSpPr>
+          <p:spPr>
+            <a:xfrm flipH="1" flipV="1">
+              <a:off x="1918463" y="2989548"/>
+              <a:ext cx="691806" cy="104374"/>
+            </a:xfrm>
+            <a:prstGeom prst="line">
+              <a:avLst/>
+            </a:prstGeom>
+            <a:ln w="12700" cap="rnd">
+              <a:solidFill>
+                <a:schemeClr val="tx1"/>
+              </a:solidFill>
+              <a:round/>
+              <a:headEnd type="triangle" w="sm" len="med"/>
+              <a:tailEnd type="triangle" w="sm" len="med"/>
+            </a:ln>
+          </p:spPr>
+          <p:style>
+            <a:lnRef idx="2">
+              <a:schemeClr val="accent1"/>
+            </a:lnRef>
+            <a:fillRef idx="0">
+              <a:schemeClr val="accent1"/>
+            </a:fillRef>
+            <a:effectRef idx="1">
+              <a:schemeClr val="accent1"/>
+            </a:effectRef>
+            <a:fontRef idx="minor">
+              <a:schemeClr val="tx1"/>
+            </a:fontRef>
+          </p:style>
+        </p:cxnSp>
+      </p:grpSp>
+      <p:cxnSp>
+        <p:nvCxnSpPr>
+          <p:cNvPr id="16" name="Gerader Verbinder 15">
+            <a:extLst>
+              <a:ext uri="{FF2B5EF4-FFF2-40B4-BE49-F238E27FC236}">
+                <a16:creationId xmlns:a16="http://schemas.microsoft.com/office/drawing/2014/main" id="{544C0C49-9073-9B10-FE72-7E235FB4ED08}"/>
+              </a:ext>
+            </a:extLst>
+          </p:cNvPr>
+          <p:cNvCxnSpPr>
+            <a:cxnSpLocks/>
+          </p:cNvCxnSpPr>
+          <p:nvPr/>
+        </p:nvCxnSpPr>
+        <p:spPr>
+          <a:xfrm flipV="1">
+            <a:off x="708816" y="2549032"/>
+            <a:ext cx="0" cy="266130"/>
+          </a:xfrm>
+          <a:prstGeom prst="line">
+            <a:avLst/>
+          </a:prstGeom>
+          <a:ln w="12700" cap="rnd">
+            <a:solidFill>
+              <a:schemeClr val="tx1"/>
+            </a:solidFill>
+            <a:round/>
+          </a:ln>
+        </p:spPr>
+        <p:style>
+          <a:lnRef idx="2">
+            <a:schemeClr val="accent1"/>
+          </a:lnRef>
+          <a:fillRef idx="0">
+            <a:schemeClr val="accent1"/>
+          </a:fillRef>
+          <a:effectRef idx="1">
+            <a:schemeClr val="accent1"/>
+          </a:effectRef>
+          <a:fontRef idx="minor">
+            <a:schemeClr val="tx1"/>
+          </a:fontRef>
+        </p:style>
+      </p:cxnSp>
+      <p:cxnSp>
+        <p:nvCxnSpPr>
+          <p:cNvPr id="35" name="Gerader Verbinder 34">
+            <a:extLst>
+              <a:ext uri="{FF2B5EF4-FFF2-40B4-BE49-F238E27FC236}">
+                <a16:creationId xmlns:a16="http://schemas.microsoft.com/office/drawing/2014/main" id="{D387DFF2-DEA1-4749-0762-5E288491BB17}"/>
+              </a:ext>
+            </a:extLst>
+          </p:cNvPr>
+          <p:cNvCxnSpPr>
+            <a:cxnSpLocks/>
+          </p:cNvCxnSpPr>
+          <p:nvPr/>
+        </p:nvCxnSpPr>
+        <p:spPr>
+          <a:xfrm flipV="1">
+            <a:off x="2116679" y="2755270"/>
+            <a:ext cx="0" cy="266130"/>
+          </a:xfrm>
+          <a:prstGeom prst="line">
+            <a:avLst/>
+          </a:prstGeom>
+          <a:ln w="12700" cap="rnd">
+            <a:solidFill>
+              <a:schemeClr val="tx1"/>
+            </a:solidFill>
+            <a:round/>
+          </a:ln>
+        </p:spPr>
+        <p:style>
+          <a:lnRef idx="2">
+            <a:schemeClr val="accent1"/>
+          </a:lnRef>
+          <a:fillRef idx="0">
+            <a:schemeClr val="accent1"/>
+          </a:fillRef>
+          <a:effectRef idx="1">
+            <a:schemeClr val="accent1"/>
+          </a:effectRef>
+          <a:fontRef idx="minor">
+            <a:schemeClr val="tx1"/>
+          </a:fontRef>
+        </p:style>
+      </p:cxnSp>
+      <p:grpSp>
+        <p:nvGrpSpPr>
+          <p:cNvPr id="3" name="Gruppieren 2">
+            <a:extLst>
+              <a:ext uri="{FF2B5EF4-FFF2-40B4-BE49-F238E27FC236}">
+                <a16:creationId xmlns:a16="http://schemas.microsoft.com/office/drawing/2014/main" id="{7FD997E2-CEA9-F378-0A44-65951E76D003}"/>
+              </a:ext>
+            </a:extLst>
+          </p:cNvPr>
+          <p:cNvGrpSpPr/>
+          <p:nvPr/>
+        </p:nvGrpSpPr>
+        <p:grpSpPr>
+          <a:xfrm rot="16708596" flipV="1">
+            <a:off x="530482" y="613220"/>
+            <a:ext cx="2172192" cy="1963730"/>
+            <a:chOff x="892842" y="766521"/>
+            <a:chExt cx="2172192" cy="1965994"/>
+          </a:xfrm>
+        </p:grpSpPr>
+        <p:sp>
+          <p:nvSpPr>
+            <p:cNvPr id="37" name="Parallelogramm 36">
+              <a:extLst>
+                <a:ext uri="{FF2B5EF4-FFF2-40B4-BE49-F238E27FC236}">
+                  <a16:creationId xmlns:a16="http://schemas.microsoft.com/office/drawing/2014/main" id="{8D307D85-E045-5FD2-1D1F-AFC6818A6869}"/>
+                </a:ext>
+              </a:extLst>
+            </p:cNvPr>
+            <p:cNvSpPr/>
+            <p:nvPr/>
+          </p:nvSpPr>
+          <p:spPr>
+            <a:xfrm rot="8886906" flipV="1">
+              <a:off x="892842" y="779259"/>
+              <a:ext cx="1083426" cy="256126"/>
+            </a:xfrm>
+            <a:prstGeom prst="parallelogram">
+              <a:avLst>
+                <a:gd name="adj" fmla="val 117404"/>
+              </a:avLst>
+            </a:prstGeom>
+            <a:solidFill>
+              <a:schemeClr val="tx2">
+                <a:lumMod val="50000"/>
+                <a:lumOff val="50000"/>
+              </a:schemeClr>
+            </a:solidFill>
+            <a:ln cap="rnd">
+              <a:solidFill>
+                <a:schemeClr val="tx2">
+                  <a:lumMod val="90000"/>
+                  <a:lumOff val="10000"/>
+                </a:schemeClr>
+              </a:solidFill>
+              <a:round/>
+            </a:ln>
+          </p:spPr>
+          <p:style>
+            <a:lnRef idx="2">
+              <a:schemeClr val="accent1">
+                <a:shade val="15000"/>
+              </a:schemeClr>
+            </a:lnRef>
+            <a:fillRef idx="1">
+              <a:schemeClr val="accent1"/>
+            </a:fillRef>
+            <a:effectRef idx="0">
+              <a:schemeClr val="accent1"/>
+            </a:effectRef>
+            <a:fontRef idx="minor">
+              <a:schemeClr val="lt1"/>
+            </a:fontRef>
+          </p:style>
+          <p:txBody>
+            <a:bodyPr rtlCol="0" anchor="ctr"/>
+            <a:lstStyle/>
+            <a:p>
+              <a:pPr algn="ctr"/>
+              <a:endParaRPr lang="de-DE"/>
+            </a:p>
+          </p:txBody>
+        </p:sp>
+        <p:sp>
+          <p:nvSpPr>
+            <p:cNvPr id="34" name="Parallelogramm 33">
+              <a:extLst>
+                <a:ext uri="{FF2B5EF4-FFF2-40B4-BE49-F238E27FC236}">
+                  <a16:creationId xmlns:a16="http://schemas.microsoft.com/office/drawing/2014/main" id="{3BF3D061-2EA4-97F9-F3D1-AC0F1058DD00}"/>
+                </a:ext>
+              </a:extLst>
+            </p:cNvPr>
+            <p:cNvSpPr/>
+            <p:nvPr/>
+          </p:nvSpPr>
+          <p:spPr>
+            <a:xfrm rot="8886906" flipV="1">
+              <a:off x="1331976" y="766521"/>
+              <a:ext cx="1298501" cy="444503"/>
+            </a:xfrm>
+            <a:prstGeom prst="parallelogram">
+              <a:avLst>
+                <a:gd name="adj" fmla="val 117404"/>
+              </a:avLst>
+            </a:prstGeom>
+            <a:solidFill>
+              <a:schemeClr val="accent2">
+                <a:lumMod val="60000"/>
+                <a:lumOff val="40000"/>
+              </a:schemeClr>
+            </a:solidFill>
+            <a:ln cap="rnd">
+              <a:solidFill>
+                <a:schemeClr val="accent2">
+                  <a:lumMod val="75000"/>
+                </a:schemeClr>
+              </a:solidFill>
+              <a:round/>
+            </a:ln>
+          </p:spPr>
+          <p:style>
+            <a:lnRef idx="2">
+              <a:schemeClr val="accent1">
+                <a:shade val="15000"/>
+              </a:schemeClr>
+            </a:lnRef>
+            <a:fillRef idx="1">
+              <a:schemeClr val="accent1"/>
+            </a:fillRef>
+            <a:effectRef idx="0">
+              <a:schemeClr val="accent1"/>
+            </a:effectRef>
+            <a:fontRef idx="minor">
+              <a:schemeClr val="lt1"/>
+            </a:fontRef>
+          </p:style>
+          <p:txBody>
+            <a:bodyPr rtlCol="0" anchor="ctr"/>
+            <a:lstStyle/>
+            <a:p>
+              <a:pPr algn="ctr"/>
+              <a:endParaRPr lang="de-DE"/>
+            </a:p>
+          </p:txBody>
+        </p:sp>
+        <p:sp>
+          <p:nvSpPr>
+            <p:cNvPr id="33" name="Parallelogramm 32">
+              <a:extLst>
+                <a:ext uri="{FF2B5EF4-FFF2-40B4-BE49-F238E27FC236}">
+                  <a16:creationId xmlns:a16="http://schemas.microsoft.com/office/drawing/2014/main" id="{A8A88F94-5E29-CBD7-2891-94E0D40583C6}"/>
+                </a:ext>
+              </a:extLst>
+            </p:cNvPr>
+            <p:cNvSpPr/>
+            <p:nvPr/>
+          </p:nvSpPr>
+          <p:spPr>
+            <a:xfrm rot="8886906" flipV="1">
+              <a:off x="1981608" y="946891"/>
+              <a:ext cx="1083426" cy="256126"/>
+            </a:xfrm>
+            <a:prstGeom prst="parallelogram">
+              <a:avLst>
+                <a:gd name="adj" fmla="val 117404"/>
+              </a:avLst>
+            </a:prstGeom>
+            <a:solidFill>
+              <a:schemeClr val="accent6">
+                <a:lumMod val="40000"/>
+                <a:lumOff val="60000"/>
+              </a:schemeClr>
+            </a:solidFill>
+            <a:ln cap="rnd">
+              <a:solidFill>
+                <a:schemeClr val="accent6">
+                  <a:lumMod val="75000"/>
+                </a:schemeClr>
+              </a:solidFill>
+              <a:round/>
+            </a:ln>
+          </p:spPr>
+          <p:style>
+            <a:lnRef idx="2">
+              <a:schemeClr val="accent1">
+                <a:shade val="15000"/>
+              </a:schemeClr>
+            </a:lnRef>
+            <a:fillRef idx="1">
+              <a:schemeClr val="accent1"/>
+            </a:fillRef>
+            <a:effectRef idx="0">
+              <a:schemeClr val="accent1"/>
+            </a:effectRef>
+            <a:fontRef idx="minor">
+              <a:schemeClr val="lt1"/>
+            </a:fontRef>
+          </p:style>
+          <p:txBody>
+            <a:bodyPr rtlCol="0" anchor="ctr"/>
+            <a:lstStyle/>
+            <a:p>
+              <a:pPr algn="ctr"/>
+              <a:endParaRPr lang="de-DE"/>
+            </a:p>
+          </p:txBody>
+        </p:sp>
+        <p:sp>
+          <p:nvSpPr>
+            <p:cNvPr id="32" name="Parallelogramm 31">
+              <a:extLst>
+                <a:ext uri="{FF2B5EF4-FFF2-40B4-BE49-F238E27FC236}">
+                  <a16:creationId xmlns:a16="http://schemas.microsoft.com/office/drawing/2014/main" id="{3D7E949C-B796-0C33-2E38-42E3643477F1}"/>
+                </a:ext>
+              </a:extLst>
+            </p:cNvPr>
+            <p:cNvSpPr/>
+            <p:nvPr/>
+          </p:nvSpPr>
+          <p:spPr>
+            <a:xfrm rot="16200000" flipV="1">
+              <a:off x="1802360" y="1479954"/>
+              <a:ext cx="1832319" cy="666920"/>
+            </a:xfrm>
+            <a:prstGeom prst="parallelogram">
+              <a:avLst>
+                <a:gd name="adj" fmla="val 62241"/>
+              </a:avLst>
+            </a:prstGeom>
+            <a:solidFill>
+              <a:schemeClr val="accent6">
+                <a:lumMod val="40000"/>
+                <a:lumOff val="60000"/>
+              </a:schemeClr>
+            </a:solidFill>
+            <a:ln cap="rnd">
+              <a:solidFill>
+                <a:schemeClr val="accent6">
+                  <a:lumMod val="75000"/>
+                </a:schemeClr>
+              </a:solidFill>
+              <a:round/>
+            </a:ln>
+          </p:spPr>
+          <p:style>
+            <a:lnRef idx="2">
+              <a:schemeClr val="accent1">
+                <a:shade val="15000"/>
+              </a:schemeClr>
+            </a:lnRef>
+            <a:fillRef idx="1">
+              <a:schemeClr val="accent1"/>
+            </a:fillRef>
+            <a:effectRef idx="0">
+              <a:schemeClr val="accent1"/>
+            </a:effectRef>
+            <a:fontRef idx="minor">
+              <a:schemeClr val="lt1"/>
+            </a:fontRef>
+          </p:style>
+          <p:txBody>
+            <a:bodyPr rtlCol="0" anchor="ctr"/>
+            <a:lstStyle/>
+            <a:p>
+              <a:pPr algn="ctr"/>
+              <a:endParaRPr lang="de-DE"/>
+            </a:p>
+          </p:txBody>
+        </p:sp>
+        <p:sp>
+          <p:nvSpPr>
+            <p:cNvPr id="4" name="Parallelogramm 3">
+              <a:extLst>
+                <a:ext uri="{FF2B5EF4-FFF2-40B4-BE49-F238E27FC236}">
+                  <a16:creationId xmlns:a16="http://schemas.microsoft.com/office/drawing/2014/main" id="{C4A81CF1-4F70-6C76-2DB8-ABD885B1D02B}"/>
+                </a:ext>
+              </a:extLst>
+            </p:cNvPr>
+            <p:cNvSpPr/>
+            <p:nvPr/>
+          </p:nvSpPr>
+          <p:spPr>
+            <a:xfrm rot="16200000">
+              <a:off x="884504" y="1573171"/>
+              <a:ext cx="1523999" cy="671278"/>
+            </a:xfrm>
+            <a:prstGeom prst="parallelogram">
+              <a:avLst>
+                <a:gd name="adj" fmla="val 15110"/>
+              </a:avLst>
+            </a:prstGeom>
+            <a:solidFill>
+              <a:schemeClr val="accent2">
+                <a:lumMod val="60000"/>
+                <a:lumOff val="40000"/>
+              </a:schemeClr>
+            </a:solidFill>
+            <a:ln cap="rnd">
+              <a:solidFill>
+                <a:schemeClr val="accent2">
+                  <a:lumMod val="75000"/>
+                </a:schemeClr>
+              </a:solidFill>
+              <a:round/>
+            </a:ln>
+          </p:spPr>
+          <p:style>
+            <a:lnRef idx="2">
+              <a:schemeClr val="accent1">
+                <a:shade val="15000"/>
+              </a:schemeClr>
+            </a:lnRef>
+            <a:fillRef idx="1">
+              <a:schemeClr val="accent1"/>
+            </a:fillRef>
+            <a:effectRef idx="0">
+              <a:schemeClr val="accent1"/>
+            </a:effectRef>
+            <a:fontRef idx="minor">
+              <a:schemeClr val="lt1"/>
+            </a:fontRef>
+          </p:style>
+          <p:txBody>
+            <a:bodyPr rtlCol="0" anchor="ctr"/>
+            <a:lstStyle/>
+            <a:p>
+              <a:pPr algn="ctr"/>
+              <a:endParaRPr lang="de-DE"/>
+            </a:p>
+          </p:txBody>
+        </p:sp>
+        <p:sp>
+          <p:nvSpPr>
+            <p:cNvPr id="14" name="Parallelogramm 13">
+              <a:extLst>
+                <a:ext uri="{FF2B5EF4-FFF2-40B4-BE49-F238E27FC236}">
+                  <a16:creationId xmlns:a16="http://schemas.microsoft.com/office/drawing/2014/main" id="{24436CA1-5C5F-535D-47FF-4C9F8D5AB165}"/>
+                </a:ext>
+              </a:extLst>
+            </p:cNvPr>
+            <p:cNvSpPr/>
+            <p:nvPr/>
+          </p:nvSpPr>
+          <p:spPr>
+            <a:xfrm rot="16200000">
+              <a:off x="1452623" y="1799433"/>
+              <a:ext cx="1480930" cy="385233"/>
+            </a:xfrm>
+            <a:prstGeom prst="parallelogram">
+              <a:avLst>
+                <a:gd name="adj" fmla="val 15110"/>
+              </a:avLst>
+            </a:prstGeom>
+            <a:solidFill>
+              <a:schemeClr val="accent6">
+                <a:lumMod val="60000"/>
+                <a:lumOff val="40000"/>
+              </a:schemeClr>
+            </a:solidFill>
+            <a:ln cap="rnd">
+              <a:solidFill>
+                <a:schemeClr val="accent6">
+                  <a:lumMod val="75000"/>
+                </a:schemeClr>
+              </a:solidFill>
+              <a:round/>
+            </a:ln>
+          </p:spPr>
+          <p:style>
+            <a:lnRef idx="2">
+              <a:schemeClr val="accent1">
+                <a:shade val="15000"/>
+              </a:schemeClr>
+            </a:lnRef>
+            <a:fillRef idx="1">
+              <a:schemeClr val="accent1"/>
+            </a:fillRef>
+            <a:effectRef idx="0">
+              <a:schemeClr val="accent1"/>
+            </a:effectRef>
+            <a:fontRef idx="minor">
+              <a:schemeClr val="lt1"/>
+            </a:fontRef>
+          </p:style>
+          <p:txBody>
+            <a:bodyPr rtlCol="0" anchor="ctr"/>
+            <a:lstStyle/>
+            <a:p>
+              <a:pPr algn="ctr"/>
+              <a:endParaRPr lang="de-DE"/>
+            </a:p>
+          </p:txBody>
+        </p:sp>
+        <p:sp>
+          <p:nvSpPr>
+            <p:cNvPr id="2" name="Parallelogramm 1">
+              <a:extLst>
+                <a:ext uri="{FF2B5EF4-FFF2-40B4-BE49-F238E27FC236}">
+                  <a16:creationId xmlns:a16="http://schemas.microsoft.com/office/drawing/2014/main" id="{5D60F91A-C1B5-9C57-F0AB-513E5355817E}"/>
+                </a:ext>
+              </a:extLst>
+            </p:cNvPr>
+            <p:cNvSpPr/>
+            <p:nvPr/>
+          </p:nvSpPr>
+          <p:spPr>
+            <a:xfrm rot="16200000">
+              <a:off x="359663" y="1633454"/>
+              <a:ext cx="1478627" cy="385233"/>
+            </a:xfrm>
+            <a:prstGeom prst="parallelogram">
+              <a:avLst>
+                <a:gd name="adj" fmla="val 15110"/>
+              </a:avLst>
+            </a:prstGeom>
+            <a:solidFill>
+              <a:schemeClr val="tx2">
+                <a:lumMod val="50000"/>
+                <a:lumOff val="50000"/>
+              </a:schemeClr>
+            </a:solidFill>
+            <a:ln cap="rnd">
+              <a:solidFill>
+                <a:schemeClr val="tx2">
+                  <a:lumMod val="90000"/>
+                  <a:lumOff val="10000"/>
+                </a:schemeClr>
+              </a:solidFill>
+              <a:round/>
+            </a:ln>
+          </p:spPr>
+          <p:style>
+            <a:lnRef idx="2">
+              <a:schemeClr val="accent1">
+                <a:shade val="15000"/>
+              </a:schemeClr>
+            </a:lnRef>
+            <a:fillRef idx="1">
+              <a:schemeClr val="accent1"/>
+            </a:fillRef>
+            <a:effectRef idx="0">
+              <a:schemeClr val="accent1"/>
+            </a:effectRef>
+            <a:fontRef idx="minor">
+              <a:schemeClr val="lt1"/>
+            </a:fontRef>
+          </p:style>
+          <p:txBody>
+            <a:bodyPr rtlCol="0" anchor="ctr"/>
+            <a:lstStyle/>
+            <a:p>
+              <a:pPr algn="ctr"/>
+              <a:endParaRPr lang="de-DE"/>
+            </a:p>
+          </p:txBody>
+        </p:sp>
+      </p:grpSp>
+      <p:sp>
+        <p:nvSpPr>
+          <p:cNvPr id="20" name="Textfeld 19">
+            <a:extLst>
+              <a:ext uri="{FF2B5EF4-FFF2-40B4-BE49-F238E27FC236}">
+                <a16:creationId xmlns:a16="http://schemas.microsoft.com/office/drawing/2014/main" id="{F06B600C-0DAF-5A88-343F-4DC02DC60DDA}"/>
+              </a:ext>
+            </a:extLst>
+          </p:cNvPr>
+          <p:cNvSpPr txBox="1"/>
+          <p:nvPr/>
+        </p:nvSpPr>
+        <p:spPr>
+          <a:xfrm>
+            <a:off x="2725048" y="1171932"/>
+            <a:ext cx="582460" cy="307777"/>
+          </a:xfrm>
+          <a:prstGeom prst="rect">
+            <a:avLst/>
+          </a:prstGeom>
+          <a:noFill/>
+        </p:spPr>
+        <p:txBody>
+          <a:bodyPr wrap="square" rtlCol="0" anchor="ctr">
+            <a:spAutoFit/>
+          </a:bodyPr>
+          <a:lstStyle/>
+          <a:p>
+            <a:pPr algn="ctr"/>
+            <a:r>
+              <a:rPr lang="de-DE" sz="1400" i="1" dirty="0">
+                <a:latin typeface="CMU Serif" panose="02000603000000000000" pitchFamily="2" charset="0"/>
+                <a:ea typeface="CMU Serif" panose="02000603000000000000" pitchFamily="2" charset="0"/>
+                <a:cs typeface="CMU Serif" panose="02000603000000000000" pitchFamily="2" charset="0"/>
+              </a:rPr>
+              <a:t>d</a:t>
+            </a:r>
+            <a:r>
+              <a:rPr lang="de-DE" sz="1400" baseline="-25000" dirty="0">
+                <a:latin typeface="CMU Serif" panose="02000603000000000000" pitchFamily="2" charset="0"/>
+                <a:ea typeface="CMU Serif" panose="02000603000000000000" pitchFamily="2" charset="0"/>
+                <a:cs typeface="CMU Serif" panose="02000603000000000000" pitchFamily="2" charset="0"/>
+              </a:rPr>
+              <a:t>2</a:t>
+            </a:r>
+          </a:p>
+        </p:txBody>
+      </p:sp>
+      <p:sp>
+        <p:nvSpPr>
+          <p:cNvPr id="21" name="Textfeld 20">
+            <a:extLst>
+              <a:ext uri="{FF2B5EF4-FFF2-40B4-BE49-F238E27FC236}">
+                <a16:creationId xmlns:a16="http://schemas.microsoft.com/office/drawing/2014/main" id="{29E36F01-3549-06AC-193F-33084AC70E3C}"/>
+              </a:ext>
+            </a:extLst>
+          </p:cNvPr>
+          <p:cNvSpPr txBox="1"/>
+          <p:nvPr/>
+        </p:nvSpPr>
+        <p:spPr>
+          <a:xfrm>
+            <a:off x="2725048" y="655196"/>
+            <a:ext cx="582460" cy="307777"/>
+          </a:xfrm>
+          <a:prstGeom prst="rect">
+            <a:avLst/>
+          </a:prstGeom>
+          <a:noFill/>
+        </p:spPr>
+        <p:txBody>
+          <a:bodyPr wrap="square" rtlCol="0" anchor="ctr">
+            <a:spAutoFit/>
+          </a:bodyPr>
+          <a:lstStyle/>
+          <a:p>
+            <a:pPr algn="ctr"/>
+            <a:r>
+              <a:rPr lang="de-DE" sz="1400" i="1" dirty="0">
+                <a:latin typeface="CMU Serif" panose="02000603000000000000" pitchFamily="2" charset="0"/>
+                <a:ea typeface="CMU Serif" panose="02000603000000000000" pitchFamily="2" charset="0"/>
+                <a:cs typeface="CMU Serif" panose="02000603000000000000" pitchFamily="2" charset="0"/>
+              </a:rPr>
+              <a:t>d</a:t>
+            </a:r>
+            <a:r>
+              <a:rPr lang="de-DE" sz="1400" baseline="-25000" dirty="0">
+                <a:latin typeface="CMU Serif" panose="02000603000000000000" pitchFamily="2" charset="0"/>
+                <a:ea typeface="CMU Serif" panose="02000603000000000000" pitchFamily="2" charset="0"/>
+                <a:cs typeface="CMU Serif" panose="02000603000000000000" pitchFamily="2" charset="0"/>
+              </a:rPr>
+              <a:t>1</a:t>
+            </a:r>
+          </a:p>
+        </p:txBody>
+      </p:sp>
+      <p:sp>
+        <p:nvSpPr>
+          <p:cNvPr id="22" name="Textfeld 21">
+            <a:extLst>
+              <a:ext uri="{FF2B5EF4-FFF2-40B4-BE49-F238E27FC236}">
+                <a16:creationId xmlns:a16="http://schemas.microsoft.com/office/drawing/2014/main" id="{598B646B-6270-3BF0-9F6F-14EA2629DAA2}"/>
+              </a:ext>
+            </a:extLst>
+          </p:cNvPr>
+          <p:cNvSpPr txBox="1"/>
+          <p:nvPr/>
+        </p:nvSpPr>
+        <p:spPr>
+          <a:xfrm>
+            <a:off x="2725048" y="1868569"/>
+            <a:ext cx="582460" cy="307777"/>
+          </a:xfrm>
+          <a:prstGeom prst="rect">
+            <a:avLst/>
+          </a:prstGeom>
+          <a:noFill/>
+        </p:spPr>
+        <p:txBody>
+          <a:bodyPr wrap="square" rtlCol="0" anchor="ctr">
+            <a:spAutoFit/>
+          </a:bodyPr>
+          <a:lstStyle/>
+          <a:p>
+            <a:pPr algn="ctr"/>
+            <a:r>
+              <a:rPr lang="de-DE" sz="1400" i="1" dirty="0">
+                <a:latin typeface="CMU Serif" panose="02000603000000000000" pitchFamily="2" charset="0"/>
+                <a:ea typeface="CMU Serif" panose="02000603000000000000" pitchFamily="2" charset="0"/>
+                <a:cs typeface="CMU Serif" panose="02000603000000000000" pitchFamily="2" charset="0"/>
+              </a:rPr>
+              <a:t>d</a:t>
+            </a:r>
+            <a:r>
+              <a:rPr lang="de-DE" sz="1400" baseline="-25000" dirty="0">
+                <a:latin typeface="CMU Serif" panose="02000603000000000000" pitchFamily="2" charset="0"/>
+                <a:ea typeface="CMU Serif" panose="02000603000000000000" pitchFamily="2" charset="0"/>
+                <a:cs typeface="CMU Serif" panose="02000603000000000000" pitchFamily="2" charset="0"/>
+              </a:rPr>
+              <a:t>3</a:t>
+            </a:r>
+          </a:p>
+        </p:txBody>
+      </p:sp>
+      <p:cxnSp>
+        <p:nvCxnSpPr>
+          <p:cNvPr id="27" name="Gerader Verbinder 26">
+            <a:extLst>
+              <a:ext uri="{FF2B5EF4-FFF2-40B4-BE49-F238E27FC236}">
+                <a16:creationId xmlns:a16="http://schemas.microsoft.com/office/drawing/2014/main" id="{3E58DDEA-00EB-E1BD-5F36-E360F8630424}"/>
+              </a:ext>
+            </a:extLst>
+          </p:cNvPr>
+          <p:cNvCxnSpPr>
+            <a:cxnSpLocks/>
+          </p:cNvCxnSpPr>
+          <p:nvPr/>
+        </p:nvCxnSpPr>
+        <p:spPr>
+          <a:xfrm flipH="1" flipV="1">
+            <a:off x="708209" y="2760311"/>
+            <a:ext cx="1408470" cy="212499"/>
+          </a:xfrm>
+          <a:prstGeom prst="line">
+            <a:avLst/>
+          </a:prstGeom>
+          <a:ln w="12700" cap="rnd">
+            <a:solidFill>
+              <a:schemeClr val="tx1"/>
+            </a:solidFill>
+            <a:round/>
+            <a:headEnd type="triangle" w="sm" len="med"/>
+            <a:tailEnd type="triangle" w="sm" len="med"/>
+          </a:ln>
+        </p:spPr>
+        <p:style>
+          <a:lnRef idx="2">
+            <a:schemeClr val="accent1"/>
+          </a:lnRef>
+          <a:fillRef idx="0">
+            <a:schemeClr val="accent1"/>
+          </a:fillRef>
+          <a:effectRef idx="1">
+            <a:schemeClr val="accent1"/>
+          </a:effectRef>
+          <a:fontRef idx="minor">
+            <a:schemeClr val="tx1"/>
+          </a:fontRef>
+        </p:style>
+      </p:cxnSp>
+      <p:cxnSp>
+        <p:nvCxnSpPr>
+          <p:cNvPr id="38" name="Gerader Verbinder 37">
+            <a:extLst>
+              <a:ext uri="{FF2B5EF4-FFF2-40B4-BE49-F238E27FC236}">
+                <a16:creationId xmlns:a16="http://schemas.microsoft.com/office/drawing/2014/main" id="{E0EEE63B-2D5C-A54F-3FAE-A236E1D723BD}"/>
+              </a:ext>
+            </a:extLst>
+          </p:cNvPr>
+          <p:cNvCxnSpPr>
+            <a:cxnSpLocks/>
+          </p:cNvCxnSpPr>
+          <p:nvPr/>
+        </p:nvCxnSpPr>
+        <p:spPr>
+          <a:xfrm flipH="1" flipV="1">
+            <a:off x="2382151" y="1712385"/>
+            <a:ext cx="791736" cy="119451"/>
+          </a:xfrm>
+          <a:prstGeom prst="line">
+            <a:avLst/>
+          </a:prstGeom>
+          <a:ln w="25400" cap="rnd">
+            <a:solidFill>
+              <a:srgbClr val="C00000"/>
+            </a:solidFill>
+            <a:round/>
+            <a:headEnd type="triangle" w="lg" len="lg"/>
+            <a:tailEnd type="none" w="sm" len="med"/>
+          </a:ln>
+        </p:spPr>
+        <p:style>
+          <a:lnRef idx="2">
+            <a:schemeClr val="accent1"/>
+          </a:lnRef>
+          <a:fillRef idx="0">
+            <a:schemeClr val="accent1"/>
+          </a:fillRef>
+          <a:effectRef idx="1">
+            <a:schemeClr val="accent1"/>
+          </a:effectRef>
+          <a:fontRef idx="minor">
+            <a:schemeClr val="tx1"/>
+          </a:fontRef>
+        </p:style>
+      </p:cxnSp>
+      <p:grpSp>
+        <p:nvGrpSpPr>
+          <p:cNvPr id="58" name="Gruppieren 57">
+            <a:extLst>
+              <a:ext uri="{FF2B5EF4-FFF2-40B4-BE49-F238E27FC236}">
+                <a16:creationId xmlns:a16="http://schemas.microsoft.com/office/drawing/2014/main" id="{59C41673-6F03-B1D4-4995-0F2E77D2EEF0}"/>
+              </a:ext>
+            </a:extLst>
+          </p:cNvPr>
+          <p:cNvGrpSpPr/>
+          <p:nvPr/>
+        </p:nvGrpSpPr>
+        <p:grpSpPr>
+          <a:xfrm>
+            <a:off x="2837252" y="1350743"/>
+            <a:ext cx="616419" cy="457149"/>
+            <a:chOff x="3066650" y="1392188"/>
+            <a:chExt cx="616419" cy="457149"/>
+          </a:xfrm>
+        </p:grpSpPr>
+        <p:sp>
+          <p:nvSpPr>
+            <p:cNvPr id="41" name="Textfeld 40">
+              <a:extLst>
+                <a:ext uri="{FF2B5EF4-FFF2-40B4-BE49-F238E27FC236}">
+                  <a16:creationId xmlns:a16="http://schemas.microsoft.com/office/drawing/2014/main" id="{C48C1943-E01D-0D07-7BE4-C26A60C8636E}"/>
+                </a:ext>
+              </a:extLst>
+            </p:cNvPr>
+            <p:cNvSpPr txBox="1"/>
+            <p:nvPr/>
+          </p:nvSpPr>
+          <p:spPr>
+            <a:xfrm>
+              <a:off x="3066650" y="1541560"/>
+              <a:ext cx="582460" cy="307777"/>
+            </a:xfrm>
+            <a:prstGeom prst="rect">
+              <a:avLst/>
+            </a:prstGeom>
+            <a:noFill/>
+          </p:spPr>
+          <p:txBody>
+            <a:bodyPr wrap="square" rtlCol="0" anchor="ctr">
+              <a:spAutoFit/>
+            </a:bodyPr>
+            <a:lstStyle/>
+            <a:p>
+              <a:pPr algn="ctr"/>
+              <a:r>
+                <a:rPr lang="de-DE" sz="1400" i="1" dirty="0">
+                  <a:solidFill>
+                    <a:srgbClr val="C00000"/>
+                  </a:solidFill>
+                  <a:latin typeface="CMU Serif" panose="02000603000000000000" pitchFamily="2" charset="0"/>
+                  <a:ea typeface="CMU Serif" panose="02000603000000000000" pitchFamily="2" charset="0"/>
+                  <a:cs typeface="CMU Serif" panose="02000603000000000000" pitchFamily="2" charset="0"/>
+                </a:rPr>
+                <a:t>Q</a:t>
+              </a:r>
+              <a:endParaRPr lang="de-DE" sz="1400" dirty="0">
+                <a:solidFill>
+                  <a:srgbClr val="C00000"/>
+                </a:solidFill>
+                <a:latin typeface="CMU Serif" panose="02000603000000000000" pitchFamily="2" charset="0"/>
+                <a:ea typeface="CMU Serif" panose="02000603000000000000" pitchFamily="2" charset="0"/>
+                <a:cs typeface="CMU Serif" panose="02000603000000000000" pitchFamily="2" charset="0"/>
+              </a:endParaRPr>
+            </a:p>
+          </p:txBody>
+        </p:sp>
+        <p:sp>
+          <p:nvSpPr>
+            <p:cNvPr id="42" name="Textfeld 41">
+              <a:extLst>
+                <a:ext uri="{FF2B5EF4-FFF2-40B4-BE49-F238E27FC236}">
+                  <a16:creationId xmlns:a16="http://schemas.microsoft.com/office/drawing/2014/main" id="{19CBDA96-7328-881C-753D-7DCD0E196606}"/>
+                </a:ext>
+              </a:extLst>
+            </p:cNvPr>
+            <p:cNvSpPr txBox="1"/>
+            <p:nvPr/>
+          </p:nvSpPr>
+          <p:spPr>
+            <a:xfrm>
+              <a:off x="3100609" y="1392188"/>
+              <a:ext cx="582460" cy="307777"/>
+            </a:xfrm>
+            <a:prstGeom prst="rect">
+              <a:avLst/>
+            </a:prstGeom>
+            <a:noFill/>
+          </p:spPr>
+          <p:txBody>
+            <a:bodyPr wrap="square" rtlCol="0" anchor="ctr">
+              <a:spAutoFit/>
+            </a:bodyPr>
+            <a:lstStyle/>
+            <a:p>
+              <a:pPr algn="ctr"/>
+              <a:r>
+                <a:rPr lang="de-DE" sz="1400" dirty="0">
+                  <a:solidFill>
+                    <a:srgbClr val="C00000"/>
+                  </a:solidFill>
+                  <a:latin typeface="CMU Serif" panose="02000603000000000000" pitchFamily="2" charset="0"/>
+                  <a:ea typeface="CMU Serif" panose="02000603000000000000" pitchFamily="2" charset="0"/>
+                  <a:cs typeface="CMU Serif" panose="02000603000000000000" pitchFamily="2" charset="0"/>
+                </a:rPr>
+                <a:t>.</a:t>
+              </a:r>
+            </a:p>
+          </p:txBody>
+        </p:sp>
+      </p:grpSp>
+      <p:sp>
+        <p:nvSpPr>
+          <p:cNvPr id="49" name="Textfeld 48">
+            <a:extLst>
+              <a:ext uri="{FF2B5EF4-FFF2-40B4-BE49-F238E27FC236}">
+                <a16:creationId xmlns:a16="http://schemas.microsoft.com/office/drawing/2014/main" id="{AEF1FC29-785B-C9F0-6CC0-86763C4D550B}"/>
+              </a:ext>
+            </a:extLst>
+          </p:cNvPr>
+          <p:cNvSpPr txBox="1"/>
+          <p:nvPr/>
+        </p:nvSpPr>
+        <p:spPr>
+          <a:xfrm>
+            <a:off x="212461" y="1908461"/>
+            <a:ext cx="386480" cy="307777"/>
+          </a:xfrm>
+          <a:prstGeom prst="rect">
+            <a:avLst/>
+          </a:prstGeom>
+          <a:noFill/>
+        </p:spPr>
+        <p:txBody>
+          <a:bodyPr wrap="square" rtlCol="0" anchor="ctr">
+            <a:spAutoFit/>
+          </a:bodyPr>
+          <a:lstStyle/>
+          <a:p>
+            <a:pPr algn="ctr"/>
+            <a:r>
+              <a:rPr lang="de-DE" sz="1400" i="1" dirty="0">
+                <a:latin typeface="CMU Serif" panose="02000603000000000000" pitchFamily="2" charset="0"/>
+                <a:ea typeface="CMU Serif" panose="02000603000000000000" pitchFamily="2" charset="0"/>
+                <a:cs typeface="CMU Serif" panose="02000603000000000000" pitchFamily="2" charset="0"/>
+              </a:rPr>
+              <a:t>T</a:t>
+            </a:r>
+            <a:r>
+              <a:rPr lang="de-DE" sz="1400" baseline="-25000" dirty="0">
+                <a:latin typeface="CMU Serif" panose="02000603000000000000" pitchFamily="2" charset="0"/>
+                <a:ea typeface="CMU Serif" panose="02000603000000000000" pitchFamily="2" charset="0"/>
+                <a:cs typeface="CMU Serif" panose="02000603000000000000" pitchFamily="2" charset="0"/>
+              </a:rPr>
+              <a:t>1</a:t>
+            </a:r>
+          </a:p>
+        </p:txBody>
+      </p:sp>
+      <p:sp>
+        <p:nvSpPr>
+          <p:cNvPr id="66" name="Textfeld 65">
+            <a:extLst>
+              <a:ext uri="{FF2B5EF4-FFF2-40B4-BE49-F238E27FC236}">
+                <a16:creationId xmlns:a16="http://schemas.microsoft.com/office/drawing/2014/main" id="{3BAFDC77-7D81-CA72-0E9D-53D00B311376}"/>
+              </a:ext>
+            </a:extLst>
+          </p:cNvPr>
+          <p:cNvSpPr txBox="1"/>
+          <p:nvPr/>
+        </p:nvSpPr>
+        <p:spPr>
+          <a:xfrm>
+            <a:off x="1164604" y="2868288"/>
+            <a:ext cx="376264" cy="307777"/>
+          </a:xfrm>
+          <a:prstGeom prst="rect">
+            <a:avLst/>
+          </a:prstGeom>
+          <a:noFill/>
+        </p:spPr>
+        <p:txBody>
+          <a:bodyPr wrap="square" rtlCol="0" anchor="ctr">
+            <a:spAutoFit/>
+          </a:bodyPr>
+          <a:lstStyle/>
+          <a:p>
+            <a:pPr algn="ctr"/>
+            <a:r>
+              <a:rPr lang="de-DE" sz="1400" i="1" dirty="0">
+                <a:latin typeface="CMU Serif" panose="02000603000000000000" pitchFamily="2" charset="0"/>
+                <a:ea typeface="CMU Serif" panose="02000603000000000000" pitchFamily="2" charset="0"/>
+                <a:cs typeface="CMU Serif" panose="02000603000000000000" pitchFamily="2" charset="0"/>
+              </a:rPr>
+              <a:t>l</a:t>
+            </a:r>
+            <a:endParaRPr lang="de-DE" sz="1400" baseline="-25000" dirty="0">
+              <a:latin typeface="CMU Serif" panose="02000603000000000000" pitchFamily="2" charset="0"/>
+              <a:ea typeface="CMU Serif" panose="02000603000000000000" pitchFamily="2" charset="0"/>
+              <a:cs typeface="CMU Serif" panose="02000603000000000000" pitchFamily="2" charset="0"/>
+            </a:endParaRPr>
+          </a:p>
+        </p:txBody>
+      </p:sp>
+      <p:sp>
+        <p:nvSpPr>
+          <p:cNvPr id="69" name="Textfeld 68">
+            <a:extLst>
+              <a:ext uri="{FF2B5EF4-FFF2-40B4-BE49-F238E27FC236}">
+                <a16:creationId xmlns:a16="http://schemas.microsoft.com/office/drawing/2014/main" id="{18A8F9C6-301A-BCED-0BA6-F51FEDCA81F7}"/>
+              </a:ext>
+            </a:extLst>
+          </p:cNvPr>
+          <p:cNvSpPr txBox="1"/>
+          <p:nvPr/>
+        </p:nvSpPr>
+        <p:spPr>
+          <a:xfrm>
+            <a:off x="1268732" y="1795101"/>
+            <a:ext cx="369564" cy="307777"/>
+          </a:xfrm>
+          <a:prstGeom prst="rect">
+            <a:avLst/>
+          </a:prstGeom>
+          <a:noFill/>
+        </p:spPr>
+        <p:txBody>
+          <a:bodyPr wrap="square" rtlCol="0" anchor="ctr">
+            <a:spAutoFit/>
+          </a:bodyPr>
+          <a:lstStyle/>
+          <a:p>
+            <a:pPr algn="ctr"/>
+            <a:r>
+              <a:rPr lang="de-DE" sz="1400" i="1" dirty="0">
+                <a:solidFill>
+                  <a:schemeClr val="accent2">
+                    <a:lumMod val="50000"/>
+                  </a:schemeClr>
+                </a:solidFill>
+                <a:latin typeface="Latin Modern Math" panose="02000503000000000000" pitchFamily="50" charset="0"/>
+                <a:ea typeface="Latin Modern Math" panose="02000503000000000000" pitchFamily="50" charset="0"/>
+                <a:cs typeface="CMU Serif" panose="02000603000000000000" pitchFamily="2" charset="0"/>
+              </a:rPr>
+              <a:t>λ</a:t>
+            </a:r>
+            <a:r>
+              <a:rPr lang="de-DE" sz="1400" baseline="-25000" dirty="0">
+                <a:solidFill>
+                  <a:schemeClr val="accent2">
+                    <a:lumMod val="50000"/>
+                  </a:schemeClr>
+                </a:solidFill>
+                <a:latin typeface="CMU Serif" panose="02000603000000000000" pitchFamily="2" charset="0"/>
+                <a:ea typeface="CMU Serif" panose="02000603000000000000" pitchFamily="2" charset="0"/>
+                <a:cs typeface="CMU Serif" panose="02000603000000000000" pitchFamily="2" charset="0"/>
+              </a:rPr>
+              <a:t>2</a:t>
+            </a:r>
+          </a:p>
+        </p:txBody>
+      </p:sp>
+      <p:sp>
+        <p:nvSpPr>
+          <p:cNvPr id="70" name="Textfeld 69">
+            <a:extLst>
+              <a:ext uri="{FF2B5EF4-FFF2-40B4-BE49-F238E27FC236}">
+                <a16:creationId xmlns:a16="http://schemas.microsoft.com/office/drawing/2014/main" id="{178B4F14-2683-74AF-1710-17D1ADFC0215}"/>
+              </a:ext>
+            </a:extLst>
+          </p:cNvPr>
+          <p:cNvSpPr txBox="1"/>
+          <p:nvPr/>
+        </p:nvSpPr>
+        <p:spPr>
+          <a:xfrm>
+            <a:off x="1269087" y="1253540"/>
+            <a:ext cx="369564" cy="307777"/>
+          </a:xfrm>
+          <a:prstGeom prst="rect">
+            <a:avLst/>
+          </a:prstGeom>
+          <a:noFill/>
+        </p:spPr>
+        <p:txBody>
+          <a:bodyPr wrap="square" rtlCol="0" anchor="ctr">
+            <a:spAutoFit/>
+          </a:bodyPr>
+          <a:lstStyle/>
+          <a:p>
+            <a:pPr algn="ctr"/>
+            <a:r>
+              <a:rPr lang="de-DE" sz="1400" i="1" dirty="0">
+                <a:solidFill>
+                  <a:schemeClr val="accent6">
+                    <a:lumMod val="50000"/>
+                  </a:schemeClr>
+                </a:solidFill>
+                <a:latin typeface="Latin Modern Math" panose="02000503000000000000" pitchFamily="50" charset="0"/>
+                <a:ea typeface="Latin Modern Math" panose="02000503000000000000" pitchFamily="50" charset="0"/>
+                <a:cs typeface="CMU Serif" panose="02000603000000000000" pitchFamily="2" charset="0"/>
+              </a:rPr>
+              <a:t>λ</a:t>
+            </a:r>
+            <a:r>
+              <a:rPr lang="de-DE" sz="1400" baseline="-25000" dirty="0">
+                <a:solidFill>
+                  <a:schemeClr val="accent6">
+                    <a:lumMod val="50000"/>
+                  </a:schemeClr>
+                </a:solidFill>
+                <a:latin typeface="CMU Serif" panose="02000603000000000000" pitchFamily="2" charset="0"/>
+                <a:ea typeface="CMU Serif" panose="02000603000000000000" pitchFamily="2" charset="0"/>
+                <a:cs typeface="CMU Serif" panose="02000603000000000000" pitchFamily="2" charset="0"/>
+              </a:rPr>
+              <a:t>1</a:t>
+            </a:r>
+          </a:p>
+        </p:txBody>
+      </p:sp>
+      <p:sp>
+        <p:nvSpPr>
+          <p:cNvPr id="36" name="Textfeld 35">
+            <a:extLst>
+              <a:ext uri="{FF2B5EF4-FFF2-40B4-BE49-F238E27FC236}">
+                <a16:creationId xmlns:a16="http://schemas.microsoft.com/office/drawing/2014/main" id="{8005D8C8-6DC6-70F8-2922-1C5FC4DED771}"/>
+              </a:ext>
+            </a:extLst>
+          </p:cNvPr>
+          <p:cNvSpPr txBox="1"/>
+          <p:nvPr/>
+        </p:nvSpPr>
+        <p:spPr>
+          <a:xfrm>
+            <a:off x="1268732" y="2357432"/>
+            <a:ext cx="369564" cy="307777"/>
+          </a:xfrm>
+          <a:prstGeom prst="rect">
+            <a:avLst/>
+          </a:prstGeom>
+          <a:noFill/>
+        </p:spPr>
+        <p:txBody>
+          <a:bodyPr wrap="square" rtlCol="0" anchor="ctr">
+            <a:spAutoFit/>
+          </a:bodyPr>
+          <a:lstStyle/>
+          <a:p>
+            <a:pPr algn="ctr"/>
+            <a:r>
+              <a:rPr lang="de-DE" sz="1400" i="1" dirty="0">
+                <a:solidFill>
+                  <a:schemeClr val="tx2">
+                    <a:lumMod val="90000"/>
+                    <a:lumOff val="10000"/>
+                  </a:schemeClr>
+                </a:solidFill>
+                <a:latin typeface="Latin Modern Math" panose="02000503000000000000" pitchFamily="50" charset="0"/>
+                <a:ea typeface="Latin Modern Math" panose="02000503000000000000" pitchFamily="50" charset="0"/>
+                <a:cs typeface="CMU Serif" panose="02000603000000000000" pitchFamily="2" charset="0"/>
+              </a:rPr>
+              <a:t>λ</a:t>
+            </a:r>
+            <a:r>
+              <a:rPr lang="de-DE" sz="1400" baseline="-25000" dirty="0">
+                <a:solidFill>
+                  <a:schemeClr val="tx2">
+                    <a:lumMod val="90000"/>
+                    <a:lumOff val="10000"/>
+                  </a:schemeClr>
+                </a:solidFill>
+                <a:latin typeface="CMU Serif" panose="02000603000000000000" pitchFamily="2" charset="0"/>
+                <a:ea typeface="CMU Serif" panose="02000603000000000000" pitchFamily="2" charset="0"/>
+                <a:cs typeface="CMU Serif" panose="02000603000000000000" pitchFamily="2" charset="0"/>
+              </a:rPr>
+              <a:t>3</a:t>
+            </a:r>
+          </a:p>
+        </p:txBody>
+      </p:sp>
+      <p:sp>
+        <p:nvSpPr>
+          <p:cNvPr id="47" name="Textfeld 46">
+            <a:extLst>
+              <a:ext uri="{FF2B5EF4-FFF2-40B4-BE49-F238E27FC236}">
+                <a16:creationId xmlns:a16="http://schemas.microsoft.com/office/drawing/2014/main" id="{DB87FE9B-E584-555C-92AD-FCE2ABF498B7}"/>
+              </a:ext>
+            </a:extLst>
+          </p:cNvPr>
+          <p:cNvSpPr txBox="1"/>
+          <p:nvPr/>
+        </p:nvSpPr>
+        <p:spPr>
+          <a:xfrm>
+            <a:off x="2042808" y="1712429"/>
+            <a:ext cx="458632" cy="307777"/>
+          </a:xfrm>
+          <a:prstGeom prst="rect">
+            <a:avLst/>
+          </a:prstGeom>
+          <a:noFill/>
+        </p:spPr>
+        <p:txBody>
+          <a:bodyPr wrap="square" rtlCol="0" anchor="ctr">
+            <a:spAutoFit/>
+          </a:bodyPr>
+          <a:lstStyle/>
+          <a:p>
+            <a:pPr algn="ctr"/>
+            <a:r>
+              <a:rPr lang="de-DE" sz="1400" i="1" dirty="0">
+                <a:solidFill>
+                  <a:schemeClr val="accent2">
+                    <a:lumMod val="50000"/>
+                  </a:schemeClr>
+                </a:solidFill>
+                <a:latin typeface="CMU Serif" panose="02000603000000000000" pitchFamily="2" charset="0"/>
+                <a:ea typeface="CMU Serif" panose="02000603000000000000" pitchFamily="2" charset="0"/>
+                <a:cs typeface="CMU Serif" panose="02000603000000000000" pitchFamily="2" charset="0"/>
+              </a:rPr>
+              <a:t>A</a:t>
+            </a:r>
+            <a:r>
+              <a:rPr lang="de-DE" sz="1400" baseline="-25000" dirty="0">
+                <a:solidFill>
+                  <a:schemeClr val="accent2">
+                    <a:lumMod val="50000"/>
+                  </a:schemeClr>
+                </a:solidFill>
+                <a:latin typeface="CMU Serif" panose="02000603000000000000" pitchFamily="2" charset="0"/>
+                <a:ea typeface="CMU Serif" panose="02000603000000000000" pitchFamily="2" charset="0"/>
+                <a:cs typeface="CMU Serif" panose="02000603000000000000" pitchFamily="2" charset="0"/>
+              </a:rPr>
+              <a:t>2</a:t>
+            </a:r>
+          </a:p>
+        </p:txBody>
+      </p:sp>
+      <p:sp>
+        <p:nvSpPr>
+          <p:cNvPr id="51" name="Textfeld 50">
+            <a:extLst>
+              <a:ext uri="{FF2B5EF4-FFF2-40B4-BE49-F238E27FC236}">
+                <a16:creationId xmlns:a16="http://schemas.microsoft.com/office/drawing/2014/main" id="{5347727F-8C70-299A-46DA-9DE2A3AF9453}"/>
+              </a:ext>
+            </a:extLst>
+          </p:cNvPr>
+          <p:cNvSpPr txBox="1"/>
+          <p:nvPr/>
+        </p:nvSpPr>
+        <p:spPr>
+          <a:xfrm>
+            <a:off x="2079890" y="2181396"/>
+            <a:ext cx="385100" cy="307777"/>
+          </a:xfrm>
+          <a:prstGeom prst="rect">
+            <a:avLst/>
+          </a:prstGeom>
+          <a:noFill/>
+        </p:spPr>
+        <p:txBody>
+          <a:bodyPr wrap="square" rtlCol="0" anchor="ctr">
+            <a:spAutoFit/>
+          </a:bodyPr>
+          <a:lstStyle/>
+          <a:p>
+            <a:pPr algn="ctr"/>
+            <a:r>
+              <a:rPr lang="de-DE" sz="1400" i="1" dirty="0">
+                <a:solidFill>
+                  <a:schemeClr val="tx2">
+                    <a:lumMod val="90000"/>
+                    <a:lumOff val="10000"/>
+                  </a:schemeClr>
+                </a:solidFill>
+                <a:latin typeface="CMU Serif" panose="02000603000000000000" pitchFamily="2" charset="0"/>
+                <a:ea typeface="CMU Serif" panose="02000603000000000000" pitchFamily="2" charset="0"/>
+                <a:cs typeface="CMU Serif" panose="02000603000000000000" pitchFamily="2" charset="0"/>
+              </a:rPr>
+              <a:t>A</a:t>
+            </a:r>
+            <a:r>
+              <a:rPr lang="de-DE" sz="1400" baseline="-25000" dirty="0">
+                <a:solidFill>
+                  <a:schemeClr val="tx2">
+                    <a:lumMod val="90000"/>
+                    <a:lumOff val="10000"/>
+                  </a:schemeClr>
+                </a:solidFill>
+                <a:latin typeface="CMU Serif" panose="02000603000000000000" pitchFamily="2" charset="0"/>
+                <a:ea typeface="CMU Serif" panose="02000603000000000000" pitchFamily="2" charset="0"/>
+                <a:cs typeface="CMU Serif" panose="02000603000000000000" pitchFamily="2" charset="0"/>
+              </a:rPr>
+              <a:t>3</a:t>
+            </a:r>
+          </a:p>
+        </p:txBody>
+      </p:sp>
+      <p:sp>
+        <p:nvSpPr>
+          <p:cNvPr id="55" name="Textfeld 54">
+            <a:extLst>
+              <a:ext uri="{FF2B5EF4-FFF2-40B4-BE49-F238E27FC236}">
+                <a16:creationId xmlns:a16="http://schemas.microsoft.com/office/drawing/2014/main" id="{1A169DAE-96F8-F30A-3BA2-1AD0333DB8CF}"/>
+              </a:ext>
+            </a:extLst>
+          </p:cNvPr>
+          <p:cNvSpPr txBox="1"/>
+          <p:nvPr/>
+        </p:nvSpPr>
+        <p:spPr>
+          <a:xfrm>
+            <a:off x="2066960" y="1078411"/>
+            <a:ext cx="397800" cy="307777"/>
+          </a:xfrm>
+          <a:prstGeom prst="rect">
+            <a:avLst/>
+          </a:prstGeom>
+          <a:noFill/>
+        </p:spPr>
+        <p:txBody>
+          <a:bodyPr wrap="square" rtlCol="0" anchor="ctr">
+            <a:spAutoFit/>
+          </a:bodyPr>
+          <a:lstStyle/>
+          <a:p>
+            <a:pPr algn="ctr"/>
+            <a:r>
+              <a:rPr lang="de-DE" sz="1400" i="1" dirty="0">
+                <a:solidFill>
+                  <a:schemeClr val="accent6">
+                    <a:lumMod val="50000"/>
+                  </a:schemeClr>
+                </a:solidFill>
+                <a:latin typeface="CMU Serif" panose="02000603000000000000" pitchFamily="2" charset="0"/>
+                <a:ea typeface="CMU Serif" panose="02000603000000000000" pitchFamily="2" charset="0"/>
+                <a:cs typeface="CMU Serif" panose="02000603000000000000" pitchFamily="2" charset="0"/>
+              </a:rPr>
+              <a:t>A</a:t>
+            </a:r>
+            <a:r>
+              <a:rPr lang="de-DE" sz="1400" baseline="-25000" dirty="0">
+                <a:solidFill>
+                  <a:schemeClr val="accent6">
+                    <a:lumMod val="50000"/>
+                  </a:schemeClr>
+                </a:solidFill>
+                <a:latin typeface="CMU Serif" panose="02000603000000000000" pitchFamily="2" charset="0"/>
+                <a:ea typeface="CMU Serif" panose="02000603000000000000" pitchFamily="2" charset="0"/>
+                <a:cs typeface="CMU Serif" panose="02000603000000000000" pitchFamily="2" charset="0"/>
+              </a:rPr>
+              <a:t>1</a:t>
+            </a:r>
+          </a:p>
+        </p:txBody>
+      </p:sp>
+      <p:cxnSp>
+        <p:nvCxnSpPr>
+          <p:cNvPr id="59" name="Gerader Verbinder 58">
+            <a:extLst>
+              <a:ext uri="{FF2B5EF4-FFF2-40B4-BE49-F238E27FC236}">
+                <a16:creationId xmlns:a16="http://schemas.microsoft.com/office/drawing/2014/main" id="{C31FA387-BAFE-20D2-16A8-3CEE2D5C285C}"/>
+              </a:ext>
+            </a:extLst>
+          </p:cNvPr>
+          <p:cNvCxnSpPr>
+            <a:cxnSpLocks/>
+          </p:cNvCxnSpPr>
+          <p:nvPr/>
+        </p:nvCxnSpPr>
+        <p:spPr>
+          <a:xfrm flipH="1">
+            <a:off x="2116679" y="2382922"/>
+            <a:ext cx="501755" cy="589888"/>
+          </a:xfrm>
+          <a:prstGeom prst="line">
+            <a:avLst/>
+          </a:prstGeom>
+          <a:ln w="12700" cap="rnd">
+            <a:solidFill>
+              <a:schemeClr val="tx1"/>
+            </a:solidFill>
+            <a:round/>
+            <a:headEnd type="triangle" w="sm" len="med"/>
+            <a:tailEnd type="triangle" w="sm" len="med"/>
+          </a:ln>
+        </p:spPr>
+        <p:style>
+          <a:lnRef idx="2">
+            <a:schemeClr val="accent1"/>
+          </a:lnRef>
+          <a:fillRef idx="0">
+            <a:schemeClr val="accent1"/>
+          </a:fillRef>
+          <a:effectRef idx="1">
+            <a:schemeClr val="accent1"/>
+          </a:effectRef>
+          <a:fontRef idx="minor">
+            <a:schemeClr val="tx1"/>
+          </a:fontRef>
+        </p:style>
+      </p:cxnSp>
+      <p:sp>
+        <p:nvSpPr>
+          <p:cNvPr id="75" name="Textfeld 74">
+            <a:extLst>
+              <a:ext uri="{FF2B5EF4-FFF2-40B4-BE49-F238E27FC236}">
+                <a16:creationId xmlns:a16="http://schemas.microsoft.com/office/drawing/2014/main" id="{2A9B598F-FF60-7AB3-0D13-E7FF916EFD7C}"/>
+              </a:ext>
+            </a:extLst>
+          </p:cNvPr>
+          <p:cNvSpPr txBox="1"/>
+          <p:nvPr/>
+        </p:nvSpPr>
+        <p:spPr>
+          <a:xfrm>
+            <a:off x="2257894" y="2625655"/>
+            <a:ext cx="376264" cy="307777"/>
+          </a:xfrm>
+          <a:prstGeom prst="rect">
+            <a:avLst/>
+          </a:prstGeom>
+          <a:noFill/>
+        </p:spPr>
+        <p:txBody>
+          <a:bodyPr wrap="square" rtlCol="0" anchor="ctr">
+            <a:spAutoFit/>
+          </a:bodyPr>
+          <a:lstStyle/>
+          <a:p>
+            <a:pPr algn="ctr"/>
+            <a:r>
+              <a:rPr lang="de-DE" sz="1400" i="1" dirty="0">
+                <a:latin typeface="CMU Serif" panose="02000603000000000000" pitchFamily="2" charset="0"/>
+                <a:ea typeface="CMU Serif" panose="02000603000000000000" pitchFamily="2" charset="0"/>
+                <a:cs typeface="CMU Serif" panose="02000603000000000000" pitchFamily="2" charset="0"/>
+              </a:rPr>
+              <a:t>b</a:t>
+            </a:r>
+            <a:endParaRPr lang="de-DE" sz="1400" baseline="-25000" dirty="0">
+              <a:latin typeface="CMU Serif" panose="02000603000000000000" pitchFamily="2" charset="0"/>
+              <a:ea typeface="CMU Serif" panose="02000603000000000000" pitchFamily="2" charset="0"/>
+              <a:cs typeface="CMU Serif" panose="02000603000000000000" pitchFamily="2" charset="0"/>
+            </a:endParaRPr>
+          </a:p>
+        </p:txBody>
+      </p:sp>
+      <p:sp>
+        <p:nvSpPr>
+          <p:cNvPr id="76" name="Textfeld 75">
+            <a:extLst>
+              <a:ext uri="{FF2B5EF4-FFF2-40B4-BE49-F238E27FC236}">
+                <a16:creationId xmlns:a16="http://schemas.microsoft.com/office/drawing/2014/main" id="{27D97F94-CB03-6F5D-115F-70FA4F83EA2D}"/>
+              </a:ext>
+            </a:extLst>
+          </p:cNvPr>
+          <p:cNvSpPr txBox="1"/>
+          <p:nvPr/>
+        </p:nvSpPr>
+        <p:spPr>
+          <a:xfrm>
+            <a:off x="2884213" y="2305690"/>
+            <a:ext cx="386480" cy="307777"/>
+          </a:xfrm>
+          <a:prstGeom prst="rect">
+            <a:avLst/>
+          </a:prstGeom>
+          <a:noFill/>
+        </p:spPr>
+        <p:txBody>
+          <a:bodyPr wrap="square" rtlCol="0" anchor="ctr">
+            <a:spAutoFit/>
+          </a:bodyPr>
+          <a:lstStyle/>
+          <a:p>
+            <a:pPr algn="ctr"/>
+            <a:r>
+              <a:rPr lang="de-DE" sz="1400" i="1" dirty="0">
+                <a:latin typeface="CMU Serif" panose="02000603000000000000" pitchFamily="2" charset="0"/>
+                <a:ea typeface="CMU Serif" panose="02000603000000000000" pitchFamily="2" charset="0"/>
+                <a:cs typeface="CMU Serif" panose="02000603000000000000" pitchFamily="2" charset="0"/>
+              </a:rPr>
+              <a:t>T</a:t>
+            </a:r>
+            <a:r>
+              <a:rPr lang="de-DE" sz="1400" baseline="-25000" dirty="0">
+                <a:latin typeface="CMU Serif" panose="02000603000000000000" pitchFamily="2" charset="0"/>
+                <a:ea typeface="CMU Serif" panose="02000603000000000000" pitchFamily="2" charset="0"/>
+                <a:cs typeface="CMU Serif" panose="02000603000000000000" pitchFamily="2" charset="0"/>
+              </a:rPr>
+              <a:t>2</a:t>
+            </a:r>
+          </a:p>
+        </p:txBody>
+      </p:sp>
+    </p:spTree>
+    <p:extLst>
+      <p:ext uri="{BB962C8B-B14F-4D97-AF65-F5344CB8AC3E}">
+        <p14:creationId xmlns:p14="http://schemas.microsoft.com/office/powerpoint/2010/main" val="4161433388"/>
       </p:ext>
     </p:extLst>
   </p:cSld>

</xml_diff>